<commit_message>
Flyers: July–Oct cohort, full credentials, organ-systems coverage
- Cohort label: 'Enrolling now · July–October cohort'
- Instructor strip: Allan Bakesiga, MD · MD (Makerere) · MScGH (Duke)
  · Incoming PGY-1 Neurology, Creighton · Epi/Biostats TA
- Step 1 topics split into two labeled groups: Disciplines and Organ
  systems (Cardio, Respiratory, GI, Renal, Reproductive, Endocrine,
  MSK, Neuro, Heme/Onc, Skin)
- Step 2 CK keeps single specialty list

Co-Authored-By: Claude Opus 4.7 (1M context) <noreply@anthropic.com>
</commit_message>
<xml_diff>
--- a/outputs/flyers/USMLE_Step1_Flyer.pptx
+++ b/outputs/flyers/USMLE_Step1_Flyer.pptx
@@ -933,7 +933,7 @@
                 <a:ea typeface="Calibri" pitchFamily="34" charset="-122"/>
                 <a:cs typeface="Calibri" pitchFamily="34" charset="-120"/>
               </a:rPr>
-              <a:t>USMLE Tutoring · 2026 Cohort</a:t>
+              <a:t>Enrolling now · July–October cohort</a:t>
             </a:r>
             <a:endParaRPr lang="en-US" sz="1100" dirty="0"/>
           </a:p>
@@ -1256,8 +1256,8 @@
         </p:nvSpPr>
         <p:spPr>
           <a:xfrm>
-            <a:off x="1417320" y="1965960"/>
-            <a:ext cx="5852160" cy="310896"/>
+            <a:off x="1417320" y="1947672"/>
+            <a:ext cx="5852160" cy="292608"/>
           </a:xfrm>
           <a:prstGeom prst="rect">
             <a:avLst/>
@@ -1281,7 +1281,7 @@
                 <a:ea typeface="Calibri" pitchFamily="34" charset="-122"/>
                 <a:cs typeface="Calibri" pitchFamily="34" charset="-120"/>
               </a:rPr>
-              <a:t>Allan Bakesiga</a:t>
+              <a:t>Allan Bakesiga, MD</a:t>
             </a:r>
             <a:endParaRPr lang="en-US" sz="1600" dirty="0"/>
           </a:p>
@@ -1295,7 +1295,7 @@
         </p:nvSpPr>
         <p:spPr>
           <a:xfrm>
-            <a:off x="1417320" y="2258568"/>
+            <a:off x="1417320" y="2240280"/>
             <a:ext cx="5852160" cy="237744"/>
           </a:xfrm>
           <a:prstGeom prst="rect">
@@ -1312,7 +1312,7 @@
               <a:buNone/>
             </a:pPr>
             <a:r>
-              <a:rPr lang="en-US" sz="1100" dirty="0">
+              <a:rPr lang="en-US" sz="1050" dirty="0">
                 <a:solidFill>
                   <a:srgbClr val="345671"/>
                 </a:solidFill>
@@ -1320,9 +1320,9 @@
                 <a:ea typeface="Calibri" pitchFamily="34" charset="-122"/>
                 <a:cs typeface="Calibri" pitchFamily="34" charset="-120"/>
               </a:rPr>
-              <a:t>MD candidate · Duke University · Daily USMLE study lead</a:t>
-            </a:r>
-            <a:endParaRPr lang="en-US" sz="1100" dirty="0"/>
+              <a:t>MD (Makerere)  ·  MScGH (Duke)  ·  Incoming PGY-1 Neurology, Creighton</a:t>
+            </a:r>
+            <a:endParaRPr lang="en-US" sz="1050" dirty="0"/>
           </a:p>
         </p:txBody>
       </p:sp>
@@ -1334,7 +1334,7 @@
         </p:nvSpPr>
         <p:spPr>
           <a:xfrm>
-            <a:off x="1417320" y="2468880"/>
+            <a:off x="1417320" y="2459736"/>
             <a:ext cx="5852160" cy="219456"/>
           </a:xfrm>
           <a:prstGeom prst="rect">
@@ -1351,15 +1351,15 @@
               <a:buNone/>
             </a:pPr>
             <a:r>
-              <a:rPr lang="en-US" sz="1000" dirty="0">
-                <a:solidFill>
-                  <a:srgbClr val="6B87A3"/>
+              <a:rPr lang="en-US" sz="1000" i="1" dirty="0">
+                <a:solidFill>
+                  <a:srgbClr val="075985"/>
                 </a:solidFill>
                 <a:latin typeface="Calibri" pitchFamily="34" charset="0"/>
                 <a:ea typeface="Calibri" pitchFamily="34" charset="-122"/>
                 <a:cs typeface="Calibri" pitchFamily="34" charset="-120"/>
               </a:rPr>
-              <a:t>Neurology / neurosurgery research · Active residency applicant</a:t>
+              <a:t>Epidemiology &amp; biostatistics teaching assistant</a:t>
             </a:r>
             <a:endParaRPr lang="en-US" sz="1000" dirty="0"/>
           </a:p>
@@ -2517,8 +2517,8 @@
         </p:nvSpPr>
         <p:spPr>
           <a:xfrm>
-            <a:off x="457200" y="6766560"/>
-            <a:ext cx="6858000" cy="777240"/>
+            <a:off x="457200" y="6784848"/>
+            <a:ext cx="6858000" cy="502920"/>
           </a:xfrm>
           <a:prstGeom prst="rect">
             <a:avLst/>
@@ -2534,23 +2534,90 @@
               <a:buNone/>
             </a:pPr>
             <a:r>
-              <a:rPr lang="en-US" sz="1200" dirty="0">
-                <a:solidFill>
-                  <a:srgbClr val="0C2A3D"/>
+              <a:rPr lang="en-US" sz="1150" b="1" dirty="0">
+                <a:solidFill>
+                  <a:srgbClr val="075985"/>
                 </a:solidFill>
                 <a:latin typeface="Calibri" pitchFamily="34" charset="0"/>
                 <a:ea typeface="Calibri" pitchFamily="34" charset="-122"/>
                 <a:cs typeface="Calibri" pitchFamily="34" charset="-120"/>
               </a:rPr>
+              <a:t>Disciplines:  </a:t>
+            </a:r>
+            <a:pPr indent="0" marL="0">
+              <a:buNone/>
+            </a:pPr>
+            <a:r>
+              <a:rPr lang="en-US" sz="1150" dirty="0">
+                <a:solidFill>
+                  <a:srgbClr val="0C2A3D"/>
+                </a:solidFill>
+                <a:latin typeface="Calibri" pitchFamily="34" charset="0"/>
+                <a:ea typeface="Calibri" pitchFamily="34" charset="-122"/>
+                <a:cs typeface="Calibri" pitchFamily="34" charset="-120"/>
+              </a:rPr>
               <a:t>Anatomy  ·  Physiology  ·  Biochemistry  ·  Pathology  ·  Pharmacology  ·  Microbiology  ·  Immunology  ·  Behavioral science  ·  Biostatistics  ·  Genetics</a:t>
             </a:r>
-            <a:endParaRPr lang="en-US" sz="1200" dirty="0"/>
-          </a:p>
-        </p:txBody>
-      </p:sp>
-      <p:sp>
-        <p:nvSpPr>
-          <p:cNvPr id="51" name="Shape 49"/>
+            <a:endParaRPr lang="en-US" sz="1150" dirty="0"/>
+          </a:p>
+        </p:txBody>
+      </p:sp>
+      <p:sp>
+        <p:nvSpPr>
+          <p:cNvPr id="51" name="Text 49"/>
+          <p:cNvSpPr/>
+          <p:nvPr/>
+        </p:nvSpPr>
+        <p:spPr>
+          <a:xfrm>
+            <a:off x="457200" y="7287768"/>
+            <a:ext cx="6858000" cy="502920"/>
+          </a:xfrm>
+          <a:prstGeom prst="rect">
+            <a:avLst/>
+          </a:prstGeom>
+          <a:noFill/>
+          <a:ln/>
+        </p:spPr>
+        <p:txBody>
+          <a:bodyPr wrap="square" lIns="0" tIns="0" rIns="0" bIns="0" rtlCol="0" anchor="ctr"/>
+          <a:lstStyle/>
+          <a:p>
+            <a:pPr indent="0" marL="0">
+              <a:buNone/>
+            </a:pPr>
+            <a:r>
+              <a:rPr lang="en-US" sz="1150" b="1" dirty="0">
+                <a:solidFill>
+                  <a:srgbClr val="075985"/>
+                </a:solidFill>
+                <a:latin typeface="Calibri" pitchFamily="34" charset="0"/>
+                <a:ea typeface="Calibri" pitchFamily="34" charset="-122"/>
+                <a:cs typeface="Calibri" pitchFamily="34" charset="-120"/>
+              </a:rPr>
+              <a:t>Organ systems:  </a:t>
+            </a:r>
+            <a:pPr indent="0" marL="0">
+              <a:buNone/>
+            </a:pPr>
+            <a:r>
+              <a:rPr lang="en-US" sz="1150" dirty="0">
+                <a:solidFill>
+                  <a:srgbClr val="0C2A3D"/>
+                </a:solidFill>
+                <a:latin typeface="Calibri" pitchFamily="34" charset="0"/>
+                <a:ea typeface="Calibri" pitchFamily="34" charset="-122"/>
+                <a:cs typeface="Calibri" pitchFamily="34" charset="-120"/>
+              </a:rPr>
+              <a:t>Cardiovascular  ·  Respiratory  ·  Gastrointestinal  ·  Renal  ·  Reproductive  ·  Endocrine  ·  Musculoskeletal  ·  Nervous system  ·  Heme/Onc  ·  Skin</a:t>
+            </a:r>
+            <a:endParaRPr lang="en-US" sz="1150" dirty="0"/>
+          </a:p>
+        </p:txBody>
+      </p:sp>
+      <p:sp>
+        <p:nvSpPr>
+          <p:cNvPr id="52" name="Shape 50"/>
           <p:cNvSpPr/>
           <p:nvPr/>
         </p:nvSpPr>
@@ -2575,7 +2642,7 @@
       </p:sp>
       <p:sp>
         <p:nvSpPr>
-          <p:cNvPr id="52" name="Shape 50"/>
+          <p:cNvPr id="53" name="Shape 51"/>
           <p:cNvSpPr/>
           <p:nvPr/>
         </p:nvSpPr>
@@ -2600,7 +2667,7 @@
       </p:sp>
       <p:sp>
         <p:nvSpPr>
-          <p:cNvPr id="53" name="Text 51"/>
+          <p:cNvPr id="54" name="Text 52"/>
           <p:cNvSpPr/>
           <p:nvPr/>
         </p:nvSpPr>
@@ -2639,7 +2706,7 @@
       </p:sp>
       <p:sp>
         <p:nvSpPr>
-          <p:cNvPr id="54" name="Text 52"/>
+          <p:cNvPr id="55" name="Text 53"/>
           <p:cNvSpPr/>
           <p:nvPr/>
         </p:nvSpPr>
@@ -2678,7 +2745,7 @@
       </p:sp>
       <p:sp>
         <p:nvSpPr>
-          <p:cNvPr id="55" name="Text 53"/>
+          <p:cNvPr id="56" name="Text 54"/>
           <p:cNvSpPr/>
           <p:nvPr/>
         </p:nvSpPr>
@@ -2717,7 +2784,7 @@
       </p:sp>
       <p:sp>
         <p:nvSpPr>
-          <p:cNvPr id="56" name="Text 54"/>
+          <p:cNvPr id="57" name="Text 55"/>
           <p:cNvSpPr/>
           <p:nvPr/>
         </p:nvSpPr>
@@ -2756,7 +2823,7 @@
       </p:sp>
       <p:sp>
         <p:nvSpPr>
-          <p:cNvPr id="57" name="Shape 55"/>
+          <p:cNvPr id="58" name="Shape 56"/>
           <p:cNvSpPr/>
           <p:nvPr/>
         </p:nvSpPr>
@@ -2781,7 +2848,7 @@
       </p:sp>
       <p:sp>
         <p:nvSpPr>
-          <p:cNvPr id="58" name="Text 56"/>
+          <p:cNvPr id="59" name="Text 57"/>
           <p:cNvSpPr/>
           <p:nvPr/>
         </p:nvSpPr>
@@ -2820,7 +2887,7 @@
       </p:sp>
       <p:sp>
         <p:nvSpPr>
-          <p:cNvPr id="59" name="Shape 57"/>
+          <p:cNvPr id="60" name="Shape 58"/>
           <p:cNvSpPr/>
           <p:nvPr/>
         </p:nvSpPr>
@@ -2845,7 +2912,7 @@
       </p:sp>
       <p:sp>
         <p:nvSpPr>
-          <p:cNvPr id="60" name="Shape 58"/>
+          <p:cNvPr id="61" name="Shape 59"/>
           <p:cNvSpPr/>
           <p:nvPr/>
         </p:nvSpPr>

</xml_diff>

<commit_message>
Flyers: add USMLE kicker above big title
Two-tier title block now reads 'USMLE' (small caps) above
'Step 1' / 'Step 2 CK' (big), making the exam brand explicit
on each flyer when shared without context.
</commit_message>
<xml_diff>
--- a/outputs/flyers/USMLE_Step1_Flyer.pptx
+++ b/outputs/flyers/USMLE_Step1_Flyer.pptx
@@ -908,8 +908,8 @@
         </p:nvSpPr>
         <p:spPr>
           <a:xfrm>
-            <a:off x="457200" y="320040"/>
-            <a:ext cx="4457700" cy="274320"/>
+            <a:off x="457200" y="256032"/>
+            <a:ext cx="4457700" cy="201168"/>
           </a:xfrm>
           <a:prstGeom prst="rect">
             <a:avLst/>
@@ -925,7 +925,7 @@
               <a:buNone/>
             </a:pPr>
             <a:r>
-              <a:rPr lang="en-US" sz="1100" b="1" spc="400" kern="0" dirty="0">
+              <a:rPr lang="en-US" sz="1000" b="1" spc="400" kern="0" dirty="0">
                 <a:solidFill>
                   <a:srgbClr val="FFFFFF"/>
                 </a:solidFill>
@@ -935,7 +935,7 @@
               </a:rPr>
               <a:t>Enrolling now · July–October cohort</a:t>
             </a:r>
-            <a:endParaRPr lang="en-US" sz="1100" dirty="0"/>
+            <a:endParaRPr lang="en-US" sz="1000" dirty="0"/>
           </a:p>
         </p:txBody>
       </p:sp>
@@ -947,8 +947,8 @@
         </p:nvSpPr>
         <p:spPr>
           <a:xfrm>
-            <a:off x="457200" y="566928"/>
-            <a:ext cx="4457700" cy="777240"/>
+            <a:off x="457200" y="457200"/>
+            <a:ext cx="4457700" cy="274320"/>
           </a:xfrm>
           <a:prstGeom prst="rect">
             <a:avLst/>
@@ -964,7 +964,7 @@
               <a:buNone/>
             </a:pPr>
             <a:r>
-              <a:rPr lang="en-US" sz="5600" b="1" dirty="0">
+              <a:rPr lang="en-US" sz="2200" b="1" spc="800" kern="0" dirty="0">
                 <a:solidFill>
                   <a:srgbClr val="FFFFFF"/>
                 </a:solidFill>
@@ -972,22 +972,61 @@
                 <a:ea typeface="Arial Black" pitchFamily="34" charset="-122"/>
                 <a:cs typeface="Arial Black" pitchFamily="34" charset="-120"/>
               </a:rPr>
+              <a:t>USMLE</a:t>
+            </a:r>
+            <a:endParaRPr lang="en-US" sz="2200" dirty="0"/>
+          </a:p>
+        </p:txBody>
+      </p:sp>
+      <p:sp>
+        <p:nvSpPr>
+          <p:cNvPr id="5" name="Text 3"/>
+          <p:cNvSpPr/>
+          <p:nvPr/>
+        </p:nvSpPr>
+        <p:spPr>
+          <a:xfrm>
+            <a:off x="457200" y="749808"/>
+            <a:ext cx="4457700" cy="713232"/>
+          </a:xfrm>
+          <a:prstGeom prst="rect">
+            <a:avLst/>
+          </a:prstGeom>
+          <a:noFill/>
+          <a:ln/>
+        </p:spPr>
+        <p:txBody>
+          <a:bodyPr wrap="square" lIns="0" tIns="0" rIns="0" bIns="0" rtlCol="0" anchor="ctr"/>
+          <a:lstStyle/>
+          <a:p>
+            <a:pPr indent="0" marL="0">
+              <a:buNone/>
+            </a:pPr>
+            <a:r>
+              <a:rPr lang="en-US" sz="4800" b="1" dirty="0">
+                <a:solidFill>
+                  <a:srgbClr val="FFFFFF"/>
+                </a:solidFill>
+                <a:latin typeface="Arial Black" pitchFamily="34" charset="0"/>
+                <a:ea typeface="Arial Black" pitchFamily="34" charset="-122"/>
+                <a:cs typeface="Arial Black" pitchFamily="34" charset="-120"/>
+              </a:rPr>
               <a:t>Step 1</a:t>
             </a:r>
-            <a:endParaRPr lang="en-US" sz="5600" dirty="0"/>
-          </a:p>
-        </p:txBody>
-      </p:sp>
-      <p:sp>
-        <p:nvSpPr>
-          <p:cNvPr id="5" name="Text 3"/>
-          <p:cNvSpPr/>
-          <p:nvPr/>
-        </p:nvSpPr>
-        <p:spPr>
-          <a:xfrm>
-            <a:off x="457200" y="1335024"/>
-            <a:ext cx="5829300" cy="292608"/>
+            <a:endParaRPr lang="en-US" sz="4800" dirty="0"/>
+          </a:p>
+        </p:txBody>
+      </p:sp>
+      <p:sp>
+        <p:nvSpPr>
+          <p:cNvPr id="6" name="Text 4"/>
+          <p:cNvSpPr/>
+          <p:nvPr/>
+        </p:nvSpPr>
+        <p:spPr>
+          <a:xfrm>
+            <a:off x="457200" y="1444752"/>
+            <a:ext cx="5829300" cy="219456"/>
           </a:xfrm>
           <a:prstGeom prst="rect">
             <a:avLst/>
@@ -1003,7 +1042,7 @@
               <a:buNone/>
             </a:pPr>
             <a:r>
-              <a:rPr lang="en-US" sz="1400" i="1" dirty="0">
+              <a:rPr lang="en-US" sz="1200" i="1" dirty="0">
                 <a:solidFill>
                   <a:srgbClr val="FFFFFF"/>
                 </a:solidFill>
@@ -1013,13 +1052,13 @@
               </a:rPr>
               <a:t>Master the foundational sciences. Build the base every step rests on.</a:t>
             </a:r>
-            <a:endParaRPr lang="en-US" sz="1400" dirty="0"/>
-          </a:p>
-        </p:txBody>
-      </p:sp>
-      <p:sp>
-        <p:nvSpPr>
-          <p:cNvPr id="6" name="Shape 4"/>
+            <a:endParaRPr lang="en-US" sz="1200" dirty="0"/>
+          </a:p>
+        </p:txBody>
+      </p:sp>
+      <p:sp>
+        <p:nvSpPr>
+          <p:cNvPr id="7" name="Shape 5"/>
           <p:cNvSpPr/>
           <p:nvPr/>
         </p:nvSpPr>
@@ -1044,7 +1083,7 @@
       </p:sp>
       <p:sp>
         <p:nvSpPr>
-          <p:cNvPr id="7" name="Text 5"/>
+          <p:cNvPr id="8" name="Text 6"/>
           <p:cNvSpPr/>
           <p:nvPr/>
         </p:nvSpPr>
@@ -1083,7 +1122,7 @@
       </p:sp>
       <p:sp>
         <p:nvSpPr>
-          <p:cNvPr id="8" name="Text 6"/>
+          <p:cNvPr id="9" name="Text 7"/>
           <p:cNvSpPr/>
           <p:nvPr/>
         </p:nvSpPr>
@@ -1122,7 +1161,7 @@
       </p:sp>
       <p:sp>
         <p:nvSpPr>
-          <p:cNvPr id="9" name="Text 7"/>
+          <p:cNvPr id="10" name="Text 8"/>
           <p:cNvSpPr/>
           <p:nvPr/>
         </p:nvSpPr>
@@ -1161,7 +1200,7 @@
       </p:sp>
       <p:sp>
         <p:nvSpPr>
-          <p:cNvPr id="10" name="Shape 8"/>
+          <p:cNvPr id="11" name="Shape 9"/>
           <p:cNvSpPr/>
           <p:nvPr/>
         </p:nvSpPr>
@@ -1186,7 +1225,7 @@
       </p:sp>
       <p:sp>
         <p:nvSpPr>
-          <p:cNvPr id="11" name="Shape 9"/>
+          <p:cNvPr id="12" name="Shape 10"/>
           <p:cNvSpPr/>
           <p:nvPr/>
         </p:nvSpPr>
@@ -1211,7 +1250,7 @@
       </p:sp>
       <p:sp>
         <p:nvSpPr>
-          <p:cNvPr id="12" name="Text 10"/>
+          <p:cNvPr id="13" name="Text 11"/>
           <p:cNvSpPr/>
           <p:nvPr/>
         </p:nvSpPr>
@@ -1250,7 +1289,7 @@
       </p:sp>
       <p:sp>
         <p:nvSpPr>
-          <p:cNvPr id="13" name="Text 11"/>
+          <p:cNvPr id="14" name="Text 12"/>
           <p:cNvSpPr/>
           <p:nvPr/>
         </p:nvSpPr>
@@ -1289,7 +1328,7 @@
       </p:sp>
       <p:sp>
         <p:nvSpPr>
-          <p:cNvPr id="14" name="Text 12"/>
+          <p:cNvPr id="15" name="Text 13"/>
           <p:cNvSpPr/>
           <p:nvPr/>
         </p:nvSpPr>
@@ -1328,7 +1367,7 @@
       </p:sp>
       <p:sp>
         <p:nvSpPr>
-          <p:cNvPr id="15" name="Text 13"/>
+          <p:cNvPr id="16" name="Text 14"/>
           <p:cNvSpPr/>
           <p:nvPr/>
         </p:nvSpPr>
@@ -1367,7 +1406,7 @@
       </p:sp>
       <p:sp>
         <p:nvSpPr>
-          <p:cNvPr id="16" name="Shape 14"/>
+          <p:cNvPr id="17" name="Shape 15"/>
           <p:cNvSpPr/>
           <p:nvPr/>
         </p:nvSpPr>
@@ -1392,7 +1431,7 @@
       </p:sp>
       <p:sp>
         <p:nvSpPr>
-          <p:cNvPr id="17" name="Text 15"/>
+          <p:cNvPr id="18" name="Text 16"/>
           <p:cNvSpPr/>
           <p:nvPr/>
         </p:nvSpPr>
@@ -1431,7 +1470,7 @@
       </p:sp>
       <p:sp>
         <p:nvSpPr>
-          <p:cNvPr id="18" name="Text 16"/>
+          <p:cNvPr id="19" name="Text 17"/>
           <p:cNvSpPr/>
           <p:nvPr/>
         </p:nvSpPr>
@@ -1470,7 +1509,7 @@
       </p:sp>
       <p:sp>
         <p:nvSpPr>
-          <p:cNvPr id="19" name="Shape 17"/>
+          <p:cNvPr id="20" name="Shape 18"/>
           <p:cNvSpPr/>
           <p:nvPr/>
         </p:nvSpPr>
@@ -1495,7 +1534,7 @@
       </p:sp>
       <p:sp>
         <p:nvSpPr>
-          <p:cNvPr id="20" name="Text 18"/>
+          <p:cNvPr id="21" name="Text 19"/>
           <p:cNvSpPr/>
           <p:nvPr/>
         </p:nvSpPr>
@@ -1534,7 +1573,7 @@
       </p:sp>
       <p:sp>
         <p:nvSpPr>
-          <p:cNvPr id="21" name="Text 19"/>
+          <p:cNvPr id="22" name="Text 20"/>
           <p:cNvSpPr/>
           <p:nvPr/>
         </p:nvSpPr>
@@ -1573,7 +1612,7 @@
       </p:sp>
       <p:sp>
         <p:nvSpPr>
-          <p:cNvPr id="22" name="Shape 20"/>
+          <p:cNvPr id="23" name="Shape 21"/>
           <p:cNvSpPr/>
           <p:nvPr/>
         </p:nvSpPr>
@@ -1598,7 +1637,7 @@
       </p:sp>
       <p:sp>
         <p:nvSpPr>
-          <p:cNvPr id="23" name="Text 21"/>
+          <p:cNvPr id="24" name="Text 22"/>
           <p:cNvSpPr/>
           <p:nvPr/>
         </p:nvSpPr>
@@ -1637,7 +1676,7 @@
       </p:sp>
       <p:sp>
         <p:nvSpPr>
-          <p:cNvPr id="24" name="Text 22"/>
+          <p:cNvPr id="25" name="Text 23"/>
           <p:cNvSpPr/>
           <p:nvPr/>
         </p:nvSpPr>
@@ -1676,7 +1715,7 @@
       </p:sp>
       <p:sp>
         <p:nvSpPr>
-          <p:cNvPr id="25" name="Shape 23"/>
+          <p:cNvPr id="26" name="Shape 24"/>
           <p:cNvSpPr/>
           <p:nvPr/>
         </p:nvSpPr>
@@ -1708,7 +1747,7 @@
       </p:sp>
       <p:sp>
         <p:nvSpPr>
-          <p:cNvPr id="26" name="Shape 24"/>
+          <p:cNvPr id="27" name="Shape 25"/>
           <p:cNvSpPr/>
           <p:nvPr/>
         </p:nvSpPr>
@@ -1733,7 +1772,7 @@
       </p:sp>
       <p:sp>
         <p:nvSpPr>
-          <p:cNvPr id="27" name="Shape 25"/>
+          <p:cNvPr id="28" name="Shape 26"/>
           <p:cNvSpPr/>
           <p:nvPr/>
         </p:nvSpPr>
@@ -1758,7 +1797,7 @@
       </p:sp>
       <p:sp>
         <p:nvSpPr>
-          <p:cNvPr id="28" name="Text 26"/>
+          <p:cNvPr id="29" name="Text 27"/>
           <p:cNvSpPr/>
           <p:nvPr/>
         </p:nvSpPr>
@@ -1797,7 +1836,7 @@
       </p:sp>
       <p:sp>
         <p:nvSpPr>
-          <p:cNvPr id="29" name="Text 27"/>
+          <p:cNvPr id="30" name="Text 28"/>
           <p:cNvSpPr/>
           <p:nvPr/>
         </p:nvSpPr>
@@ -1836,7 +1875,7 @@
       </p:sp>
       <p:sp>
         <p:nvSpPr>
-          <p:cNvPr id="30" name="Text 28"/>
+          <p:cNvPr id="31" name="Text 29"/>
           <p:cNvSpPr/>
           <p:nvPr/>
         </p:nvSpPr>
@@ -1875,7 +1914,7 @@
       </p:sp>
       <p:sp>
         <p:nvSpPr>
-          <p:cNvPr id="31" name="Shape 29"/>
+          <p:cNvPr id="32" name="Shape 30"/>
           <p:cNvSpPr/>
           <p:nvPr/>
         </p:nvSpPr>
@@ -1907,7 +1946,7 @@
       </p:sp>
       <p:sp>
         <p:nvSpPr>
-          <p:cNvPr id="32" name="Shape 30"/>
+          <p:cNvPr id="33" name="Shape 31"/>
           <p:cNvSpPr/>
           <p:nvPr/>
         </p:nvSpPr>
@@ -1932,7 +1971,7 @@
       </p:sp>
       <p:sp>
         <p:nvSpPr>
-          <p:cNvPr id="33" name="Shape 31"/>
+          <p:cNvPr id="34" name="Shape 32"/>
           <p:cNvSpPr/>
           <p:nvPr/>
         </p:nvSpPr>
@@ -1957,7 +1996,7 @@
       </p:sp>
       <p:sp>
         <p:nvSpPr>
-          <p:cNvPr id="34" name="Text 32"/>
+          <p:cNvPr id="35" name="Text 33"/>
           <p:cNvSpPr/>
           <p:nvPr/>
         </p:nvSpPr>
@@ -1996,7 +2035,7 @@
       </p:sp>
       <p:sp>
         <p:nvSpPr>
-          <p:cNvPr id="35" name="Text 33"/>
+          <p:cNvPr id="36" name="Text 34"/>
           <p:cNvSpPr/>
           <p:nvPr/>
         </p:nvSpPr>
@@ -2035,7 +2074,7 @@
       </p:sp>
       <p:sp>
         <p:nvSpPr>
-          <p:cNvPr id="36" name="Text 34"/>
+          <p:cNvPr id="37" name="Text 35"/>
           <p:cNvSpPr/>
           <p:nvPr/>
         </p:nvSpPr>
@@ -2074,7 +2113,7 @@
       </p:sp>
       <p:sp>
         <p:nvSpPr>
-          <p:cNvPr id="37" name="Shape 35"/>
+          <p:cNvPr id="38" name="Shape 36"/>
           <p:cNvSpPr/>
           <p:nvPr/>
         </p:nvSpPr>
@@ -2106,7 +2145,7 @@
       </p:sp>
       <p:sp>
         <p:nvSpPr>
-          <p:cNvPr id="38" name="Shape 36"/>
+          <p:cNvPr id="39" name="Shape 37"/>
           <p:cNvSpPr/>
           <p:nvPr/>
         </p:nvSpPr>
@@ -2131,7 +2170,7 @@
       </p:sp>
       <p:sp>
         <p:nvSpPr>
-          <p:cNvPr id="39" name="Shape 37"/>
+          <p:cNvPr id="40" name="Shape 38"/>
           <p:cNvSpPr/>
           <p:nvPr/>
         </p:nvSpPr>
@@ -2156,7 +2195,7 @@
       </p:sp>
       <p:sp>
         <p:nvSpPr>
-          <p:cNvPr id="40" name="Text 38"/>
+          <p:cNvPr id="41" name="Text 39"/>
           <p:cNvSpPr/>
           <p:nvPr/>
         </p:nvSpPr>
@@ -2195,7 +2234,7 @@
       </p:sp>
       <p:sp>
         <p:nvSpPr>
-          <p:cNvPr id="41" name="Text 39"/>
+          <p:cNvPr id="42" name="Text 40"/>
           <p:cNvSpPr/>
           <p:nvPr/>
         </p:nvSpPr>
@@ -2234,7 +2273,7 @@
       </p:sp>
       <p:sp>
         <p:nvSpPr>
-          <p:cNvPr id="42" name="Text 40"/>
+          <p:cNvPr id="43" name="Text 41"/>
           <p:cNvSpPr/>
           <p:nvPr/>
         </p:nvSpPr>
@@ -2273,7 +2312,7 @@
       </p:sp>
       <p:sp>
         <p:nvSpPr>
-          <p:cNvPr id="43" name="Shape 41"/>
+          <p:cNvPr id="44" name="Shape 42"/>
           <p:cNvSpPr/>
           <p:nvPr/>
         </p:nvSpPr>
@@ -2305,7 +2344,7 @@
       </p:sp>
       <p:sp>
         <p:nvSpPr>
-          <p:cNvPr id="44" name="Shape 42"/>
+          <p:cNvPr id="45" name="Shape 43"/>
           <p:cNvSpPr/>
           <p:nvPr/>
         </p:nvSpPr>
@@ -2330,7 +2369,7 @@
       </p:sp>
       <p:sp>
         <p:nvSpPr>
-          <p:cNvPr id="45" name="Shape 43"/>
+          <p:cNvPr id="46" name="Shape 44"/>
           <p:cNvSpPr/>
           <p:nvPr/>
         </p:nvSpPr>
@@ -2355,7 +2394,7 @@
       </p:sp>
       <p:sp>
         <p:nvSpPr>
-          <p:cNvPr id="46" name="Text 44"/>
+          <p:cNvPr id="47" name="Text 45"/>
           <p:cNvSpPr/>
           <p:nvPr/>
         </p:nvSpPr>
@@ -2394,7 +2433,7 @@
       </p:sp>
       <p:sp>
         <p:nvSpPr>
-          <p:cNvPr id="47" name="Text 45"/>
+          <p:cNvPr id="48" name="Text 46"/>
           <p:cNvSpPr/>
           <p:nvPr/>
         </p:nvSpPr>
@@ -2433,7 +2472,7 @@
       </p:sp>
       <p:sp>
         <p:nvSpPr>
-          <p:cNvPr id="48" name="Text 46"/>
+          <p:cNvPr id="49" name="Text 47"/>
           <p:cNvSpPr/>
           <p:nvPr/>
         </p:nvSpPr>
@@ -2472,7 +2511,7 @@
       </p:sp>
       <p:sp>
         <p:nvSpPr>
-          <p:cNvPr id="49" name="Text 47"/>
+          <p:cNvPr id="50" name="Text 48"/>
           <p:cNvSpPr/>
           <p:nvPr/>
         </p:nvSpPr>
@@ -2511,7 +2550,7 @@
       </p:sp>
       <p:sp>
         <p:nvSpPr>
-          <p:cNvPr id="50" name="Text 48"/>
+          <p:cNvPr id="51" name="Text 49"/>
           <p:cNvSpPr/>
           <p:nvPr/>
         </p:nvSpPr>
@@ -2564,7 +2603,7 @@
       </p:sp>
       <p:sp>
         <p:nvSpPr>
-          <p:cNvPr id="51" name="Text 49"/>
+          <p:cNvPr id="52" name="Text 50"/>
           <p:cNvSpPr/>
           <p:nvPr/>
         </p:nvSpPr>
@@ -2617,7 +2656,7 @@
       </p:sp>
       <p:sp>
         <p:nvSpPr>
-          <p:cNvPr id="52" name="Shape 50"/>
+          <p:cNvPr id="53" name="Shape 51"/>
           <p:cNvSpPr/>
           <p:nvPr/>
         </p:nvSpPr>
@@ -2642,7 +2681,7 @@
       </p:sp>
       <p:sp>
         <p:nvSpPr>
-          <p:cNvPr id="53" name="Shape 51"/>
+          <p:cNvPr id="54" name="Shape 52"/>
           <p:cNvSpPr/>
           <p:nvPr/>
         </p:nvSpPr>
@@ -2667,7 +2706,7 @@
       </p:sp>
       <p:sp>
         <p:nvSpPr>
-          <p:cNvPr id="54" name="Text 52"/>
+          <p:cNvPr id="55" name="Text 53"/>
           <p:cNvSpPr/>
           <p:nvPr/>
         </p:nvSpPr>
@@ -2706,7 +2745,7 @@
       </p:sp>
       <p:sp>
         <p:nvSpPr>
-          <p:cNvPr id="55" name="Text 53"/>
+          <p:cNvPr id="56" name="Text 54"/>
           <p:cNvSpPr/>
           <p:nvPr/>
         </p:nvSpPr>
@@ -2745,7 +2784,7 @@
       </p:sp>
       <p:sp>
         <p:nvSpPr>
-          <p:cNvPr id="56" name="Text 54"/>
+          <p:cNvPr id="57" name="Text 55"/>
           <p:cNvSpPr/>
           <p:nvPr/>
         </p:nvSpPr>
@@ -2784,7 +2823,7 @@
       </p:sp>
       <p:sp>
         <p:nvSpPr>
-          <p:cNvPr id="57" name="Text 55"/>
+          <p:cNvPr id="58" name="Text 56"/>
           <p:cNvSpPr/>
           <p:nvPr/>
         </p:nvSpPr>
@@ -2823,7 +2862,7 @@
       </p:sp>
       <p:sp>
         <p:nvSpPr>
-          <p:cNvPr id="58" name="Shape 56"/>
+          <p:cNvPr id="59" name="Shape 57"/>
           <p:cNvSpPr/>
           <p:nvPr/>
         </p:nvSpPr>
@@ -2848,7 +2887,7 @@
       </p:sp>
       <p:sp>
         <p:nvSpPr>
-          <p:cNvPr id="59" name="Text 57"/>
+          <p:cNvPr id="60" name="Text 58"/>
           <p:cNvSpPr/>
           <p:nvPr/>
         </p:nvSpPr>
@@ -2887,7 +2926,7 @@
       </p:sp>
       <p:sp>
         <p:nvSpPr>
-          <p:cNvPr id="60" name="Shape 58"/>
+          <p:cNvPr id="61" name="Shape 59"/>
           <p:cNvSpPr/>
           <p:nvPr/>
         </p:nvSpPr>
@@ -2912,7 +2951,7 @@
       </p:sp>
       <p:sp>
         <p:nvSpPr>
-          <p:cNvPr id="61" name="Shape 59"/>
+          <p:cNvPr id="62" name="Shape 60"/>
           <p:cNvSpPr/>
           <p:nvPr/>
         </p:nvSpPr>

</xml_diff>

<commit_message>
Flyers: bigger fonts throughout + WhatsApp contact
- All fonts up ~15%: USMLE kicker, big title (54pt), Allan's
  name (18pt), credentials, stat numbers (26pt), card titles
  (15pt), topics (12.5pt), callout (14pt), URL (24pt)
- Header band expanded 1.85->2.00; vertical positions reflowed
- Stamp on right widened to 2.00 with bigger '4-month prep'
- Two-column contact row at bottom: email (blue dot) +
  WhatsApp +256 705 571 443 (real WhatsApp brand logo)
- Limited-cohort note moved to small italic line below
- whatsapp.png (asset, not build output) tracked; gitignore
  narrowed to exclude only USMLE_*.{pdf,jpg,png} build outputs

Co-Authored-By: Claude Opus 4.7 (1M context) <noreply@anthropic.com>
</commit_message>
<xml_diff>
--- a/outputs/flyers/USMLE_Step1_Flyer.pptx
+++ b/outputs/flyers/USMLE_Step1_Flyer.pptx
@@ -884,7 +884,7 @@
         <p:spPr>
           <a:xfrm>
             <a:off x="0" y="0"/>
-            <a:ext cx="7772400" cy="1691640"/>
+            <a:ext cx="7772400" cy="1828800"/>
           </a:xfrm>
           <a:prstGeom prst="rect">
             <a:avLst/>
@@ -908,8 +908,8 @@
         </p:nvSpPr>
         <p:spPr>
           <a:xfrm>
-            <a:off x="457200" y="256032"/>
-            <a:ext cx="4457700" cy="201168"/>
+            <a:off x="457200" y="237744"/>
+            <a:ext cx="4457700" cy="219456"/>
           </a:xfrm>
           <a:prstGeom prst="rect">
             <a:avLst/>
@@ -925,7 +925,7 @@
               <a:buNone/>
             </a:pPr>
             <a:r>
-              <a:rPr lang="en-US" sz="1000" b="1" spc="400" kern="0" dirty="0">
+              <a:rPr lang="en-US" sz="1100" b="1" spc="400" kern="0" dirty="0">
                 <a:solidFill>
                   <a:srgbClr val="FFFFFF"/>
                 </a:solidFill>
@@ -935,7 +935,7 @@
               </a:rPr>
               <a:t>Enrolling now · July–October cohort</a:t>
             </a:r>
-            <a:endParaRPr lang="en-US" sz="1000" dirty="0"/>
+            <a:endParaRPr lang="en-US" sz="1100" dirty="0"/>
           </a:p>
         </p:txBody>
       </p:sp>
@@ -948,7 +948,7 @@
         <p:spPr>
           <a:xfrm>
             <a:off x="457200" y="457200"/>
-            <a:ext cx="4457700" cy="274320"/>
+            <a:ext cx="4457700" cy="292608"/>
           </a:xfrm>
           <a:prstGeom prst="rect">
             <a:avLst/>
@@ -964,7 +964,7 @@
               <a:buNone/>
             </a:pPr>
             <a:r>
-              <a:rPr lang="en-US" sz="2200" b="1" spc="800" kern="0" dirty="0">
+              <a:rPr lang="en-US" sz="2400" b="1" spc="800" kern="0" dirty="0">
                 <a:solidFill>
                   <a:srgbClr val="FFFFFF"/>
                 </a:solidFill>
@@ -974,7 +974,7 @@
               </a:rPr>
               <a:t>USMLE</a:t>
             </a:r>
-            <a:endParaRPr lang="en-US" sz="2200" dirty="0"/>
+            <a:endParaRPr lang="en-US" sz="2400" dirty="0"/>
           </a:p>
         </p:txBody>
       </p:sp>
@@ -986,8 +986,8 @@
         </p:nvSpPr>
         <p:spPr>
           <a:xfrm>
-            <a:off x="457200" y="749808"/>
-            <a:ext cx="4457700" cy="713232"/>
+            <a:off x="457200" y="768096"/>
+            <a:ext cx="4457700" cy="777240"/>
           </a:xfrm>
           <a:prstGeom prst="rect">
             <a:avLst/>
@@ -1003,7 +1003,7 @@
               <a:buNone/>
             </a:pPr>
             <a:r>
-              <a:rPr lang="en-US" sz="4800" b="1" dirty="0">
+              <a:rPr lang="en-US" sz="5400" b="1" dirty="0">
                 <a:solidFill>
                   <a:srgbClr val="FFFFFF"/>
                 </a:solidFill>
@@ -1013,7 +1013,7 @@
               </a:rPr>
               <a:t>Step 1</a:t>
             </a:r>
-            <a:endParaRPr lang="en-US" sz="4800" dirty="0"/>
+            <a:endParaRPr lang="en-US" sz="5400" dirty="0"/>
           </a:p>
         </p:txBody>
       </p:sp>
@@ -1025,8 +1025,8 @@
         </p:nvSpPr>
         <p:spPr>
           <a:xfrm>
-            <a:off x="457200" y="1444752"/>
-            <a:ext cx="5829300" cy="219456"/>
+            <a:off x="457200" y="1517904"/>
+            <a:ext cx="5829300" cy="237744"/>
           </a:xfrm>
           <a:prstGeom prst="rect">
             <a:avLst/>
@@ -1042,7 +1042,7 @@
               <a:buNone/>
             </a:pPr>
             <a:r>
-              <a:rPr lang="en-US" sz="1200" i="1" dirty="0">
+              <a:rPr lang="en-US" sz="1300" i="1" dirty="0">
                 <a:solidFill>
                   <a:srgbClr val="FFFFFF"/>
                 </a:solidFill>
@@ -1052,7 +1052,7 @@
               </a:rPr>
               <a:t>Master the foundational sciences. Build the base every step rests on.</a:t>
             </a:r>
-            <a:endParaRPr lang="en-US" sz="1200" dirty="0"/>
+            <a:endParaRPr lang="en-US" sz="1300" dirty="0"/>
           </a:p>
         </p:txBody>
       </p:sp>
@@ -1064,8 +1064,8 @@
         </p:nvSpPr>
         <p:spPr>
           <a:xfrm>
-            <a:off x="5623560" y="457200"/>
-            <a:ext cx="1691640" cy="868680"/>
+            <a:off x="5486400" y="457200"/>
+            <a:ext cx="1828800" cy="960120"/>
           </a:xfrm>
           <a:prstGeom prst="rect">
             <a:avLst/>
@@ -1089,8 +1089,8 @@
         </p:nvSpPr>
         <p:spPr>
           <a:xfrm>
-            <a:off x="5623560" y="502920"/>
-            <a:ext cx="1691640" cy="274320"/>
+            <a:off x="5486400" y="502920"/>
+            <a:ext cx="1828800" cy="292608"/>
           </a:xfrm>
           <a:prstGeom prst="rect">
             <a:avLst/>
@@ -1106,7 +1106,7 @@
               <a:buNone/>
             </a:pPr>
             <a:r>
-              <a:rPr lang="en-US" sz="1100" b="1" spc="400" kern="0" dirty="0">
+              <a:rPr lang="en-US" sz="1200" b="1" spc="400" kern="0" dirty="0">
                 <a:solidFill>
                   <a:srgbClr val="FFFFFF"/>
                 </a:solidFill>
@@ -1116,7 +1116,7 @@
               </a:rPr>
               <a:t>MON–SUN</a:t>
             </a:r>
-            <a:endParaRPr lang="en-US" sz="1100" dirty="0"/>
+            <a:endParaRPr lang="en-US" sz="1200" dirty="0"/>
           </a:p>
         </p:txBody>
       </p:sp>
@@ -1128,8 +1128,8 @@
         </p:nvSpPr>
         <p:spPr>
           <a:xfrm>
-            <a:off x="5623560" y="777240"/>
-            <a:ext cx="1691640" cy="256032"/>
+            <a:off x="5486400" y="804672"/>
+            <a:ext cx="1828800" cy="292608"/>
           </a:xfrm>
           <a:prstGeom prst="rect">
             <a:avLst/>
@@ -1145,7 +1145,7 @@
               <a:buNone/>
             </a:pPr>
             <a:r>
-              <a:rPr lang="en-US" sz="1200" b="1" dirty="0">
+              <a:rPr lang="en-US" sz="1400" b="1" dirty="0">
                 <a:solidFill>
                   <a:srgbClr val="FFFFFF"/>
                 </a:solidFill>
@@ -1155,7 +1155,7 @@
               </a:rPr>
               <a:t>4-month prep</a:t>
             </a:r>
-            <a:endParaRPr lang="en-US" sz="1200" dirty="0"/>
+            <a:endParaRPr lang="en-US" sz="1400" dirty="0"/>
           </a:p>
         </p:txBody>
       </p:sp>
@@ -1167,8 +1167,8 @@
         </p:nvSpPr>
         <p:spPr>
           <a:xfrm>
-            <a:off x="5623560" y="1033272"/>
-            <a:ext cx="1691640" cy="237744"/>
+            <a:off x="5486400" y="1097280"/>
+            <a:ext cx="1828800" cy="274320"/>
           </a:xfrm>
           <a:prstGeom prst="rect">
             <a:avLst/>
@@ -1184,7 +1184,7 @@
               <a:buNone/>
             </a:pPr>
             <a:r>
-              <a:rPr lang="en-US" sz="900" i="1" dirty="0">
+              <a:rPr lang="en-US" sz="1050" i="1" dirty="0">
                 <a:solidFill>
                   <a:srgbClr val="FFFFFF"/>
                 </a:solidFill>
@@ -1194,7 +1194,7 @@
               </a:rPr>
               <a:t>· daily classes ·</a:t>
             </a:r>
-            <a:endParaRPr lang="en-US" sz="900" dirty="0"/>
+            <a:endParaRPr lang="en-US" sz="1050" dirty="0"/>
           </a:p>
         </p:txBody>
       </p:sp>
@@ -1206,8 +1206,8 @@
         </p:nvSpPr>
         <p:spPr>
           <a:xfrm>
-            <a:off x="457200" y="1874520"/>
-            <a:ext cx="6858000" cy="868680"/>
+            <a:off x="457200" y="1965960"/>
+            <a:ext cx="6858000" cy="1005840"/>
           </a:xfrm>
           <a:prstGeom prst="rect">
             <a:avLst/>
@@ -1231,8 +1231,8 @@
         </p:nvSpPr>
         <p:spPr>
           <a:xfrm>
-            <a:off x="621792" y="1993392"/>
-            <a:ext cx="640080" cy="640080"/>
+            <a:off x="640080" y="2130552"/>
+            <a:ext cx="713232" cy="713232"/>
           </a:xfrm>
           <a:prstGeom prst="ellipse">
             <a:avLst/>
@@ -1256,8 +1256,8 @@
         </p:nvSpPr>
         <p:spPr>
           <a:xfrm>
-            <a:off x="621792" y="1993392"/>
-            <a:ext cx="640080" cy="640080"/>
+            <a:off x="640080" y="2130552"/>
+            <a:ext cx="713232" cy="713232"/>
           </a:xfrm>
           <a:prstGeom prst="rect">
             <a:avLst/>
@@ -1273,7 +1273,7 @@
               <a:buNone/>
             </a:pPr>
             <a:r>
-              <a:rPr lang="en-US" sz="2200" b="1" dirty="0">
+              <a:rPr lang="en-US" sz="2400" b="1" dirty="0">
                 <a:solidFill>
                   <a:srgbClr val="FFFFFF"/>
                 </a:solidFill>
@@ -1283,7 +1283,7 @@
               </a:rPr>
               <a:t>AB</a:t>
             </a:r>
-            <a:endParaRPr lang="en-US" sz="2200" dirty="0"/>
+            <a:endParaRPr lang="en-US" sz="2400" dirty="0"/>
           </a:p>
         </p:txBody>
       </p:sp>
@@ -1295,8 +1295,8 @@
         </p:nvSpPr>
         <p:spPr>
           <a:xfrm>
-            <a:off x="1417320" y="1947672"/>
-            <a:ext cx="5852160" cy="292608"/>
+            <a:off x="1508760" y="2057400"/>
+            <a:ext cx="5760720" cy="329184"/>
           </a:xfrm>
           <a:prstGeom prst="rect">
             <a:avLst/>
@@ -1312,7 +1312,7 @@
               <a:buNone/>
             </a:pPr>
             <a:r>
-              <a:rPr lang="en-US" sz="1600" b="1" dirty="0">
+              <a:rPr lang="en-US" sz="1800" b="1" dirty="0">
                 <a:solidFill>
                   <a:srgbClr val="0C2A3D"/>
                 </a:solidFill>
@@ -1322,7 +1322,7 @@
               </a:rPr>
               <a:t>Allan Bakesiga, MD</a:t>
             </a:r>
-            <a:endParaRPr lang="en-US" sz="1600" dirty="0"/>
+            <a:endParaRPr lang="en-US" sz="1800" dirty="0"/>
           </a:p>
         </p:txBody>
       </p:sp>
@@ -1334,8 +1334,8 @@
         </p:nvSpPr>
         <p:spPr>
           <a:xfrm>
-            <a:off x="1417320" y="2240280"/>
-            <a:ext cx="5852160" cy="237744"/>
+            <a:off x="1508760" y="2386584"/>
+            <a:ext cx="5760720" cy="274320"/>
           </a:xfrm>
           <a:prstGeom prst="rect">
             <a:avLst/>
@@ -1351,7 +1351,7 @@
               <a:buNone/>
             </a:pPr>
             <a:r>
-              <a:rPr lang="en-US" sz="1050" dirty="0">
+              <a:rPr lang="en-US" sz="1200" dirty="0">
                 <a:solidFill>
                   <a:srgbClr val="345671"/>
                 </a:solidFill>
@@ -1361,7 +1361,7 @@
               </a:rPr>
               <a:t>MD (Makerere)  ·  MScGH (Duke)  ·  Incoming PGY-1 Neurology, Creighton</a:t>
             </a:r>
-            <a:endParaRPr lang="en-US" sz="1050" dirty="0"/>
+            <a:endParaRPr lang="en-US" sz="1200" dirty="0"/>
           </a:p>
         </p:txBody>
       </p:sp>
@@ -1373,8 +1373,8 @@
         </p:nvSpPr>
         <p:spPr>
           <a:xfrm>
-            <a:off x="1417320" y="2459736"/>
-            <a:ext cx="5852160" cy="219456"/>
+            <a:off x="1508760" y="2660904"/>
+            <a:ext cx="5760720" cy="256032"/>
           </a:xfrm>
           <a:prstGeom prst="rect">
             <a:avLst/>
@@ -1390,7 +1390,7 @@
               <a:buNone/>
             </a:pPr>
             <a:r>
-              <a:rPr lang="en-US" sz="1000" i="1" dirty="0">
+              <a:rPr lang="en-US" sz="1100" i="1" dirty="0">
                 <a:solidFill>
                   <a:srgbClr val="075985"/>
                 </a:solidFill>
@@ -1400,7 +1400,7 @@
               </a:rPr>
               <a:t>Epidemiology &amp; biostatistics teaching assistant</a:t>
             </a:r>
-            <a:endParaRPr lang="en-US" sz="1000" dirty="0"/>
+            <a:endParaRPr lang="en-US" sz="1100" dirty="0"/>
           </a:p>
         </p:txBody>
       </p:sp>
@@ -1412,8 +1412,8 @@
         </p:nvSpPr>
         <p:spPr>
           <a:xfrm>
-            <a:off x="457200" y="2926080"/>
-            <a:ext cx="2164080" cy="868680"/>
+            <a:off x="457200" y="3108960"/>
+            <a:ext cx="2164080" cy="960120"/>
           </a:xfrm>
           <a:prstGeom prst="rect">
             <a:avLst/>
@@ -1437,8 +1437,8 @@
         </p:nvSpPr>
         <p:spPr>
           <a:xfrm>
-            <a:off x="457200" y="3017520"/>
-            <a:ext cx="2164080" cy="411480"/>
+            <a:off x="457200" y="3218688"/>
+            <a:ext cx="2164080" cy="457200"/>
           </a:xfrm>
           <a:prstGeom prst="rect">
             <a:avLst/>
@@ -1454,7 +1454,7 @@
               <a:buNone/>
             </a:pPr>
             <a:r>
-              <a:rPr lang="en-US" sz="2200" b="1" dirty="0">
+              <a:rPr lang="en-US" sz="2600" b="1" dirty="0">
                 <a:solidFill>
                   <a:srgbClr val="075985"/>
                 </a:solidFill>
@@ -1464,7 +1464,7 @@
               </a:rPr>
               <a:t>Mon–Sun</a:t>
             </a:r>
-            <a:endParaRPr lang="en-US" sz="2200" dirty="0"/>
+            <a:endParaRPr lang="en-US" sz="2600" dirty="0"/>
           </a:p>
         </p:txBody>
       </p:sp>
@@ -1476,8 +1476,8 @@
         </p:nvSpPr>
         <p:spPr>
           <a:xfrm>
-            <a:off x="457200" y="3429000"/>
-            <a:ext cx="2164080" cy="292608"/>
+            <a:off x="457200" y="3675888"/>
+            <a:ext cx="2164080" cy="320040"/>
           </a:xfrm>
           <a:prstGeom prst="rect">
             <a:avLst/>
@@ -1493,7 +1493,7 @@
               <a:buNone/>
             </a:pPr>
             <a:r>
-              <a:rPr lang="en-US" sz="1000" b="1" spc="200" kern="0" dirty="0">
+              <a:rPr lang="en-US" sz="1100" b="1" spc="200" kern="0" dirty="0">
                 <a:solidFill>
                   <a:srgbClr val="345671"/>
                 </a:solidFill>
@@ -1503,7 +1503,7 @@
               </a:rPr>
               <a:t>Daily classes</a:t>
             </a:r>
-            <a:endParaRPr lang="en-US" sz="1000" dirty="0"/>
+            <a:endParaRPr lang="en-US" sz="1100" dirty="0"/>
           </a:p>
         </p:txBody>
       </p:sp>
@@ -1515,8 +1515,8 @@
         </p:nvSpPr>
         <p:spPr>
           <a:xfrm>
-            <a:off x="2804160" y="2926080"/>
-            <a:ext cx="2164080" cy="868680"/>
+            <a:off x="2804160" y="3108960"/>
+            <a:ext cx="2164080" cy="960120"/>
           </a:xfrm>
           <a:prstGeom prst="rect">
             <a:avLst/>
@@ -1540,8 +1540,8 @@
         </p:nvSpPr>
         <p:spPr>
           <a:xfrm>
-            <a:off x="2804160" y="3017520"/>
-            <a:ext cx="2164080" cy="411480"/>
+            <a:off x="2804160" y="3218688"/>
+            <a:ext cx="2164080" cy="457200"/>
           </a:xfrm>
           <a:prstGeom prst="rect">
             <a:avLst/>
@@ -1557,7 +1557,7 @@
               <a:buNone/>
             </a:pPr>
             <a:r>
-              <a:rPr lang="en-US" sz="2200" b="1" dirty="0">
+              <a:rPr lang="en-US" sz="2600" b="1" dirty="0">
                 <a:solidFill>
                   <a:srgbClr val="075985"/>
                 </a:solidFill>
@@ -1567,7 +1567,7 @@
               </a:rPr>
               <a:t>4 mo</a:t>
             </a:r>
-            <a:endParaRPr lang="en-US" sz="2200" dirty="0"/>
+            <a:endParaRPr lang="en-US" sz="2600" dirty="0"/>
           </a:p>
         </p:txBody>
       </p:sp>
@@ -1579,8 +1579,8 @@
         </p:nvSpPr>
         <p:spPr>
           <a:xfrm>
-            <a:off x="2804160" y="3429000"/>
-            <a:ext cx="2164080" cy="292608"/>
+            <a:off x="2804160" y="3675888"/>
+            <a:ext cx="2164080" cy="320040"/>
           </a:xfrm>
           <a:prstGeom prst="rect">
             <a:avLst/>
@@ -1596,7 +1596,7 @@
               <a:buNone/>
             </a:pPr>
             <a:r>
-              <a:rPr lang="en-US" sz="1000" b="1" spc="200" kern="0" dirty="0">
+              <a:rPr lang="en-US" sz="1100" b="1" spc="200" kern="0" dirty="0">
                 <a:solidFill>
                   <a:srgbClr val="345671"/>
                 </a:solidFill>
@@ -1606,7 +1606,7 @@
               </a:rPr>
               <a:t>Structured roadmap</a:t>
             </a:r>
-            <a:endParaRPr lang="en-US" sz="1000" dirty="0"/>
+            <a:endParaRPr lang="en-US" sz="1100" dirty="0"/>
           </a:p>
         </p:txBody>
       </p:sp>
@@ -1618,8 +1618,8 @@
         </p:nvSpPr>
         <p:spPr>
           <a:xfrm>
-            <a:off x="5151120" y="2926080"/>
-            <a:ext cx="2164080" cy="868680"/>
+            <a:off x="5151120" y="3108960"/>
+            <a:ext cx="2164080" cy="960120"/>
           </a:xfrm>
           <a:prstGeom prst="rect">
             <a:avLst/>
@@ -1643,8 +1643,8 @@
         </p:nvSpPr>
         <p:spPr>
           <a:xfrm>
-            <a:off x="5151120" y="3017520"/>
-            <a:ext cx="2164080" cy="411480"/>
+            <a:off x="5151120" y="3218688"/>
+            <a:ext cx="2164080" cy="457200"/>
           </a:xfrm>
           <a:prstGeom prst="rect">
             <a:avLst/>
@@ -1660,7 +1660,7 @@
               <a:buNone/>
             </a:pPr>
             <a:r>
-              <a:rPr lang="en-US" sz="2200" b="1" dirty="0">
+              <a:rPr lang="en-US" sz="2600" b="1" dirty="0">
                 <a:solidFill>
                   <a:srgbClr val="075985"/>
                 </a:solidFill>
@@ -1670,7 +1670,7 @@
               </a:rPr>
               <a:t>Step 1+2</a:t>
             </a:r>
-            <a:endParaRPr lang="en-US" sz="2200" dirty="0"/>
+            <a:endParaRPr lang="en-US" sz="2600" dirty="0"/>
           </a:p>
         </p:txBody>
       </p:sp>
@@ -1682,8 +1682,8 @@
         </p:nvSpPr>
         <p:spPr>
           <a:xfrm>
-            <a:off x="5151120" y="3429000"/>
-            <a:ext cx="2164080" cy="292608"/>
+            <a:off x="5151120" y="3675888"/>
+            <a:ext cx="2164080" cy="320040"/>
           </a:xfrm>
           <a:prstGeom prst="rect">
             <a:avLst/>
@@ -1699,7 +1699,7 @@
               <a:buNone/>
             </a:pPr>
             <a:r>
-              <a:rPr lang="en-US" sz="1000" b="1" spc="200" kern="0" dirty="0">
+              <a:rPr lang="en-US" sz="1100" b="1" spc="200" kern="0" dirty="0">
                 <a:solidFill>
                   <a:srgbClr val="345671"/>
                 </a:solidFill>
@@ -1709,7 +1709,7 @@
               </a:rPr>
               <a:t>Combined option</a:t>
             </a:r>
-            <a:endParaRPr lang="en-US" sz="1000" dirty="0"/>
+            <a:endParaRPr lang="en-US" sz="1100" dirty="0"/>
           </a:p>
         </p:txBody>
       </p:sp>
@@ -1721,8 +1721,8 @@
         </p:nvSpPr>
         <p:spPr>
           <a:xfrm>
-            <a:off x="457200" y="4023360"/>
-            <a:ext cx="3314700" cy="1005840"/>
+            <a:off x="457200" y="4160520"/>
+            <a:ext cx="3314700" cy="1097280"/>
           </a:xfrm>
           <a:prstGeom prst="rect">
             <a:avLst/>
@@ -1753,8 +1753,8 @@
         </p:nvSpPr>
         <p:spPr>
           <a:xfrm>
-            <a:off x="457200" y="4023360"/>
-            <a:ext cx="91440" cy="1005840"/>
+            <a:off x="457200" y="4160520"/>
+            <a:ext cx="91440" cy="1097280"/>
           </a:xfrm>
           <a:prstGeom prst="rect">
             <a:avLst/>
@@ -1778,8 +1778,8 @@
         </p:nvSpPr>
         <p:spPr>
           <a:xfrm>
-            <a:off x="685800" y="4206240"/>
-            <a:ext cx="384048" cy="384048"/>
+            <a:off x="685800" y="4361688"/>
+            <a:ext cx="438912" cy="438912"/>
           </a:xfrm>
           <a:prstGeom prst="ellipse">
             <a:avLst/>
@@ -1803,8 +1803,8 @@
         </p:nvSpPr>
         <p:spPr>
           <a:xfrm>
-            <a:off x="685800" y="4206240"/>
-            <a:ext cx="384048" cy="384048"/>
+            <a:off x="685800" y="4361688"/>
+            <a:ext cx="438912" cy="438912"/>
           </a:xfrm>
           <a:prstGeom prst="rect">
             <a:avLst/>
@@ -1820,7 +1820,7 @@
               <a:buNone/>
             </a:pPr>
             <a:r>
-              <a:rPr lang="en-US" sz="1600" b="1" dirty="0">
+              <a:rPr lang="en-US" sz="1800" b="1" dirty="0">
                 <a:solidFill>
                   <a:srgbClr val="FFFFFF"/>
                 </a:solidFill>
@@ -1830,7 +1830,7 @@
               </a:rPr>
               <a:t>1</a:t>
             </a:r>
-            <a:endParaRPr lang="en-US" sz="1600" dirty="0"/>
+            <a:endParaRPr lang="en-US" sz="1800" dirty="0"/>
           </a:p>
         </p:txBody>
       </p:sp>
@@ -1842,8 +1842,8 @@
         </p:nvSpPr>
         <p:spPr>
           <a:xfrm>
-            <a:off x="1143000" y="4187952"/>
-            <a:ext cx="2537460" cy="274320"/>
+            <a:off x="1207008" y="4325112"/>
+            <a:ext cx="2473452" cy="310896"/>
           </a:xfrm>
           <a:prstGeom prst="rect">
             <a:avLst/>
@@ -1859,7 +1859,7 @@
               <a:buNone/>
             </a:pPr>
             <a:r>
-              <a:rPr lang="en-US" sz="1300" b="1" dirty="0">
+              <a:rPr lang="en-US" sz="1500" b="1" dirty="0">
                 <a:solidFill>
                   <a:srgbClr val="0C2A3D"/>
                 </a:solidFill>
@@ -1869,7 +1869,7 @@
               </a:rPr>
               <a:t>Daily classes</a:t>
             </a:r>
-            <a:endParaRPr lang="en-US" sz="1300" dirty="0"/>
+            <a:endParaRPr lang="en-US" sz="1500" dirty="0"/>
           </a:p>
         </p:txBody>
       </p:sp>
@@ -1881,8 +1881,8 @@
         </p:nvSpPr>
         <p:spPr>
           <a:xfrm>
-            <a:off x="1143000" y="4480560"/>
-            <a:ext cx="2537460" cy="502920"/>
+            <a:off x="1207008" y="4654296"/>
+            <a:ext cx="2473452" cy="548640"/>
           </a:xfrm>
           <a:prstGeom prst="rect">
             <a:avLst/>
@@ -1898,7 +1898,7 @@
               <a:buNone/>
             </a:pPr>
             <a:r>
-              <a:rPr lang="en-US" sz="1000" dirty="0">
+              <a:rPr lang="en-US" sz="1150" dirty="0">
                 <a:solidFill>
                   <a:srgbClr val="345671"/>
                 </a:solidFill>
@@ -1908,7 +1908,7 @@
               </a:rPr>
               <a:t>Monday to Sunday. Topic-by-topic flow that keeps you in the material every single day.</a:t>
             </a:r>
-            <a:endParaRPr lang="en-US" sz="1000" dirty="0"/>
+            <a:endParaRPr lang="en-US" sz="1150" dirty="0"/>
           </a:p>
         </p:txBody>
       </p:sp>
@@ -1920,8 +1920,8 @@
         </p:nvSpPr>
         <p:spPr>
           <a:xfrm>
-            <a:off x="4000500" y="4023360"/>
-            <a:ext cx="3314700" cy="1005840"/>
+            <a:off x="4000500" y="4160520"/>
+            <a:ext cx="3314700" cy="1097280"/>
           </a:xfrm>
           <a:prstGeom prst="rect">
             <a:avLst/>
@@ -1952,8 +1952,8 @@
         </p:nvSpPr>
         <p:spPr>
           <a:xfrm>
-            <a:off x="4000500" y="4023360"/>
-            <a:ext cx="91440" cy="1005840"/>
+            <a:off x="4000500" y="4160520"/>
+            <a:ext cx="91440" cy="1097280"/>
           </a:xfrm>
           <a:prstGeom prst="rect">
             <a:avLst/>
@@ -1977,8 +1977,8 @@
         </p:nvSpPr>
         <p:spPr>
           <a:xfrm>
-            <a:off x="4229100" y="4206240"/>
-            <a:ext cx="384048" cy="384048"/>
+            <a:off x="4229100" y="4361688"/>
+            <a:ext cx="438912" cy="438912"/>
           </a:xfrm>
           <a:prstGeom prst="ellipse">
             <a:avLst/>
@@ -2002,8 +2002,8 @@
         </p:nvSpPr>
         <p:spPr>
           <a:xfrm>
-            <a:off x="4229100" y="4206240"/>
-            <a:ext cx="384048" cy="384048"/>
+            <a:off x="4229100" y="4361688"/>
+            <a:ext cx="438912" cy="438912"/>
           </a:xfrm>
           <a:prstGeom prst="rect">
             <a:avLst/>
@@ -2019,7 +2019,7 @@
               <a:buNone/>
             </a:pPr>
             <a:r>
-              <a:rPr lang="en-US" sz="1600" b="1" dirty="0">
+              <a:rPr lang="en-US" sz="1800" b="1" dirty="0">
                 <a:solidFill>
                   <a:srgbClr val="FFFFFF"/>
                 </a:solidFill>
@@ -2029,7 +2029,7 @@
               </a:rPr>
               <a:t>2</a:t>
             </a:r>
-            <a:endParaRPr lang="en-US" sz="1600" dirty="0"/>
+            <a:endParaRPr lang="en-US" sz="1800" dirty="0"/>
           </a:p>
         </p:txBody>
       </p:sp>
@@ -2041,8 +2041,8 @@
         </p:nvSpPr>
         <p:spPr>
           <a:xfrm>
-            <a:off x="4686300" y="4187952"/>
-            <a:ext cx="2537460" cy="274320"/>
+            <a:off x="4750308" y="4325112"/>
+            <a:ext cx="2473452" cy="310896"/>
           </a:xfrm>
           <a:prstGeom prst="rect">
             <a:avLst/>
@@ -2058,7 +2058,7 @@
               <a:buNone/>
             </a:pPr>
             <a:r>
-              <a:rPr lang="en-US" sz="1300" b="1" dirty="0">
+              <a:rPr lang="en-US" sz="1500" b="1" dirty="0">
                 <a:solidFill>
                   <a:srgbClr val="0C2A3D"/>
                 </a:solidFill>
@@ -2068,7 +2068,7 @@
               </a:rPr>
               <a:t>Active community</a:t>
             </a:r>
-            <a:endParaRPr lang="en-US" sz="1300" dirty="0"/>
+            <a:endParaRPr lang="en-US" sz="1500" dirty="0"/>
           </a:p>
         </p:txBody>
       </p:sp>
@@ -2080,8 +2080,8 @@
         </p:nvSpPr>
         <p:spPr>
           <a:xfrm>
-            <a:off x="4686300" y="4480560"/>
-            <a:ext cx="2537460" cy="502920"/>
+            <a:off x="4750308" y="4654296"/>
+            <a:ext cx="2473452" cy="548640"/>
           </a:xfrm>
           <a:prstGeom prst="rect">
             <a:avLst/>
@@ -2097,7 +2097,7 @@
               <a:buNone/>
             </a:pPr>
             <a:r>
-              <a:rPr lang="en-US" sz="1000" dirty="0">
+              <a:rPr lang="en-US" sz="1150" dirty="0">
                 <a:solidFill>
                   <a:srgbClr val="345671"/>
                 </a:solidFill>
@@ -2107,7 +2107,7 @@
               </a:rPr>
               <a:t>Off-class peer discussions, accountability, and rapid Q&amp;A between sessions.</a:t>
             </a:r>
-            <a:endParaRPr lang="en-US" sz="1000" dirty="0"/>
+            <a:endParaRPr lang="en-US" sz="1150" dirty="0"/>
           </a:p>
         </p:txBody>
       </p:sp>
@@ -2119,8 +2119,8 @@
         </p:nvSpPr>
         <p:spPr>
           <a:xfrm>
-            <a:off x="457200" y="5193792"/>
-            <a:ext cx="3314700" cy="1005840"/>
+            <a:off x="457200" y="5422392"/>
+            <a:ext cx="3314700" cy="1097280"/>
           </a:xfrm>
           <a:prstGeom prst="rect">
             <a:avLst/>
@@ -2151,8 +2151,8 @@
         </p:nvSpPr>
         <p:spPr>
           <a:xfrm>
-            <a:off x="457200" y="5193792"/>
-            <a:ext cx="91440" cy="1005840"/>
+            <a:off x="457200" y="5422392"/>
+            <a:ext cx="91440" cy="1097280"/>
           </a:xfrm>
           <a:prstGeom prst="rect">
             <a:avLst/>
@@ -2176,8 +2176,8 @@
         </p:nvSpPr>
         <p:spPr>
           <a:xfrm>
-            <a:off x="685800" y="5376672"/>
-            <a:ext cx="384048" cy="384048"/>
+            <a:off x="685800" y="5623560"/>
+            <a:ext cx="438912" cy="438912"/>
           </a:xfrm>
           <a:prstGeom prst="ellipse">
             <a:avLst/>
@@ -2201,8 +2201,8 @@
         </p:nvSpPr>
         <p:spPr>
           <a:xfrm>
-            <a:off x="685800" y="5376672"/>
-            <a:ext cx="384048" cy="384048"/>
+            <a:off x="685800" y="5623560"/>
+            <a:ext cx="438912" cy="438912"/>
           </a:xfrm>
           <a:prstGeom prst="rect">
             <a:avLst/>
@@ -2218,7 +2218,7 @@
               <a:buNone/>
             </a:pPr>
             <a:r>
-              <a:rPr lang="en-US" sz="1600" b="1" dirty="0">
+              <a:rPr lang="en-US" sz="1800" b="1" dirty="0">
                 <a:solidFill>
                   <a:srgbClr val="FFFFFF"/>
                 </a:solidFill>
@@ -2228,7 +2228,7 @@
               </a:rPr>
               <a:t>3</a:t>
             </a:r>
-            <a:endParaRPr lang="en-US" sz="1600" dirty="0"/>
+            <a:endParaRPr lang="en-US" sz="1800" dirty="0"/>
           </a:p>
         </p:txBody>
       </p:sp>
@@ -2240,8 +2240,8 @@
         </p:nvSpPr>
         <p:spPr>
           <a:xfrm>
-            <a:off x="1143000" y="5358384"/>
-            <a:ext cx="2537460" cy="274320"/>
+            <a:off x="1207008" y="5586984"/>
+            <a:ext cx="2473452" cy="310896"/>
           </a:xfrm>
           <a:prstGeom prst="rect">
             <a:avLst/>
@@ -2257,7 +2257,7 @@
               <a:buNone/>
             </a:pPr>
             <a:r>
-              <a:rPr lang="en-US" sz="1300" b="1" dirty="0">
+              <a:rPr lang="en-US" sz="1500" b="1" dirty="0">
                 <a:solidFill>
                   <a:srgbClr val="0C2A3D"/>
                 </a:solidFill>
@@ -2267,7 +2267,7 @@
               </a:rPr>
               <a:t>Textbook + Qbank</a:t>
             </a:r>
-            <a:endParaRPr lang="en-US" sz="1300" dirty="0"/>
+            <a:endParaRPr lang="en-US" sz="1500" dirty="0"/>
           </a:p>
         </p:txBody>
       </p:sp>
@@ -2279,8 +2279,8 @@
         </p:nvSpPr>
         <p:spPr>
           <a:xfrm>
-            <a:off x="1143000" y="5650992"/>
-            <a:ext cx="2537460" cy="502920"/>
+            <a:off x="1207008" y="5916168"/>
+            <a:ext cx="2473452" cy="548640"/>
           </a:xfrm>
           <a:prstGeom prst="rect">
             <a:avLst/>
@@ -2296,7 +2296,7 @@
               <a:buNone/>
             </a:pPr>
             <a:r>
-              <a:rPr lang="en-US" sz="1000" dirty="0">
+              <a:rPr lang="en-US" sz="1150" dirty="0">
                 <a:solidFill>
                   <a:srgbClr val="345671"/>
                 </a:solidFill>
@@ -2306,7 +2306,7 @@
               </a:rPr>
               <a:t>Full review of the recommended textbook plus USMLE-style questions from the recommended Qbank.</a:t>
             </a:r>
-            <a:endParaRPr lang="en-US" sz="1000" dirty="0"/>
+            <a:endParaRPr lang="en-US" sz="1150" dirty="0"/>
           </a:p>
         </p:txBody>
       </p:sp>
@@ -2318,8 +2318,8 @@
         </p:nvSpPr>
         <p:spPr>
           <a:xfrm>
-            <a:off x="4000500" y="5193792"/>
-            <a:ext cx="3314700" cy="1005840"/>
+            <a:off x="4000500" y="5422392"/>
+            <a:ext cx="3314700" cy="1097280"/>
           </a:xfrm>
           <a:prstGeom prst="rect">
             <a:avLst/>
@@ -2350,8 +2350,8 @@
         </p:nvSpPr>
         <p:spPr>
           <a:xfrm>
-            <a:off x="4000500" y="5193792"/>
-            <a:ext cx="91440" cy="1005840"/>
+            <a:off x="4000500" y="5422392"/>
+            <a:ext cx="91440" cy="1097280"/>
           </a:xfrm>
           <a:prstGeom prst="rect">
             <a:avLst/>
@@ -2375,8 +2375,8 @@
         </p:nvSpPr>
         <p:spPr>
           <a:xfrm>
-            <a:off x="4229100" y="5376672"/>
-            <a:ext cx="384048" cy="384048"/>
+            <a:off x="4229100" y="5623560"/>
+            <a:ext cx="438912" cy="438912"/>
           </a:xfrm>
           <a:prstGeom prst="ellipse">
             <a:avLst/>
@@ -2400,8 +2400,8 @@
         </p:nvSpPr>
         <p:spPr>
           <a:xfrm>
-            <a:off x="4229100" y="5376672"/>
-            <a:ext cx="384048" cy="384048"/>
+            <a:off x="4229100" y="5623560"/>
+            <a:ext cx="438912" cy="438912"/>
           </a:xfrm>
           <a:prstGeom prst="rect">
             <a:avLst/>
@@ -2417,7 +2417,7 @@
               <a:buNone/>
             </a:pPr>
             <a:r>
-              <a:rPr lang="en-US" sz="1600" b="1" dirty="0">
+              <a:rPr lang="en-US" sz="1800" b="1" dirty="0">
                 <a:solidFill>
                   <a:srgbClr val="FFFFFF"/>
                 </a:solidFill>
@@ -2427,7 +2427,7 @@
               </a:rPr>
               <a:t>4</a:t>
             </a:r>
-            <a:endParaRPr lang="en-US" sz="1600" dirty="0"/>
+            <a:endParaRPr lang="en-US" sz="1800" dirty="0"/>
           </a:p>
         </p:txBody>
       </p:sp>
@@ -2439,8 +2439,8 @@
         </p:nvSpPr>
         <p:spPr>
           <a:xfrm>
-            <a:off x="4686300" y="5358384"/>
-            <a:ext cx="2537460" cy="274320"/>
+            <a:off x="4750308" y="5586984"/>
+            <a:ext cx="2473452" cy="310896"/>
           </a:xfrm>
           <a:prstGeom prst="rect">
             <a:avLst/>
@@ -2456,7 +2456,7 @@
               <a:buNone/>
             </a:pPr>
             <a:r>
-              <a:rPr lang="en-US" sz="1300" b="1" dirty="0">
+              <a:rPr lang="en-US" sz="1500" b="1" dirty="0">
                 <a:solidFill>
                   <a:srgbClr val="0C2A3D"/>
                 </a:solidFill>
@@ -2466,7 +2466,7 @@
               </a:rPr>
               <a:t>End-to-end mentorship</a:t>
             </a:r>
-            <a:endParaRPr lang="en-US" sz="1300" dirty="0"/>
+            <a:endParaRPr lang="en-US" sz="1500" dirty="0"/>
           </a:p>
         </p:txBody>
       </p:sp>
@@ -2478,8 +2478,8 @@
         </p:nvSpPr>
         <p:spPr>
           <a:xfrm>
-            <a:off x="4686300" y="5650992"/>
-            <a:ext cx="2537460" cy="502920"/>
+            <a:off x="4750308" y="5916168"/>
+            <a:ext cx="2473452" cy="548640"/>
           </a:xfrm>
           <a:prstGeom prst="rect">
             <a:avLst/>
@@ -2495,7 +2495,7 @@
               <a:buNone/>
             </a:pPr>
             <a:r>
-              <a:rPr lang="en-US" sz="1000" dirty="0">
+              <a:rPr lang="en-US" sz="1150" dirty="0">
                 <a:solidFill>
                   <a:srgbClr val="345671"/>
                 </a:solidFill>
@@ -2505,7 +2505,7 @@
               </a:rPr>
               <a:t>Guidance through ECFMG, CV, personal statement, interview prep, and residency application.</a:t>
             </a:r>
-            <a:endParaRPr lang="en-US" sz="1000" dirty="0"/>
+            <a:endParaRPr lang="en-US" sz="1150" dirty="0"/>
           </a:p>
         </p:txBody>
       </p:sp>
@@ -2517,8 +2517,8 @@
         </p:nvSpPr>
         <p:spPr>
           <a:xfrm>
-            <a:off x="457200" y="6492240"/>
-            <a:ext cx="6858000" cy="256032"/>
+            <a:off x="457200" y="6583680"/>
+            <a:ext cx="6858000" cy="274320"/>
           </a:xfrm>
           <a:prstGeom prst="rect">
             <a:avLst/>
@@ -2534,7 +2534,7 @@
               <a:buNone/>
             </a:pPr>
             <a:r>
-              <a:rPr lang="en-US" sz="1000" b="1" spc="400" kern="0" dirty="0">
+              <a:rPr lang="en-US" sz="1100" b="1" spc="400" kern="0" dirty="0">
                 <a:solidFill>
                   <a:srgbClr val="075985"/>
                 </a:solidFill>
@@ -2544,7 +2544,7 @@
               </a:rPr>
               <a:t>WHAT WE COVER</a:t>
             </a:r>
-            <a:endParaRPr lang="en-US" sz="1000" dirty="0"/>
+            <a:endParaRPr lang="en-US" sz="1100" dirty="0"/>
           </a:p>
         </p:txBody>
       </p:sp>
@@ -2556,7 +2556,7 @@
         </p:nvSpPr>
         <p:spPr>
           <a:xfrm>
-            <a:off x="457200" y="6784848"/>
+            <a:off x="457200" y="6894576"/>
             <a:ext cx="6858000" cy="502920"/>
           </a:xfrm>
           <a:prstGeom prst="rect">
@@ -2573,7 +2573,7 @@
               <a:buNone/>
             </a:pPr>
             <a:r>
-              <a:rPr lang="en-US" sz="1150" b="1" dirty="0">
+              <a:rPr lang="en-US" sz="1250" b="1" dirty="0">
                 <a:solidFill>
                   <a:srgbClr val="075985"/>
                 </a:solidFill>
@@ -2587,7 +2587,7 @@
               <a:buNone/>
             </a:pPr>
             <a:r>
-              <a:rPr lang="en-US" sz="1150" dirty="0">
+              <a:rPr lang="en-US" sz="1250" dirty="0">
                 <a:solidFill>
                   <a:srgbClr val="0C2A3D"/>
                 </a:solidFill>
@@ -2597,7 +2597,7 @@
               </a:rPr>
               <a:t>Anatomy  ·  Physiology  ·  Biochemistry  ·  Pathology  ·  Pharmacology  ·  Microbiology  ·  Immunology  ·  Behavioral science  ·  Biostatistics  ·  Genetics</a:t>
             </a:r>
-            <a:endParaRPr lang="en-US" sz="1150" dirty="0"/>
+            <a:endParaRPr lang="en-US" sz="1250" dirty="0"/>
           </a:p>
         </p:txBody>
       </p:sp>
@@ -2609,7 +2609,7 @@
         </p:nvSpPr>
         <p:spPr>
           <a:xfrm>
-            <a:off x="457200" y="7287768"/>
+            <a:off x="457200" y="7397496"/>
             <a:ext cx="6858000" cy="502920"/>
           </a:xfrm>
           <a:prstGeom prst="rect">
@@ -2626,7 +2626,7 @@
               <a:buNone/>
             </a:pPr>
             <a:r>
-              <a:rPr lang="en-US" sz="1150" b="1" dirty="0">
+              <a:rPr lang="en-US" sz="1250" b="1" dirty="0">
                 <a:solidFill>
                   <a:srgbClr val="075985"/>
                 </a:solidFill>
@@ -2640,7 +2640,7 @@
               <a:buNone/>
             </a:pPr>
             <a:r>
-              <a:rPr lang="en-US" sz="1150" dirty="0">
+              <a:rPr lang="en-US" sz="1250" dirty="0">
                 <a:solidFill>
                   <a:srgbClr val="0C2A3D"/>
                 </a:solidFill>
@@ -2650,7 +2650,7 @@
               </a:rPr>
               <a:t>Cardiovascular  ·  Respiratory  ·  Gastrointestinal  ·  Renal  ·  Reproductive  ·  Endocrine  ·  Musculoskeletal  ·  Nervous system  ·  Heme/Onc  ·  Skin</a:t>
             </a:r>
-            <a:endParaRPr lang="en-US" sz="1150" dirty="0"/>
+            <a:endParaRPr lang="en-US" sz="1250" dirty="0"/>
           </a:p>
         </p:txBody>
       </p:sp>
@@ -2662,7 +2662,7 @@
         </p:nvSpPr>
         <p:spPr>
           <a:xfrm>
-            <a:off x="457200" y="7772400"/>
+            <a:off x="457200" y="7909560"/>
             <a:ext cx="6858000" cy="777240"/>
           </a:xfrm>
           <a:prstGeom prst="rect">
@@ -2687,7 +2687,7 @@
         </p:nvSpPr>
         <p:spPr>
           <a:xfrm>
-            <a:off x="457200" y="7772400"/>
+            <a:off x="457200" y="7909560"/>
             <a:ext cx="91440" cy="777240"/>
           </a:xfrm>
           <a:prstGeom prst="rect">
@@ -2712,7 +2712,7 @@
         </p:nvSpPr>
         <p:spPr>
           <a:xfrm>
-            <a:off x="731520" y="7863840"/>
+            <a:off x="731520" y="7982712"/>
             <a:ext cx="6492240" cy="274320"/>
           </a:xfrm>
           <a:prstGeom prst="rect">
@@ -2729,7 +2729,7 @@
               <a:buNone/>
             </a:pPr>
             <a:r>
-              <a:rPr lang="en-US" sz="1300" b="1" dirty="0">
+              <a:rPr lang="en-US" sz="1400" b="1" dirty="0">
                 <a:solidFill>
                   <a:srgbClr val="FFFFFF"/>
                 </a:solidFill>
@@ -2739,7 +2739,7 @@
               </a:rPr>
               <a:t>Doing both Step 1 &amp; 2?</a:t>
             </a:r>
-            <a:endParaRPr lang="en-US" sz="1300" dirty="0"/>
+            <a:endParaRPr lang="en-US" sz="1400" dirty="0"/>
           </a:p>
         </p:txBody>
       </p:sp>
@@ -2751,7 +2751,7 @@
         </p:nvSpPr>
         <p:spPr>
           <a:xfrm>
-            <a:off x="731520" y="8138160"/>
+            <a:off x="731520" y="8257032"/>
             <a:ext cx="6492240" cy="384048"/>
           </a:xfrm>
           <a:prstGeom prst="rect">
@@ -2768,7 +2768,7 @@
               <a:buNone/>
             </a:pPr>
             <a:r>
-              <a:rPr lang="en-US" sz="1050" dirty="0">
+              <a:rPr lang="en-US" sz="1150" dirty="0">
                 <a:solidFill>
                   <a:srgbClr val="FFFFFF"/>
                 </a:solidFill>
@@ -2778,7 +2778,7 @@
               </a:rPr>
               <a:t>Take the expedited combined prep — overlapping topics taught once, reinforced across both Steps. Save time, retain more.</a:t>
             </a:r>
-            <a:endParaRPr lang="en-US" sz="1050" dirty="0"/>
+            <a:endParaRPr lang="en-US" sz="1150" dirty="0"/>
           </a:p>
         </p:txBody>
       </p:sp>
@@ -2791,7 +2791,7 @@
         <p:spPr>
           <a:xfrm>
             <a:off x="457200" y="8732520"/>
-            <a:ext cx="6858000" cy="274320"/>
+            <a:ext cx="6858000" cy="201168"/>
           </a:xfrm>
           <a:prstGeom prst="rect">
             <a:avLst/>
@@ -2807,7 +2807,7 @@
               <a:buNone/>
             </a:pPr>
             <a:r>
-              <a:rPr lang="en-US" sz="1000" b="1" spc="400" kern="0" dirty="0">
+              <a:rPr lang="en-US" sz="1100" b="1" spc="400" kern="0" dirty="0">
                 <a:solidFill>
                   <a:srgbClr val="075985"/>
                 </a:solidFill>
@@ -2817,7 +2817,7 @@
               </a:rPr>
               <a:t>SIGN UP</a:t>
             </a:r>
-            <a:endParaRPr lang="en-US" sz="1000" dirty="0"/>
+            <a:endParaRPr lang="en-US" sz="1100" dirty="0"/>
           </a:p>
         </p:txBody>
       </p:sp>
@@ -2829,8 +2829,8 @@
         </p:nvSpPr>
         <p:spPr>
           <a:xfrm>
-            <a:off x="457200" y="8979408"/>
-            <a:ext cx="6858000" cy="384048"/>
+            <a:off x="457200" y="8915400"/>
+            <a:ext cx="6858000" cy="402336"/>
           </a:xfrm>
           <a:prstGeom prst="rect">
             <a:avLst/>
@@ -2846,7 +2846,7 @@
               <a:buNone/>
             </a:pPr>
             <a:r>
-              <a:rPr lang="en-US" sz="2200" b="1" dirty="0">
+              <a:rPr lang="en-US" sz="2400" b="1" dirty="0">
                 <a:solidFill>
                   <a:srgbClr val="0284C7"/>
                 </a:solidFill>
@@ -2856,7 +2856,7 @@
               </a:rPr>
               <a:t>bakesiga.github.io/usmle-dashboard</a:t>
             </a:r>
-            <a:endParaRPr lang="en-US" sz="2200" dirty="0"/>
+            <a:endParaRPr lang="en-US" sz="2400" dirty="0"/>
           </a:p>
         </p:txBody>
       </p:sp>
@@ -2868,7 +2868,7 @@
         </p:nvSpPr>
         <p:spPr>
           <a:xfrm>
-            <a:off x="457200" y="9518904"/>
+            <a:off x="457200" y="9427464"/>
             <a:ext cx="164592" cy="164592"/>
           </a:xfrm>
           <a:prstGeom prst="ellipse">
@@ -2893,8 +2893,8 @@
         </p:nvSpPr>
         <p:spPr>
           <a:xfrm>
-            <a:off x="713232" y="9445752"/>
-            <a:ext cx="6601968" cy="292608"/>
+            <a:off x="694944" y="9372600"/>
+            <a:ext cx="3099816" cy="274320"/>
           </a:xfrm>
           <a:prstGeom prst="rect">
             <a:avLst/>
@@ -2910,7 +2910,7 @@
               <a:buNone/>
             </a:pPr>
             <a:r>
-              <a:rPr lang="en-US" sz="1200" b="1" dirty="0">
+              <a:rPr lang="en-US" sz="1250" b="1" dirty="0">
                 <a:solidFill>
                   <a:srgbClr val="0C2A3D"/>
                 </a:solidFill>
@@ -2918,22 +2918,124 @@
                 <a:ea typeface="Calibri" pitchFamily="34" charset="-122"/>
                 <a:cs typeface="Calibri" pitchFamily="34" charset="-120"/>
               </a:rPr>
-              <a:t>allanbakesiga@gmail.com  ·  Limited cohort</a:t>
-            </a:r>
-            <a:endParaRPr lang="en-US" sz="1200" dirty="0"/>
-          </a:p>
-        </p:txBody>
-      </p:sp>
-      <p:sp>
-        <p:nvSpPr>
-          <p:cNvPr id="61" name="Shape 59"/>
-          <p:cNvSpPr/>
-          <p:nvPr/>
-        </p:nvSpPr>
-        <p:spPr>
-          <a:xfrm>
-            <a:off x="0" y="9784080"/>
-            <a:ext cx="7772400" cy="54864"/>
+              <a:t>allanbakesiga@gmail.com</a:t>
+            </a:r>
+            <a:endParaRPr lang="en-US" sz="1250" dirty="0"/>
+          </a:p>
+        </p:txBody>
+      </p:sp>
+      <p:pic>
+        <p:nvPicPr>
+          <p:cNvPr id="61" name="Image 0" descr="whatsapp.png">    </p:cNvPr>
+          <p:cNvPicPr>
+            <a:picLocks noChangeAspect="1"/>
+          </p:cNvPicPr>
+          <p:nvPr/>
+        </p:nvPicPr>
+        <p:blipFill>
+          <a:blip r:embed="rId1"/>
+          <a:stretch>
+            <a:fillRect/>
+          </a:stretch>
+        </p:blipFill>
+        <p:spPr>
+          <a:xfrm>
+            <a:off x="3977640" y="9390888"/>
+            <a:ext cx="237744" cy="237744"/>
+          </a:xfrm>
+          <a:prstGeom prst="rect">
+            <a:avLst/>
+          </a:prstGeom>
+        </p:spPr>
+      </p:pic>
+      <p:sp>
+        <p:nvSpPr>
+          <p:cNvPr id="62" name="Text 59"/>
+          <p:cNvSpPr/>
+          <p:nvPr/>
+        </p:nvSpPr>
+        <p:spPr>
+          <a:xfrm>
+            <a:off x="4288536" y="9372600"/>
+            <a:ext cx="2843784" cy="274320"/>
+          </a:xfrm>
+          <a:prstGeom prst="rect">
+            <a:avLst/>
+          </a:prstGeom>
+          <a:noFill/>
+          <a:ln/>
+        </p:spPr>
+        <p:txBody>
+          <a:bodyPr wrap="square" lIns="0" tIns="0" rIns="0" bIns="0" rtlCol="0" anchor="ctr"/>
+          <a:lstStyle/>
+          <a:p>
+            <a:pPr indent="0" marL="0">
+              <a:buNone/>
+            </a:pPr>
+            <a:r>
+              <a:rPr lang="en-US" sz="1250" b="1" dirty="0">
+                <a:solidFill>
+                  <a:srgbClr val="0C2A3D"/>
+                </a:solidFill>
+                <a:latin typeface="Calibri" pitchFamily="34" charset="0"/>
+                <a:ea typeface="Calibri" pitchFamily="34" charset="-122"/>
+                <a:cs typeface="Calibri" pitchFamily="34" charset="-120"/>
+              </a:rPr>
+              <a:t>WhatsApp · +256 705 571 443</a:t>
+            </a:r>
+            <a:endParaRPr lang="en-US" sz="1250" dirty="0"/>
+          </a:p>
+        </p:txBody>
+      </p:sp>
+      <p:sp>
+        <p:nvSpPr>
+          <p:cNvPr id="63" name="Text 60"/>
+          <p:cNvSpPr/>
+          <p:nvPr/>
+        </p:nvSpPr>
+        <p:spPr>
+          <a:xfrm>
+            <a:off x="457200" y="9683496"/>
+            <a:ext cx="6858000" cy="182880"/>
+          </a:xfrm>
+          <a:prstGeom prst="rect">
+            <a:avLst/>
+          </a:prstGeom>
+          <a:noFill/>
+          <a:ln/>
+        </p:spPr>
+        <p:txBody>
+          <a:bodyPr wrap="square" lIns="0" tIns="0" rIns="0" bIns="0" rtlCol="0" anchor="ctr"/>
+          <a:lstStyle/>
+          <a:p>
+            <a:pPr algn="l" indent="0" marL="0">
+              <a:buNone/>
+            </a:pPr>
+            <a:r>
+              <a:rPr lang="en-US" sz="950" i="1" dirty="0">
+                <a:solidFill>
+                  <a:srgbClr val="6B87A3"/>
+                </a:solidFill>
+                <a:latin typeface="Calibri" pitchFamily="34" charset="0"/>
+                <a:ea typeface="Calibri" pitchFamily="34" charset="-122"/>
+                <a:cs typeface="Calibri" pitchFamily="34" charset="-120"/>
+              </a:rPr>
+              <a:t>Limited cohort · Sign in with the Gmail Allan adds you under</a:t>
+            </a:r>
+            <a:endParaRPr lang="en-US" sz="950" dirty="0"/>
+          </a:p>
+        </p:txBody>
+      </p:sp>
+      <p:sp>
+        <p:nvSpPr>
+          <p:cNvPr id="64" name="Shape 61"/>
+          <p:cNvSpPr/>
+          <p:nvPr/>
+        </p:nvSpPr>
+        <p:spPr>
+          <a:xfrm>
+            <a:off x="0" y="9875520"/>
+            <a:ext cx="7772400" cy="45720"/>
           </a:xfrm>
           <a:prstGeom prst="rect">
             <a:avLst/>
@@ -2951,14 +3053,14 @@
       </p:sp>
       <p:sp>
         <p:nvSpPr>
-          <p:cNvPr id="62" name="Shape 60"/>
-          <p:cNvSpPr/>
-          <p:nvPr/>
-        </p:nvSpPr>
-        <p:spPr>
-          <a:xfrm>
-            <a:off x="0" y="9838944"/>
-            <a:ext cx="7772400" cy="219456"/>
+          <p:cNvPr id="65" name="Shape 62"/>
+          <p:cNvSpPr/>
+          <p:nvPr/>
+        </p:nvSpPr>
+        <p:spPr>
+          <a:xfrm>
+            <a:off x="0" y="9921240"/>
+            <a:ext cx="7772400" cy="137160"/>
           </a:xfrm>
           <a:prstGeom prst="rect">
             <a:avLst/>

</xml_diff>

<commit_message>
Flyers: callout hugs topics; remove Step 2 white space
Callout Y is now computed from where the topics block ends
(topicsEnd + 0.05) instead of being fixed. Step 2 (single
topics line) no longer has a wide white gap above the
combined-prep callout. Step 1 (two topics lines) keeps the
same tight stacking.

CTA stays anchored at fixed y=9.55 with slightly tightened
limited-cohort line so the bottom strip is identical across
both flyers.

Co-Authored-By: Claude Opus 4.7 (1M context) <noreply@anthropic.com>
</commit_message>
<xml_diff>
--- a/outputs/flyers/USMLE_Step1_Flyer.pptx
+++ b/outputs/flyers/USMLE_Step1_Flyer.pptx
@@ -2662,7 +2662,7 @@
         </p:nvSpPr>
         <p:spPr>
           <a:xfrm>
-            <a:off x="457200" y="7909560"/>
+            <a:off x="457200" y="7946136"/>
             <a:ext cx="6858000" cy="777240"/>
           </a:xfrm>
           <a:prstGeom prst="rect">
@@ -2687,7 +2687,7 @@
         </p:nvSpPr>
         <p:spPr>
           <a:xfrm>
-            <a:off x="457200" y="7909560"/>
+            <a:off x="457200" y="7946136"/>
             <a:ext cx="91440" cy="777240"/>
           </a:xfrm>
           <a:prstGeom prst="rect">
@@ -2712,7 +2712,7 @@
         </p:nvSpPr>
         <p:spPr>
           <a:xfrm>
-            <a:off x="731520" y="7982712"/>
+            <a:off x="731520" y="8019288"/>
             <a:ext cx="6492240" cy="274320"/>
           </a:xfrm>
           <a:prstGeom prst="rect">
@@ -2751,7 +2751,7 @@
         </p:nvSpPr>
         <p:spPr>
           <a:xfrm>
-            <a:off x="731520" y="8257032"/>
+            <a:off x="731520" y="8293608"/>
             <a:ext cx="6492240" cy="384048"/>
           </a:xfrm>
           <a:prstGeom prst="rect">
@@ -2995,8 +2995,8 @@
         </p:nvSpPr>
         <p:spPr>
           <a:xfrm>
-            <a:off x="457200" y="9683496"/>
-            <a:ext cx="6858000" cy="182880"/>
+            <a:off x="457200" y="9665208"/>
+            <a:ext cx="6858000" cy="164592"/>
           </a:xfrm>
           <a:prstGeom prst="rect">
             <a:avLst/>

</xml_diff>

<commit_message>
Flyers: swap AB initials for Allan's headshot
Cropped from the original 5184x3888 source (~/Downloads/100_0576 (4).JPG)
to a 600x600 square framed on head + collar + chest, then
embedded as the avatar with a brand-coloured ring.

Co-Authored-By: Claude Opus 4.7 (1M context) <noreply@anthropic.com>
</commit_message>
<xml_diff>
--- a/outputs/flyers/USMLE_Step1_Flyer.pptx
+++ b/outputs/flyers/USMLE_Step1_Flyer.pptx
@@ -1231,8 +1231,8 @@
         </p:nvSpPr>
         <p:spPr>
           <a:xfrm>
-            <a:off x="640080" y="2130552"/>
-            <a:ext cx="713232" cy="713232"/>
+            <a:off x="603504" y="2093976"/>
+            <a:ext cx="786384" cy="786384"/>
           </a:xfrm>
           <a:prstGeom prst="ellipse">
             <a:avLst/>
@@ -1248,48 +1248,32 @@
           </a:ln>
         </p:spPr>
       </p:sp>
-      <p:sp>
-        <p:nvSpPr>
-          <p:cNvPr id="13" name="Text 11"/>
-          <p:cNvSpPr/>
-          <p:nvPr/>
-        </p:nvSpPr>
+      <p:pic>
+        <p:nvPicPr>
+          <p:cNvPr id="13" name="Image 0" descr="allan.jpg">    </p:cNvPr>
+          <p:cNvPicPr>
+            <a:picLocks noChangeAspect="1"/>
+          </p:cNvPicPr>
+          <p:nvPr/>
+        </p:nvPicPr>
+        <p:blipFill>
+          <a:blip r:embed="rId1"/>
+          <a:srcRect l="0" r="0" t="0" b="0"/>
+          <a:stretch/>
+        </p:blipFill>
         <p:spPr>
           <a:xfrm>
             <a:off x="640080" y="2130552"/>
             <a:ext cx="713232" cy="713232"/>
           </a:xfrm>
-          <a:prstGeom prst="rect">
-            <a:avLst/>
-          </a:prstGeom>
-          <a:noFill/>
-          <a:ln/>
-        </p:spPr>
-        <p:txBody>
-          <a:bodyPr wrap="square" lIns="0" tIns="0" rIns="0" bIns="0" rtlCol="0" anchor="ctr"/>
-          <a:lstStyle/>
-          <a:p>
-            <a:pPr algn="ctr" indent="0" marL="0">
-              <a:buNone/>
-            </a:pPr>
-            <a:r>
-              <a:rPr lang="en-US" sz="2400" b="1" dirty="0">
-                <a:solidFill>
-                  <a:srgbClr val="FFFFFF"/>
-                </a:solidFill>
-                <a:latin typeface="Arial Black" pitchFamily="34" charset="0"/>
-                <a:ea typeface="Arial Black" pitchFamily="34" charset="-122"/>
-                <a:cs typeface="Arial Black" pitchFamily="34" charset="-120"/>
-              </a:rPr>
-              <a:t>AB</a:t>
-            </a:r>
-            <a:endParaRPr lang="en-US" sz="2400" dirty="0"/>
-          </a:p>
-        </p:txBody>
-      </p:sp>
-      <p:sp>
-        <p:nvSpPr>
-          <p:cNvPr id="14" name="Text 12"/>
+          <a:prstGeom prst="ellipse">
+            <a:avLst/>
+          </a:prstGeom>
+        </p:spPr>
+      </p:pic>
+      <p:sp>
+        <p:nvSpPr>
+          <p:cNvPr id="14" name="Text 11"/>
           <p:cNvSpPr/>
           <p:nvPr/>
         </p:nvSpPr>
@@ -1328,7 +1312,7 @@
       </p:sp>
       <p:sp>
         <p:nvSpPr>
-          <p:cNvPr id="15" name="Text 13"/>
+          <p:cNvPr id="15" name="Text 12"/>
           <p:cNvSpPr/>
           <p:nvPr/>
         </p:nvSpPr>
@@ -1367,7 +1351,7 @@
       </p:sp>
       <p:sp>
         <p:nvSpPr>
-          <p:cNvPr id="16" name="Text 14"/>
+          <p:cNvPr id="16" name="Text 13"/>
           <p:cNvSpPr/>
           <p:nvPr/>
         </p:nvSpPr>
@@ -1406,7 +1390,7 @@
       </p:sp>
       <p:sp>
         <p:nvSpPr>
-          <p:cNvPr id="17" name="Shape 15"/>
+          <p:cNvPr id="17" name="Shape 14"/>
           <p:cNvSpPr/>
           <p:nvPr/>
         </p:nvSpPr>
@@ -1431,7 +1415,7 @@
       </p:sp>
       <p:sp>
         <p:nvSpPr>
-          <p:cNvPr id="18" name="Text 16"/>
+          <p:cNvPr id="18" name="Text 15"/>
           <p:cNvSpPr/>
           <p:nvPr/>
         </p:nvSpPr>
@@ -1470,7 +1454,7 @@
       </p:sp>
       <p:sp>
         <p:nvSpPr>
-          <p:cNvPr id="19" name="Text 17"/>
+          <p:cNvPr id="19" name="Text 16"/>
           <p:cNvSpPr/>
           <p:nvPr/>
         </p:nvSpPr>
@@ -1509,7 +1493,7 @@
       </p:sp>
       <p:sp>
         <p:nvSpPr>
-          <p:cNvPr id="20" name="Shape 18"/>
+          <p:cNvPr id="20" name="Shape 17"/>
           <p:cNvSpPr/>
           <p:nvPr/>
         </p:nvSpPr>
@@ -1534,7 +1518,7 @@
       </p:sp>
       <p:sp>
         <p:nvSpPr>
-          <p:cNvPr id="21" name="Text 19"/>
+          <p:cNvPr id="21" name="Text 18"/>
           <p:cNvSpPr/>
           <p:nvPr/>
         </p:nvSpPr>
@@ -1573,7 +1557,7 @@
       </p:sp>
       <p:sp>
         <p:nvSpPr>
-          <p:cNvPr id="22" name="Text 20"/>
+          <p:cNvPr id="22" name="Text 19"/>
           <p:cNvSpPr/>
           <p:nvPr/>
         </p:nvSpPr>
@@ -1612,7 +1596,7 @@
       </p:sp>
       <p:sp>
         <p:nvSpPr>
-          <p:cNvPr id="23" name="Shape 21"/>
+          <p:cNvPr id="23" name="Shape 20"/>
           <p:cNvSpPr/>
           <p:nvPr/>
         </p:nvSpPr>
@@ -1637,7 +1621,7 @@
       </p:sp>
       <p:sp>
         <p:nvSpPr>
-          <p:cNvPr id="24" name="Text 22"/>
+          <p:cNvPr id="24" name="Text 21"/>
           <p:cNvSpPr/>
           <p:nvPr/>
         </p:nvSpPr>
@@ -1676,7 +1660,7 @@
       </p:sp>
       <p:sp>
         <p:nvSpPr>
-          <p:cNvPr id="25" name="Text 23"/>
+          <p:cNvPr id="25" name="Text 22"/>
           <p:cNvSpPr/>
           <p:nvPr/>
         </p:nvSpPr>
@@ -1715,7 +1699,7 @@
       </p:sp>
       <p:sp>
         <p:nvSpPr>
-          <p:cNvPr id="26" name="Shape 24"/>
+          <p:cNvPr id="26" name="Shape 23"/>
           <p:cNvSpPr/>
           <p:nvPr/>
         </p:nvSpPr>
@@ -1747,7 +1731,7 @@
       </p:sp>
       <p:sp>
         <p:nvSpPr>
-          <p:cNvPr id="27" name="Shape 25"/>
+          <p:cNvPr id="27" name="Shape 24"/>
           <p:cNvSpPr/>
           <p:nvPr/>
         </p:nvSpPr>
@@ -1772,7 +1756,7 @@
       </p:sp>
       <p:sp>
         <p:nvSpPr>
-          <p:cNvPr id="28" name="Shape 26"/>
+          <p:cNvPr id="28" name="Shape 25"/>
           <p:cNvSpPr/>
           <p:nvPr/>
         </p:nvSpPr>
@@ -1797,7 +1781,7 @@
       </p:sp>
       <p:sp>
         <p:nvSpPr>
-          <p:cNvPr id="29" name="Text 27"/>
+          <p:cNvPr id="29" name="Text 26"/>
           <p:cNvSpPr/>
           <p:nvPr/>
         </p:nvSpPr>
@@ -1836,7 +1820,7 @@
       </p:sp>
       <p:sp>
         <p:nvSpPr>
-          <p:cNvPr id="30" name="Text 28"/>
+          <p:cNvPr id="30" name="Text 27"/>
           <p:cNvSpPr/>
           <p:nvPr/>
         </p:nvSpPr>
@@ -1875,7 +1859,7 @@
       </p:sp>
       <p:sp>
         <p:nvSpPr>
-          <p:cNvPr id="31" name="Text 29"/>
+          <p:cNvPr id="31" name="Text 28"/>
           <p:cNvSpPr/>
           <p:nvPr/>
         </p:nvSpPr>
@@ -1914,7 +1898,7 @@
       </p:sp>
       <p:sp>
         <p:nvSpPr>
-          <p:cNvPr id="32" name="Shape 30"/>
+          <p:cNvPr id="32" name="Shape 29"/>
           <p:cNvSpPr/>
           <p:nvPr/>
         </p:nvSpPr>
@@ -1946,7 +1930,7 @@
       </p:sp>
       <p:sp>
         <p:nvSpPr>
-          <p:cNvPr id="33" name="Shape 31"/>
+          <p:cNvPr id="33" name="Shape 30"/>
           <p:cNvSpPr/>
           <p:nvPr/>
         </p:nvSpPr>
@@ -1971,7 +1955,7 @@
       </p:sp>
       <p:sp>
         <p:nvSpPr>
-          <p:cNvPr id="34" name="Shape 32"/>
+          <p:cNvPr id="34" name="Shape 31"/>
           <p:cNvSpPr/>
           <p:nvPr/>
         </p:nvSpPr>
@@ -1996,7 +1980,7 @@
       </p:sp>
       <p:sp>
         <p:nvSpPr>
-          <p:cNvPr id="35" name="Text 33"/>
+          <p:cNvPr id="35" name="Text 32"/>
           <p:cNvSpPr/>
           <p:nvPr/>
         </p:nvSpPr>
@@ -2035,7 +2019,7 @@
       </p:sp>
       <p:sp>
         <p:nvSpPr>
-          <p:cNvPr id="36" name="Text 34"/>
+          <p:cNvPr id="36" name="Text 33"/>
           <p:cNvSpPr/>
           <p:nvPr/>
         </p:nvSpPr>
@@ -2074,7 +2058,7 @@
       </p:sp>
       <p:sp>
         <p:nvSpPr>
-          <p:cNvPr id="37" name="Text 35"/>
+          <p:cNvPr id="37" name="Text 34"/>
           <p:cNvSpPr/>
           <p:nvPr/>
         </p:nvSpPr>
@@ -2113,7 +2097,7 @@
       </p:sp>
       <p:sp>
         <p:nvSpPr>
-          <p:cNvPr id="38" name="Shape 36"/>
+          <p:cNvPr id="38" name="Shape 35"/>
           <p:cNvSpPr/>
           <p:nvPr/>
         </p:nvSpPr>
@@ -2145,7 +2129,7 @@
       </p:sp>
       <p:sp>
         <p:nvSpPr>
-          <p:cNvPr id="39" name="Shape 37"/>
+          <p:cNvPr id="39" name="Shape 36"/>
           <p:cNvSpPr/>
           <p:nvPr/>
         </p:nvSpPr>
@@ -2170,7 +2154,7 @@
       </p:sp>
       <p:sp>
         <p:nvSpPr>
-          <p:cNvPr id="40" name="Shape 38"/>
+          <p:cNvPr id="40" name="Shape 37"/>
           <p:cNvSpPr/>
           <p:nvPr/>
         </p:nvSpPr>
@@ -2195,7 +2179,7 @@
       </p:sp>
       <p:sp>
         <p:nvSpPr>
-          <p:cNvPr id="41" name="Text 39"/>
+          <p:cNvPr id="41" name="Text 38"/>
           <p:cNvSpPr/>
           <p:nvPr/>
         </p:nvSpPr>
@@ -2234,7 +2218,7 @@
       </p:sp>
       <p:sp>
         <p:nvSpPr>
-          <p:cNvPr id="42" name="Text 40"/>
+          <p:cNvPr id="42" name="Text 39"/>
           <p:cNvSpPr/>
           <p:nvPr/>
         </p:nvSpPr>
@@ -2273,7 +2257,7 @@
       </p:sp>
       <p:sp>
         <p:nvSpPr>
-          <p:cNvPr id="43" name="Text 41"/>
+          <p:cNvPr id="43" name="Text 40"/>
           <p:cNvSpPr/>
           <p:nvPr/>
         </p:nvSpPr>
@@ -2312,7 +2296,7 @@
       </p:sp>
       <p:sp>
         <p:nvSpPr>
-          <p:cNvPr id="44" name="Shape 42"/>
+          <p:cNvPr id="44" name="Shape 41"/>
           <p:cNvSpPr/>
           <p:nvPr/>
         </p:nvSpPr>
@@ -2344,7 +2328,7 @@
       </p:sp>
       <p:sp>
         <p:nvSpPr>
-          <p:cNvPr id="45" name="Shape 43"/>
+          <p:cNvPr id="45" name="Shape 42"/>
           <p:cNvSpPr/>
           <p:nvPr/>
         </p:nvSpPr>
@@ -2369,7 +2353,7 @@
       </p:sp>
       <p:sp>
         <p:nvSpPr>
-          <p:cNvPr id="46" name="Shape 44"/>
+          <p:cNvPr id="46" name="Shape 43"/>
           <p:cNvSpPr/>
           <p:nvPr/>
         </p:nvSpPr>
@@ -2394,7 +2378,7 @@
       </p:sp>
       <p:sp>
         <p:nvSpPr>
-          <p:cNvPr id="47" name="Text 45"/>
+          <p:cNvPr id="47" name="Text 44"/>
           <p:cNvSpPr/>
           <p:nvPr/>
         </p:nvSpPr>
@@ -2433,7 +2417,7 @@
       </p:sp>
       <p:sp>
         <p:nvSpPr>
-          <p:cNvPr id="48" name="Text 46"/>
+          <p:cNvPr id="48" name="Text 45"/>
           <p:cNvSpPr/>
           <p:nvPr/>
         </p:nvSpPr>
@@ -2472,7 +2456,7 @@
       </p:sp>
       <p:sp>
         <p:nvSpPr>
-          <p:cNvPr id="49" name="Text 47"/>
+          <p:cNvPr id="49" name="Text 46"/>
           <p:cNvSpPr/>
           <p:nvPr/>
         </p:nvSpPr>
@@ -2511,7 +2495,7 @@
       </p:sp>
       <p:sp>
         <p:nvSpPr>
-          <p:cNvPr id="50" name="Text 48"/>
+          <p:cNvPr id="50" name="Text 47"/>
           <p:cNvSpPr/>
           <p:nvPr/>
         </p:nvSpPr>
@@ -2550,7 +2534,7 @@
       </p:sp>
       <p:sp>
         <p:nvSpPr>
-          <p:cNvPr id="51" name="Text 49"/>
+          <p:cNvPr id="51" name="Text 48"/>
           <p:cNvSpPr/>
           <p:nvPr/>
         </p:nvSpPr>
@@ -2603,7 +2587,7 @@
       </p:sp>
       <p:sp>
         <p:nvSpPr>
-          <p:cNvPr id="52" name="Text 50"/>
+          <p:cNvPr id="52" name="Text 49"/>
           <p:cNvSpPr/>
           <p:nvPr/>
         </p:nvSpPr>
@@ -2656,7 +2640,7 @@
       </p:sp>
       <p:sp>
         <p:nvSpPr>
-          <p:cNvPr id="53" name="Shape 51"/>
+          <p:cNvPr id="53" name="Shape 50"/>
           <p:cNvSpPr/>
           <p:nvPr/>
         </p:nvSpPr>
@@ -2681,7 +2665,7 @@
       </p:sp>
       <p:sp>
         <p:nvSpPr>
-          <p:cNvPr id="54" name="Shape 52"/>
+          <p:cNvPr id="54" name="Shape 51"/>
           <p:cNvSpPr/>
           <p:nvPr/>
         </p:nvSpPr>
@@ -2706,7 +2690,7 @@
       </p:sp>
       <p:sp>
         <p:nvSpPr>
-          <p:cNvPr id="55" name="Text 53"/>
+          <p:cNvPr id="55" name="Text 52"/>
           <p:cNvSpPr/>
           <p:nvPr/>
         </p:nvSpPr>
@@ -2745,7 +2729,7 @@
       </p:sp>
       <p:sp>
         <p:nvSpPr>
-          <p:cNvPr id="56" name="Text 54"/>
+          <p:cNvPr id="56" name="Text 53"/>
           <p:cNvSpPr/>
           <p:nvPr/>
         </p:nvSpPr>
@@ -2784,7 +2768,7 @@
       </p:sp>
       <p:sp>
         <p:nvSpPr>
-          <p:cNvPr id="57" name="Text 55"/>
+          <p:cNvPr id="57" name="Text 54"/>
           <p:cNvSpPr/>
           <p:nvPr/>
         </p:nvSpPr>
@@ -2823,7 +2807,7 @@
       </p:sp>
       <p:sp>
         <p:nvSpPr>
-          <p:cNvPr id="58" name="Text 56"/>
+          <p:cNvPr id="58" name="Text 55"/>
           <p:cNvSpPr/>
           <p:nvPr/>
         </p:nvSpPr>
@@ -2862,7 +2846,7 @@
       </p:sp>
       <p:sp>
         <p:nvSpPr>
-          <p:cNvPr id="59" name="Shape 57"/>
+          <p:cNvPr id="59" name="Shape 56"/>
           <p:cNvSpPr/>
           <p:nvPr/>
         </p:nvSpPr>
@@ -2887,7 +2871,7 @@
       </p:sp>
       <p:sp>
         <p:nvSpPr>
-          <p:cNvPr id="60" name="Text 58"/>
+          <p:cNvPr id="60" name="Text 57"/>
           <p:cNvSpPr/>
           <p:nvPr/>
         </p:nvSpPr>
@@ -2926,14 +2910,14 @@
       </p:sp>
       <p:pic>
         <p:nvPicPr>
-          <p:cNvPr id="61" name="Image 0" descr="whatsapp.png">    </p:cNvPr>
+          <p:cNvPr id="61" name="Image 1" descr="whatsapp.png">    </p:cNvPr>
           <p:cNvPicPr>
             <a:picLocks noChangeAspect="1"/>
           </p:cNvPicPr>
           <p:nvPr/>
         </p:nvPicPr>
         <p:blipFill>
-          <a:blip r:embed="rId1"/>
+          <a:blip r:embed="rId2"/>
           <a:stretch>
             <a:fillRect/>
           </a:stretch>
@@ -2950,7 +2934,7 @@
       </p:pic>
       <p:sp>
         <p:nvSpPr>
-          <p:cNvPr id="62" name="Text 59"/>
+          <p:cNvPr id="62" name="Text 58"/>
           <p:cNvSpPr/>
           <p:nvPr/>
         </p:nvSpPr>
@@ -2989,7 +2973,7 @@
       </p:sp>
       <p:sp>
         <p:nvSpPr>
-          <p:cNvPr id="63" name="Text 60"/>
+          <p:cNvPr id="63" name="Text 59"/>
           <p:cNvSpPr/>
           <p:nvPr/>
         </p:nvSpPr>
@@ -3028,7 +3012,7 @@
       </p:sp>
       <p:sp>
         <p:nvSpPr>
-          <p:cNvPr id="64" name="Shape 61"/>
+          <p:cNvPr id="64" name="Shape 60"/>
           <p:cNvSpPr/>
           <p:nvPr/>
         </p:nvSpPr>
@@ -3053,7 +3037,7 @@
       </p:sp>
       <p:sp>
         <p:nvSpPr>
-          <p:cNvPr id="65" name="Shape 62"/>
+          <p:cNvPr id="65" name="Shape 61"/>
           <p:cNvSpPr/>
           <p:nvPr/>
         </p:nvSpPr>

</xml_diff>

<commit_message>
Flyers: spell out ECFMG application + full TA attribution
- 'End-to-end mentorship' card body now reads 'Guidance through
  the ECFMG application, CV, personal statement, interview prep,
  and the residency match.'
- TA line under credentials expanded to 'Teaching Assistant |
  Epidemiology & Biostatistics, Duke Global Health Institute'

Co-Authored-By: Claude Opus 4.7 (1M context) <noreply@anthropic.com>
</commit_message>
<xml_diff>
--- a/outputs/flyers/USMLE_Step1_Flyer.pptx
+++ b/outputs/flyers/USMLE_Step1_Flyer.pptx
@@ -1374,7 +1374,7 @@
               <a:buNone/>
             </a:pPr>
             <a:r>
-              <a:rPr lang="en-US" sz="1100" i="1" dirty="0">
+              <a:rPr lang="en-US" sz="1050" i="1" dirty="0">
                 <a:solidFill>
                   <a:srgbClr val="075985"/>
                 </a:solidFill>
@@ -1382,9 +1382,9 @@
                 <a:ea typeface="Calibri" pitchFamily="34" charset="-122"/>
                 <a:cs typeface="Calibri" pitchFamily="34" charset="-120"/>
               </a:rPr>
-              <a:t>Epidemiology &amp; biostatistics teaching assistant</a:t>
-            </a:r>
-            <a:endParaRPr lang="en-US" sz="1100" dirty="0"/>
+              <a:t>Teaching Assistant  |  Epidemiology &amp; Biostatistics, Duke Global Health Institute</a:t>
+            </a:r>
+            <a:endParaRPr lang="en-US" sz="1050" dirty="0"/>
           </a:p>
         </p:txBody>
       </p:sp>
@@ -2487,7 +2487,7 @@
                 <a:ea typeface="Calibri" pitchFamily="34" charset="-122"/>
                 <a:cs typeface="Calibri" pitchFamily="34" charset="-120"/>
               </a:rPr>
-              <a:t>Guidance through ECFMG, CV, personal statement, interview prep, and residency application.</a:t>
+              <a:t>Guidance through the ECFMG application, CV, personal statement, interview prep, and the residency match.</a:t>
             </a:r>
             <a:endParaRPr lang="en-US" sz="1150" dirty="0"/>
           </a:p>

</xml_diff>

<commit_message>
Flyers: restructure CTA into 'contact -> dashboard access' narrative
Bottom section rewritten to a clearer two-step flow:
1. 'TO SIGN UP, CONTACT ALLAN' header
2. Email + WhatsApp contact row, each with a real brand-coloured
   icon (envelope generated from SVG to match track palette;
   blue on Step 1, amber on Step 2)
3. 'Once enrolled, you'll be granted access to all course
   materials at:' explainer
4. bakesiga.github.io/usmle-dashboard URL

Drops the standalone 'SIGN UP' label and 'Limited cohort'
italic line; the new copy makes both points implicitly.

Co-Authored-By: Claude Opus 4.7 (1M context) <noreply@anthropic.com>
</commit_message>
<xml_diff>
--- a/outputs/flyers/USMLE_Step1_Flyer.pptx
+++ b/outputs/flyers/USMLE_Step1_Flyer.pptx
@@ -2774,7 +2774,7 @@
         </p:nvSpPr>
         <p:spPr>
           <a:xfrm>
-            <a:off x="457200" y="8732520"/>
+            <a:off x="457200" y="8686800"/>
             <a:ext cx="6858000" cy="201168"/>
           </a:xfrm>
           <a:prstGeom prst="rect">
@@ -2799,118 +2799,15 @@
                 <a:ea typeface="Calibri" pitchFamily="34" charset="-122"/>
                 <a:cs typeface="Calibri" pitchFamily="34" charset="-120"/>
               </a:rPr>
-              <a:t>SIGN UP</a:t>
+              <a:t>TO SIGN UP, CONTACT ALLAN</a:t>
             </a:r>
             <a:endParaRPr lang="en-US" sz="1100" dirty="0"/>
-          </a:p>
-        </p:txBody>
-      </p:sp>
-      <p:sp>
-        <p:nvSpPr>
-          <p:cNvPr id="58" name="Text 55"/>
-          <p:cNvSpPr/>
-          <p:nvPr/>
-        </p:nvSpPr>
-        <p:spPr>
-          <a:xfrm>
-            <a:off x="457200" y="8915400"/>
-            <a:ext cx="6858000" cy="402336"/>
-          </a:xfrm>
-          <a:prstGeom prst="rect">
-            <a:avLst/>
-          </a:prstGeom>
-          <a:noFill/>
-          <a:ln/>
-        </p:spPr>
-        <p:txBody>
-          <a:bodyPr wrap="square" lIns="0" tIns="0" rIns="0" bIns="0" rtlCol="0" anchor="ctr"/>
-          <a:lstStyle/>
-          <a:p>
-            <a:pPr indent="0" marL="0">
-              <a:buNone/>
-            </a:pPr>
-            <a:r>
-              <a:rPr lang="en-US" sz="2400" b="1" dirty="0">
-                <a:solidFill>
-                  <a:srgbClr val="0284C7"/>
-                </a:solidFill>
-                <a:latin typeface="Arial Black" pitchFamily="34" charset="0"/>
-                <a:ea typeface="Arial Black" pitchFamily="34" charset="-122"/>
-                <a:cs typeface="Arial Black" pitchFamily="34" charset="-120"/>
-              </a:rPr>
-              <a:t>bakesiga.github.io/usmle-dashboard</a:t>
-            </a:r>
-            <a:endParaRPr lang="en-US" sz="2400" dirty="0"/>
-          </a:p>
-        </p:txBody>
-      </p:sp>
-      <p:sp>
-        <p:nvSpPr>
-          <p:cNvPr id="59" name="Shape 56"/>
-          <p:cNvSpPr/>
-          <p:nvPr/>
-        </p:nvSpPr>
-        <p:spPr>
-          <a:xfrm>
-            <a:off x="457200" y="9427464"/>
-            <a:ext cx="164592" cy="164592"/>
-          </a:xfrm>
-          <a:prstGeom prst="ellipse">
-            <a:avLst/>
-          </a:prstGeom>
-          <a:solidFill>
-            <a:srgbClr val="0284C7"/>
-          </a:solidFill>
-          <a:ln w="12700">
-            <a:solidFill>
-              <a:srgbClr val="0284C7"/>
-            </a:solidFill>
-            <a:prstDash val="solid"/>
-          </a:ln>
-        </p:spPr>
-      </p:sp>
-      <p:sp>
-        <p:nvSpPr>
-          <p:cNvPr id="60" name="Text 57"/>
-          <p:cNvSpPr/>
-          <p:nvPr/>
-        </p:nvSpPr>
-        <p:spPr>
-          <a:xfrm>
-            <a:off x="694944" y="9372600"/>
-            <a:ext cx="3099816" cy="274320"/>
-          </a:xfrm>
-          <a:prstGeom prst="rect">
-            <a:avLst/>
-          </a:prstGeom>
-          <a:noFill/>
-          <a:ln/>
-        </p:spPr>
-        <p:txBody>
-          <a:bodyPr wrap="square" lIns="0" tIns="0" rIns="0" bIns="0" rtlCol="0" anchor="ctr"/>
-          <a:lstStyle/>
-          <a:p>
-            <a:pPr indent="0" marL="0">
-              <a:buNone/>
-            </a:pPr>
-            <a:r>
-              <a:rPr lang="en-US" sz="1250" b="1" dirty="0">
-                <a:solidFill>
-                  <a:srgbClr val="0C2A3D"/>
-                </a:solidFill>
-                <a:latin typeface="Calibri" pitchFamily="34" charset="0"/>
-                <a:ea typeface="Calibri" pitchFamily="34" charset="-122"/>
-                <a:cs typeface="Calibri" pitchFamily="34" charset="-120"/>
-              </a:rPr>
-              <a:t>allanbakesiga@gmail.com</a:t>
-            </a:r>
-            <a:endParaRPr lang="en-US" sz="1250" dirty="0"/>
           </a:p>
         </p:txBody>
       </p:sp>
       <p:pic>
         <p:nvPicPr>
-          <p:cNvPr id="61" name="Image 1" descr="whatsapp.png">    </p:cNvPr>
+          <p:cNvPr id="58" name="Image 1" descr="email-blue.png">    </p:cNvPr>
           <p:cNvPicPr>
             <a:picLocks noChangeAspect="1"/>
           </p:cNvPicPr>
@@ -2924,7 +2821,7 @@
         </p:blipFill>
         <p:spPr>
           <a:xfrm>
-            <a:off x="3977640" y="9390888"/>
+            <a:off x="457200" y="8942832"/>
             <a:ext cx="237744" cy="237744"/>
           </a:xfrm>
           <a:prstGeom prst="rect">
@@ -2934,14 +2831,14 @@
       </p:pic>
       <p:sp>
         <p:nvSpPr>
-          <p:cNvPr id="62" name="Text 58"/>
-          <p:cNvSpPr/>
-          <p:nvPr/>
-        </p:nvSpPr>
-        <p:spPr>
-          <a:xfrm>
-            <a:off x="4288536" y="9372600"/>
-            <a:ext cx="2843784" cy="274320"/>
+          <p:cNvPr id="59" name="Text 55"/>
+          <p:cNvSpPr/>
+          <p:nvPr/>
+        </p:nvSpPr>
+        <p:spPr>
+          <a:xfrm>
+            <a:off x="768096" y="8906256"/>
+            <a:ext cx="3026664" cy="292608"/>
           </a:xfrm>
           <a:prstGeom prst="rect">
             <a:avLst/>
@@ -2957,7 +2854,7 @@
               <a:buNone/>
             </a:pPr>
             <a:r>
-              <a:rPr lang="en-US" sz="1250" b="1" dirty="0">
+              <a:rPr lang="en-US" sz="1300" b="1" dirty="0">
                 <a:solidFill>
                   <a:srgbClr val="0C2A3D"/>
                 </a:solidFill>
@@ -2965,54 +2862,156 @@
                 <a:ea typeface="Calibri" pitchFamily="34" charset="-122"/>
                 <a:cs typeface="Calibri" pitchFamily="34" charset="-120"/>
               </a:rPr>
-              <a:t>WhatsApp · +256 705 571 443</a:t>
-            </a:r>
-            <a:endParaRPr lang="en-US" sz="1250" dirty="0"/>
-          </a:p>
-        </p:txBody>
-      </p:sp>
-      <p:sp>
-        <p:nvSpPr>
-          <p:cNvPr id="63" name="Text 59"/>
-          <p:cNvSpPr/>
-          <p:nvPr/>
-        </p:nvSpPr>
-        <p:spPr>
-          <a:xfrm>
-            <a:off x="457200" y="9665208"/>
-            <a:ext cx="6858000" cy="164592"/>
-          </a:xfrm>
-          <a:prstGeom prst="rect">
-            <a:avLst/>
-          </a:prstGeom>
-          <a:noFill/>
-          <a:ln/>
-        </p:spPr>
-        <p:txBody>
-          <a:bodyPr wrap="square" lIns="0" tIns="0" rIns="0" bIns="0" rtlCol="0" anchor="ctr"/>
-          <a:lstStyle/>
-          <a:p>
-            <a:pPr algn="l" indent="0" marL="0">
-              <a:buNone/>
-            </a:pPr>
-            <a:r>
-              <a:rPr lang="en-US" sz="950" i="1" dirty="0">
-                <a:solidFill>
-                  <a:srgbClr val="6B87A3"/>
+              <a:t>allanbakesiga@gmail.com</a:t>
+            </a:r>
+            <a:endParaRPr lang="en-US" sz="1300" dirty="0"/>
+          </a:p>
+        </p:txBody>
+      </p:sp>
+      <p:pic>
+        <p:nvPicPr>
+          <p:cNvPr id="60" name="Image 2" descr="whatsapp.png">    </p:cNvPr>
+          <p:cNvPicPr>
+            <a:picLocks noChangeAspect="1"/>
+          </p:cNvPicPr>
+          <p:nvPr/>
+        </p:nvPicPr>
+        <p:blipFill>
+          <a:blip r:embed="rId3"/>
+          <a:stretch>
+            <a:fillRect/>
+          </a:stretch>
+        </p:blipFill>
+        <p:spPr>
+          <a:xfrm>
+            <a:off x="3977640" y="8924544"/>
+            <a:ext cx="256032" cy="256032"/>
+          </a:xfrm>
+          <a:prstGeom prst="rect">
+            <a:avLst/>
+          </a:prstGeom>
+        </p:spPr>
+      </p:pic>
+      <p:sp>
+        <p:nvSpPr>
+          <p:cNvPr id="61" name="Text 56"/>
+          <p:cNvSpPr/>
+          <p:nvPr/>
+        </p:nvSpPr>
+        <p:spPr>
+          <a:xfrm>
+            <a:off x="4288536" y="8906256"/>
+            <a:ext cx="2843784" cy="292608"/>
+          </a:xfrm>
+          <a:prstGeom prst="rect">
+            <a:avLst/>
+          </a:prstGeom>
+          <a:noFill/>
+          <a:ln/>
+        </p:spPr>
+        <p:txBody>
+          <a:bodyPr wrap="square" lIns="0" tIns="0" rIns="0" bIns="0" rtlCol="0" anchor="ctr"/>
+          <a:lstStyle/>
+          <a:p>
+            <a:pPr indent="0" marL="0">
+              <a:buNone/>
+            </a:pPr>
+            <a:r>
+              <a:rPr lang="en-US" sz="1300" b="1" dirty="0">
+                <a:solidFill>
+                  <a:srgbClr val="0C2A3D"/>
                 </a:solidFill>
                 <a:latin typeface="Calibri" pitchFamily="34" charset="0"/>
                 <a:ea typeface="Calibri" pitchFamily="34" charset="-122"/>
                 <a:cs typeface="Calibri" pitchFamily="34" charset="-120"/>
               </a:rPr>
-              <a:t>Limited cohort · Sign in with the Gmail Allan adds you under</a:t>
-            </a:r>
-            <a:endParaRPr lang="en-US" sz="950" dirty="0"/>
-          </a:p>
-        </p:txBody>
-      </p:sp>
-      <p:sp>
-        <p:nvSpPr>
-          <p:cNvPr id="64" name="Shape 60"/>
+              <a:t>+256 705 571 443</a:t>
+            </a:r>
+            <a:endParaRPr lang="en-US" sz="1300" dirty="0"/>
+          </a:p>
+        </p:txBody>
+      </p:sp>
+      <p:sp>
+        <p:nvSpPr>
+          <p:cNvPr id="62" name="Text 57"/>
+          <p:cNvSpPr/>
+          <p:nvPr/>
+        </p:nvSpPr>
+        <p:spPr>
+          <a:xfrm>
+            <a:off x="457200" y="9253728"/>
+            <a:ext cx="6858000" cy="201168"/>
+          </a:xfrm>
+          <a:prstGeom prst="rect">
+            <a:avLst/>
+          </a:prstGeom>
+          <a:noFill/>
+          <a:ln/>
+        </p:spPr>
+        <p:txBody>
+          <a:bodyPr wrap="square" lIns="0" tIns="0" rIns="0" bIns="0" rtlCol="0" anchor="ctr"/>
+          <a:lstStyle/>
+          <a:p>
+            <a:pPr indent="0" marL="0">
+              <a:buNone/>
+            </a:pPr>
+            <a:r>
+              <a:rPr lang="en-US" sz="1050" i="1" dirty="0">
+                <a:solidFill>
+                  <a:srgbClr val="345671"/>
+                </a:solidFill>
+                <a:latin typeface="Calibri" pitchFamily="34" charset="0"/>
+                <a:ea typeface="Calibri" pitchFamily="34" charset="-122"/>
+                <a:cs typeface="Calibri" pitchFamily="34" charset="-120"/>
+              </a:rPr>
+              <a:t>Once enrolled, you'll be granted access to all course materials at:</a:t>
+            </a:r>
+            <a:endParaRPr lang="en-US" sz="1050" dirty="0"/>
+          </a:p>
+        </p:txBody>
+      </p:sp>
+      <p:sp>
+        <p:nvSpPr>
+          <p:cNvPr id="63" name="Text 58"/>
+          <p:cNvSpPr/>
+          <p:nvPr/>
+        </p:nvSpPr>
+        <p:spPr>
+          <a:xfrm>
+            <a:off x="457200" y="9454896"/>
+            <a:ext cx="6858000" cy="402336"/>
+          </a:xfrm>
+          <a:prstGeom prst="rect">
+            <a:avLst/>
+          </a:prstGeom>
+          <a:noFill/>
+          <a:ln/>
+        </p:spPr>
+        <p:txBody>
+          <a:bodyPr wrap="square" lIns="0" tIns="0" rIns="0" bIns="0" rtlCol="0" anchor="ctr"/>
+          <a:lstStyle/>
+          <a:p>
+            <a:pPr indent="0" marL="0">
+              <a:buNone/>
+            </a:pPr>
+            <a:r>
+              <a:rPr lang="en-US" sz="2200" b="1" dirty="0">
+                <a:solidFill>
+                  <a:srgbClr val="0284C7"/>
+                </a:solidFill>
+                <a:latin typeface="Arial Black" pitchFamily="34" charset="0"/>
+                <a:ea typeface="Arial Black" pitchFamily="34" charset="-122"/>
+                <a:cs typeface="Arial Black" pitchFamily="34" charset="-120"/>
+              </a:rPr>
+              <a:t>bakesiga.github.io/usmle-dashboard</a:t>
+            </a:r>
+            <a:endParaRPr lang="en-US" sz="2200" dirty="0"/>
+          </a:p>
+        </p:txBody>
+      </p:sp>
+      <p:sp>
+        <p:nvSpPr>
+          <p:cNvPr id="64" name="Shape 59"/>
           <p:cNvSpPr/>
           <p:nvPr/>
         </p:nvSpPr>
@@ -3037,7 +3036,7 @@
       </p:sp>
       <p:sp>
         <p:nvSpPr>
-          <p:cNvPr id="65" name="Shape 61"/>
+          <p:cNvPr id="65" name="Shape 60"/>
           <p:cNvSpPr/>
           <p:nvPr/>
         </p:nvSpPr>

</xml_diff>

<commit_message>
Flyers: add US call number with phone icon
Contact row now has 3 methods side-by-side:
  envelope  allanbakesiga@gmail.com
  whatsapp  +256 705 571 443
  phone     +1 984 710 2902

Phone icon generated as a brand-coloured SVG (blue / amber)
to match the existing email + WhatsApp icon treatment.
</commit_message>
<xml_diff>
--- a/outputs/flyers/USMLE_Step1_Flyer.pptx
+++ b/outputs/flyers/USMLE_Step1_Flyer.pptx
@@ -2837,8 +2837,8 @@
         </p:nvSpPr>
         <p:spPr>
           <a:xfrm>
-            <a:off x="768096" y="8906256"/>
-            <a:ext cx="3026664" cy="292608"/>
+            <a:off x="749808" y="8906256"/>
+            <a:ext cx="1883664" cy="292608"/>
           </a:xfrm>
           <a:prstGeom prst="rect">
             <a:avLst/>
@@ -2854,7 +2854,7 @@
               <a:buNone/>
             </a:pPr>
             <a:r>
-              <a:rPr lang="en-US" sz="1300" b="1" dirty="0">
+              <a:rPr lang="en-US" sz="1200" b="1" dirty="0">
                 <a:solidFill>
                   <a:srgbClr val="0C2A3D"/>
                 </a:solidFill>
@@ -2864,7 +2864,7 @@
               </a:rPr>
               <a:t>allanbakesiga@gmail.com</a:t>
             </a:r>
-            <a:endParaRPr lang="en-US" sz="1300" dirty="0"/>
+            <a:endParaRPr lang="en-US" sz="1200" dirty="0"/>
           </a:p>
         </p:txBody>
       </p:sp>
@@ -2884,7 +2884,7 @@
         </p:blipFill>
         <p:spPr>
           <a:xfrm>
-            <a:off x="3977640" y="8924544"/>
+            <a:off x="2798064" y="8924544"/>
             <a:ext cx="256032" cy="256032"/>
           </a:xfrm>
           <a:prstGeom prst="rect">
@@ -2900,8 +2900,8 @@
         </p:nvSpPr>
         <p:spPr>
           <a:xfrm>
-            <a:off x="4288536" y="8906256"/>
-            <a:ext cx="2843784" cy="292608"/>
+            <a:off x="3108960" y="8906256"/>
+            <a:ext cx="1865376" cy="292608"/>
           </a:xfrm>
           <a:prstGeom prst="rect">
             <a:avLst/>
@@ -2917,7 +2917,7 @@
               <a:buNone/>
             </a:pPr>
             <a:r>
-              <a:rPr lang="en-US" sz="1300" b="1" dirty="0">
+              <a:rPr lang="en-US" sz="1200" b="1" dirty="0">
                 <a:solidFill>
                   <a:srgbClr val="0C2A3D"/>
                 </a:solidFill>
@@ -2927,20 +2927,44 @@
               </a:rPr>
               <a:t>+256 705 571 443</a:t>
             </a:r>
-            <a:endParaRPr lang="en-US" sz="1300" dirty="0"/>
-          </a:p>
-        </p:txBody>
-      </p:sp>
-      <p:sp>
-        <p:nvSpPr>
-          <p:cNvPr id="62" name="Text 57"/>
-          <p:cNvSpPr/>
-          <p:nvPr/>
-        </p:nvSpPr>
-        <p:spPr>
-          <a:xfrm>
-            <a:off x="457200" y="9253728"/>
-            <a:ext cx="6858000" cy="201168"/>
+            <a:endParaRPr lang="en-US" sz="1200" dirty="0"/>
+          </a:p>
+        </p:txBody>
+      </p:sp>
+      <p:pic>
+        <p:nvPicPr>
+          <p:cNvPr id="62" name="Image 3" descr="phone-blue.png">    </p:cNvPr>
+          <p:cNvPicPr>
+            <a:picLocks noChangeAspect="1"/>
+          </p:cNvPicPr>
+          <p:nvPr/>
+        </p:nvPicPr>
+        <p:blipFill>
+          <a:blip r:embed="rId4"/>
+          <a:stretch>
+            <a:fillRect/>
+          </a:stretch>
+        </p:blipFill>
+        <p:spPr>
+          <a:xfrm>
+            <a:off x="5138928" y="8942832"/>
+            <a:ext cx="237744" cy="237744"/>
+          </a:xfrm>
+          <a:prstGeom prst="rect">
+            <a:avLst/>
+          </a:prstGeom>
+        </p:spPr>
+      </p:pic>
+      <p:sp>
+        <p:nvSpPr>
+          <p:cNvPr id="63" name="Text 57"/>
+          <p:cNvSpPr/>
+          <p:nvPr/>
+        </p:nvSpPr>
+        <p:spPr>
+          <a:xfrm>
+            <a:off x="5431536" y="8906256"/>
+            <a:ext cx="1883664" cy="292608"/>
           </a:xfrm>
           <a:prstGeom prst="rect">
             <a:avLst/>
@@ -2956,14 +2980,53 @@
               <a:buNone/>
             </a:pPr>
             <a:r>
-              <a:rPr lang="en-US" sz="1050" i="1" dirty="0">
-                <a:solidFill>
-                  <a:srgbClr val="345671"/>
+              <a:rPr lang="en-US" sz="1200" b="1" dirty="0">
+                <a:solidFill>
+                  <a:srgbClr val="0C2A3D"/>
                 </a:solidFill>
                 <a:latin typeface="Calibri" pitchFamily="34" charset="0"/>
                 <a:ea typeface="Calibri" pitchFamily="34" charset="-122"/>
                 <a:cs typeface="Calibri" pitchFamily="34" charset="-120"/>
               </a:rPr>
+              <a:t>+1 984 710 2902</a:t>
+            </a:r>
+            <a:endParaRPr lang="en-US" sz="1200" dirty="0"/>
+          </a:p>
+        </p:txBody>
+      </p:sp>
+      <p:sp>
+        <p:nvSpPr>
+          <p:cNvPr id="64" name="Text 58"/>
+          <p:cNvSpPr/>
+          <p:nvPr/>
+        </p:nvSpPr>
+        <p:spPr>
+          <a:xfrm>
+            <a:off x="457200" y="9253728"/>
+            <a:ext cx="6858000" cy="201168"/>
+          </a:xfrm>
+          <a:prstGeom prst="rect">
+            <a:avLst/>
+          </a:prstGeom>
+          <a:noFill/>
+          <a:ln/>
+        </p:spPr>
+        <p:txBody>
+          <a:bodyPr wrap="square" lIns="0" tIns="0" rIns="0" bIns="0" rtlCol="0" anchor="ctr"/>
+          <a:lstStyle/>
+          <a:p>
+            <a:pPr indent="0" marL="0">
+              <a:buNone/>
+            </a:pPr>
+            <a:r>
+              <a:rPr lang="en-US" sz="1050" i="1" dirty="0">
+                <a:solidFill>
+                  <a:srgbClr val="345671"/>
+                </a:solidFill>
+                <a:latin typeface="Calibri" pitchFamily="34" charset="0"/>
+                <a:ea typeface="Calibri" pitchFamily="34" charset="-122"/>
+                <a:cs typeface="Calibri" pitchFamily="34" charset="-120"/>
+              </a:rPr>
               <a:t>Once enrolled, you'll be granted access to all course materials at:</a:t>
             </a:r>
             <a:endParaRPr lang="en-US" sz="1050" dirty="0"/>
@@ -2972,7 +3035,7 @@
       </p:sp>
       <p:sp>
         <p:nvSpPr>
-          <p:cNvPr id="63" name="Text 58"/>
+          <p:cNvPr id="65" name="Text 59"/>
           <p:cNvSpPr/>
           <p:nvPr/>
         </p:nvSpPr>
@@ -3011,7 +3074,7 @@
       </p:sp>
       <p:sp>
         <p:nvSpPr>
-          <p:cNvPr id="64" name="Shape 59"/>
+          <p:cNvPr id="66" name="Shape 60"/>
           <p:cNvSpPr/>
           <p:nvPr/>
         </p:nvSpPr>
@@ -3036,7 +3099,7 @@
       </p:sp>
       <p:sp>
         <p:nvSpPr>
-          <p:cNvPr id="65" name="Shape 60"/>
+          <p:cNvPr id="67" name="Shape 61"/>
           <p:cNvSpPr/>
           <p:nvPr/>
         </p:nvSpPr>

</xml_diff>

<commit_message>
Flyers: centre 'TO SIGN UP' label + balance contact row
The 'TO SIGN UP, CONTACT ALLAN' header is now centre-aligned,
and each of the three contacts (email, WhatsApp, phone) has its
icon+text pair centred within its column rather than glued to the
left edge — gives the row a more balanced, intentional look.
</commit_message>
<xml_diff>
--- a/outputs/flyers/USMLE_Step1_Flyer.pptx
+++ b/outputs/flyers/USMLE_Step1_Flyer.pptx
@@ -2787,7 +2787,7 @@
           <a:bodyPr wrap="square" lIns="0" tIns="0" rIns="0" bIns="0" rtlCol="0" anchor="ctr"/>
           <a:lstStyle/>
           <a:p>
-            <a:pPr indent="0" marL="0">
+            <a:pPr algn="ctr" indent="0" marL="0">
               <a:buNone/>
             </a:pPr>
             <a:r>
@@ -2821,7 +2821,7 @@
         </p:blipFill>
         <p:spPr>
           <a:xfrm>
-            <a:off x="457200" y="8942832"/>
+            <a:off x="457200" y="8933688"/>
             <a:ext cx="237744" cy="237744"/>
           </a:xfrm>
           <a:prstGeom prst="rect">
@@ -2837,20 +2837,20 @@
         </p:nvSpPr>
         <p:spPr>
           <a:xfrm>
-            <a:off x="749808" y="8906256"/>
-            <a:ext cx="1883664" cy="292608"/>
-          </a:xfrm>
-          <a:prstGeom prst="rect">
-            <a:avLst/>
-          </a:prstGeom>
-          <a:noFill/>
-          <a:ln/>
-        </p:spPr>
-        <p:txBody>
-          <a:bodyPr wrap="square" lIns="0" tIns="0" rIns="0" bIns="0" rtlCol="0" anchor="ctr"/>
-          <a:lstStyle/>
-          <a:p>
-            <a:pPr indent="0" marL="0">
+            <a:off x="768096" y="8906256"/>
+            <a:ext cx="2026310" cy="292608"/>
+          </a:xfrm>
+          <a:prstGeom prst="rect">
+            <a:avLst/>
+          </a:prstGeom>
+          <a:noFill/>
+          <a:ln/>
+        </p:spPr>
+        <p:txBody>
+          <a:bodyPr wrap="square" lIns="0" tIns="0" rIns="0" bIns="0" rtlCol="0" anchor="ctr"/>
+          <a:lstStyle/>
+          <a:p>
+            <a:pPr algn="l" indent="0" marL="0">
               <a:buNone/>
             </a:pPr>
             <a:r>
@@ -2884,7 +2884,7 @@
         </p:blipFill>
         <p:spPr>
           <a:xfrm>
-            <a:off x="2798064" y="8924544"/>
+            <a:off x="3048610" y="8924544"/>
             <a:ext cx="256032" cy="256032"/>
           </a:xfrm>
           <a:prstGeom prst="rect">
@@ -2900,20 +2900,20 @@
         </p:nvSpPr>
         <p:spPr>
           <a:xfrm>
-            <a:off x="3108960" y="8906256"/>
-            <a:ext cx="1865376" cy="292608"/>
-          </a:xfrm>
-          <a:prstGeom prst="rect">
-            <a:avLst/>
-          </a:prstGeom>
-          <a:noFill/>
-          <a:ln/>
-        </p:spPr>
-        <p:txBody>
-          <a:bodyPr wrap="square" lIns="0" tIns="0" rIns="0" bIns="0" rtlCol="0" anchor="ctr"/>
-          <a:lstStyle/>
-          <a:p>
-            <a:pPr indent="0" marL="0">
+            <a:off x="3377794" y="8906256"/>
+            <a:ext cx="1437437" cy="292608"/>
+          </a:xfrm>
+          <a:prstGeom prst="rect">
+            <a:avLst/>
+          </a:prstGeom>
+          <a:noFill/>
+          <a:ln/>
+        </p:spPr>
+        <p:txBody>
+          <a:bodyPr wrap="square" lIns="0" tIns="0" rIns="0" bIns="0" rtlCol="0" anchor="ctr"/>
+          <a:lstStyle/>
+          <a:p>
+            <a:pPr algn="l" indent="0" marL="0">
               <a:buNone/>
             </a:pPr>
             <a:r>
@@ -2947,7 +2947,7 @@
         </p:blipFill>
         <p:spPr>
           <a:xfrm>
-            <a:off x="5138928" y="8942832"/>
+            <a:off x="5440680" y="8933688"/>
             <a:ext cx="237744" cy="237744"/>
           </a:xfrm>
           <a:prstGeom prst="rect">
@@ -2963,20 +2963,20 @@
         </p:nvSpPr>
         <p:spPr>
           <a:xfrm>
-            <a:off x="5431536" y="8906256"/>
-            <a:ext cx="1883664" cy="292608"/>
-          </a:xfrm>
-          <a:prstGeom prst="rect">
-            <a:avLst/>
-          </a:prstGeom>
-          <a:noFill/>
-          <a:ln/>
-        </p:spPr>
-        <p:txBody>
-          <a:bodyPr wrap="square" lIns="0" tIns="0" rIns="0" bIns="0" rtlCol="0" anchor="ctr"/>
-          <a:lstStyle/>
-          <a:p>
-            <a:pPr indent="0" marL="0">
+            <a:off x="5751576" y="8906256"/>
+            <a:ext cx="1353312" cy="292608"/>
+          </a:xfrm>
+          <a:prstGeom prst="rect">
+            <a:avLst/>
+          </a:prstGeom>
+          <a:noFill/>
+          <a:ln/>
+        </p:spPr>
+        <p:txBody>
+          <a:bodyPr wrap="square" lIns="0" tIns="0" rIns="0" bIns="0" rtlCol="0" anchor="ctr"/>
+          <a:lstStyle/>
+          <a:p>
+            <a:pPr algn="l" indent="0" marL="0">
               <a:buNone/>
             </a:pPr>
             <a:r>

</xml_diff>

<commit_message>
Flyers: 'Textbook, Qbank & more' card highlights broader resource coverage
Title and body now signal that the prep covers high-yield
resources beyond just one textbook and one Qbank — supplementary
materials are included, with USMLE-style practice questions
running throughout.
</commit_message>
<xml_diff>
--- a/outputs/flyers/USMLE_Step1_Flyer.pptx
+++ b/outputs/flyers/USMLE_Step1_Flyer.pptx
@@ -2249,7 +2249,7 @@
                 <a:ea typeface="Calibri" pitchFamily="34" charset="-122"/>
                 <a:cs typeface="Calibri" pitchFamily="34" charset="-120"/>
               </a:rPr>
-              <a:t>Textbook + Qbank</a:t>
+              <a:t>Textbook, Qbank &amp; more</a:t>
             </a:r>
             <a:endParaRPr lang="en-US" sz="1500" dirty="0"/>
           </a:p>
@@ -2288,7 +2288,7 @@
                 <a:ea typeface="Calibri" pitchFamily="34" charset="-122"/>
                 <a:cs typeface="Calibri" pitchFamily="34" charset="-120"/>
               </a:rPr>
-              <a:t>Full review of the recommended textbook plus USMLE-style questions from the recommended Qbank.</a:t>
+              <a:t>Full review of the high-yield USMLE resources (textbook, Qbank, and curated supplements), with USMLE-style practice questions woven throughout.</a:t>
             </a:r>
             <a:endParaRPr lang="en-US" sz="1150" dirty="0"/>
           </a:p>

</xml_diff>

<commit_message>
Flyers: balance white space between callout and 'TO SIGN UP' on Step 1
The 'TO SIGN UP, CONTACT ALLAN ON:' header was butting up
against the combined-prep callout because Step 1's longer
topics block pushed the callout end (~9.54) past the CTA
cap (9.50). Pulled upper content up by 0.10, slimmed the
callout box from 0.85 to 0.80, and lifted the CTA cap to
9.55 with a tighter URL h. Now ~0.16" of breathing room
between callout and header on Step 1.
</commit_message>
<xml_diff>
--- a/outputs/flyers/USMLE_Step1_Flyer.pptx
+++ b/outputs/flyers/USMLE_Step1_Flyer.pptx
@@ -1206,7 +1206,7 @@
         </p:nvSpPr>
         <p:spPr>
           <a:xfrm>
-            <a:off x="457200" y="1965960"/>
+            <a:off x="457200" y="1874520"/>
             <a:ext cx="6858000" cy="1005840"/>
           </a:xfrm>
           <a:prstGeom prst="rect">
@@ -1231,7 +1231,7 @@
         </p:nvSpPr>
         <p:spPr>
           <a:xfrm>
-            <a:off x="603504" y="2093976"/>
+            <a:off x="603504" y="2002536"/>
             <a:ext cx="786384" cy="786384"/>
           </a:xfrm>
           <a:prstGeom prst="ellipse">
@@ -1263,7 +1263,7 @@
         </p:blipFill>
         <p:spPr>
           <a:xfrm>
-            <a:off x="640080" y="2130552"/>
+            <a:off x="640080" y="2039112"/>
             <a:ext cx="713232" cy="713232"/>
           </a:xfrm>
           <a:prstGeom prst="ellipse">
@@ -1279,7 +1279,7 @@
         </p:nvSpPr>
         <p:spPr>
           <a:xfrm>
-            <a:off x="1508760" y="2057400"/>
+            <a:off x="1508760" y="1965960"/>
             <a:ext cx="5760720" cy="329184"/>
           </a:xfrm>
           <a:prstGeom prst="rect">
@@ -1318,7 +1318,7 @@
         </p:nvSpPr>
         <p:spPr>
           <a:xfrm>
-            <a:off x="1508760" y="2386584"/>
+            <a:off x="1508760" y="2295144"/>
             <a:ext cx="5760720" cy="274320"/>
           </a:xfrm>
           <a:prstGeom prst="rect">
@@ -1357,7 +1357,7 @@
         </p:nvSpPr>
         <p:spPr>
           <a:xfrm>
-            <a:off x="1508760" y="2660904"/>
+            <a:off x="1508760" y="2569464"/>
             <a:ext cx="5760720" cy="256032"/>
           </a:xfrm>
           <a:prstGeom prst="rect">
@@ -1396,7 +1396,7 @@
         </p:nvSpPr>
         <p:spPr>
           <a:xfrm>
-            <a:off x="457200" y="3108960"/>
+            <a:off x="457200" y="3017520"/>
             <a:ext cx="2164080" cy="960120"/>
           </a:xfrm>
           <a:prstGeom prst="rect">
@@ -1421,7 +1421,7 @@
         </p:nvSpPr>
         <p:spPr>
           <a:xfrm>
-            <a:off x="457200" y="3218688"/>
+            <a:off x="457200" y="3127248"/>
             <a:ext cx="2164080" cy="457200"/>
           </a:xfrm>
           <a:prstGeom prst="rect">
@@ -1460,7 +1460,7 @@
         </p:nvSpPr>
         <p:spPr>
           <a:xfrm>
-            <a:off x="457200" y="3675888"/>
+            <a:off x="457200" y="3584448"/>
             <a:ext cx="2164080" cy="320040"/>
           </a:xfrm>
           <a:prstGeom prst="rect">
@@ -1499,7 +1499,7 @@
         </p:nvSpPr>
         <p:spPr>
           <a:xfrm>
-            <a:off x="2804160" y="3108960"/>
+            <a:off x="2804160" y="3017520"/>
             <a:ext cx="2164080" cy="960120"/>
           </a:xfrm>
           <a:prstGeom prst="rect">
@@ -1524,7 +1524,7 @@
         </p:nvSpPr>
         <p:spPr>
           <a:xfrm>
-            <a:off x="2804160" y="3218688"/>
+            <a:off x="2804160" y="3127248"/>
             <a:ext cx="2164080" cy="457200"/>
           </a:xfrm>
           <a:prstGeom prst="rect">
@@ -1563,7 +1563,7 @@
         </p:nvSpPr>
         <p:spPr>
           <a:xfrm>
-            <a:off x="2804160" y="3675888"/>
+            <a:off x="2804160" y="3584448"/>
             <a:ext cx="2164080" cy="320040"/>
           </a:xfrm>
           <a:prstGeom prst="rect">
@@ -1602,7 +1602,7 @@
         </p:nvSpPr>
         <p:spPr>
           <a:xfrm>
-            <a:off x="5151120" y="3108960"/>
+            <a:off x="5151120" y="3017520"/>
             <a:ext cx="2164080" cy="960120"/>
           </a:xfrm>
           <a:prstGeom prst="rect">
@@ -1627,7 +1627,7 @@
         </p:nvSpPr>
         <p:spPr>
           <a:xfrm>
-            <a:off x="5151120" y="3218688"/>
+            <a:off x="5151120" y="3127248"/>
             <a:ext cx="2164080" cy="457200"/>
           </a:xfrm>
           <a:prstGeom prst="rect">
@@ -1666,7 +1666,7 @@
         </p:nvSpPr>
         <p:spPr>
           <a:xfrm>
-            <a:off x="5151120" y="3675888"/>
+            <a:off x="5151120" y="3584448"/>
             <a:ext cx="2164080" cy="320040"/>
           </a:xfrm>
           <a:prstGeom prst="rect">
@@ -1705,7 +1705,7 @@
         </p:nvSpPr>
         <p:spPr>
           <a:xfrm>
-            <a:off x="457200" y="4160520"/>
+            <a:off x="457200" y="4069080"/>
             <a:ext cx="3314700" cy="1097280"/>
           </a:xfrm>
           <a:prstGeom prst="rect">
@@ -1737,7 +1737,7 @@
         </p:nvSpPr>
         <p:spPr>
           <a:xfrm>
-            <a:off x="457200" y="4160520"/>
+            <a:off x="457200" y="4069080"/>
             <a:ext cx="91440" cy="1097280"/>
           </a:xfrm>
           <a:prstGeom prst="rect">
@@ -1762,7 +1762,7 @@
         </p:nvSpPr>
         <p:spPr>
           <a:xfrm>
-            <a:off x="685800" y="4361688"/>
+            <a:off x="685800" y="4270248"/>
             <a:ext cx="438912" cy="438912"/>
           </a:xfrm>
           <a:prstGeom prst="ellipse">
@@ -1787,7 +1787,7 @@
         </p:nvSpPr>
         <p:spPr>
           <a:xfrm>
-            <a:off x="685800" y="4361688"/>
+            <a:off x="685800" y="4270248"/>
             <a:ext cx="438912" cy="438912"/>
           </a:xfrm>
           <a:prstGeom prst="rect">
@@ -1826,7 +1826,7 @@
         </p:nvSpPr>
         <p:spPr>
           <a:xfrm>
-            <a:off x="1207008" y="4325112"/>
+            <a:off x="1207008" y="4233672"/>
             <a:ext cx="2473452" cy="310896"/>
           </a:xfrm>
           <a:prstGeom prst="rect">
@@ -1865,7 +1865,7 @@
         </p:nvSpPr>
         <p:spPr>
           <a:xfrm>
-            <a:off x="1207008" y="4654296"/>
+            <a:off x="1207008" y="4562856"/>
             <a:ext cx="2473452" cy="548640"/>
           </a:xfrm>
           <a:prstGeom prst="rect">
@@ -1904,7 +1904,7 @@
         </p:nvSpPr>
         <p:spPr>
           <a:xfrm>
-            <a:off x="4000500" y="4160520"/>
+            <a:off x="4000500" y="4069080"/>
             <a:ext cx="3314700" cy="1097280"/>
           </a:xfrm>
           <a:prstGeom prst="rect">
@@ -1936,7 +1936,7 @@
         </p:nvSpPr>
         <p:spPr>
           <a:xfrm>
-            <a:off x="4000500" y="4160520"/>
+            <a:off x="4000500" y="4069080"/>
             <a:ext cx="91440" cy="1097280"/>
           </a:xfrm>
           <a:prstGeom prst="rect">
@@ -1961,7 +1961,7 @@
         </p:nvSpPr>
         <p:spPr>
           <a:xfrm>
-            <a:off x="4229100" y="4361688"/>
+            <a:off x="4229100" y="4270248"/>
             <a:ext cx="438912" cy="438912"/>
           </a:xfrm>
           <a:prstGeom prst="ellipse">
@@ -1986,7 +1986,7 @@
         </p:nvSpPr>
         <p:spPr>
           <a:xfrm>
-            <a:off x="4229100" y="4361688"/>
+            <a:off x="4229100" y="4270248"/>
             <a:ext cx="438912" cy="438912"/>
           </a:xfrm>
           <a:prstGeom prst="rect">
@@ -2025,7 +2025,7 @@
         </p:nvSpPr>
         <p:spPr>
           <a:xfrm>
-            <a:off x="4750308" y="4325112"/>
+            <a:off x="4750308" y="4233672"/>
             <a:ext cx="2473452" cy="310896"/>
           </a:xfrm>
           <a:prstGeom prst="rect">
@@ -2064,7 +2064,7 @@
         </p:nvSpPr>
         <p:spPr>
           <a:xfrm>
-            <a:off x="4750308" y="4654296"/>
+            <a:off x="4750308" y="4562856"/>
             <a:ext cx="2473452" cy="548640"/>
           </a:xfrm>
           <a:prstGeom prst="rect">
@@ -2103,7 +2103,7 @@
         </p:nvSpPr>
         <p:spPr>
           <a:xfrm>
-            <a:off x="457200" y="5422392"/>
+            <a:off x="457200" y="5330952"/>
             <a:ext cx="3314700" cy="1097280"/>
           </a:xfrm>
           <a:prstGeom prst="rect">
@@ -2135,7 +2135,7 @@
         </p:nvSpPr>
         <p:spPr>
           <a:xfrm>
-            <a:off x="457200" y="5422392"/>
+            <a:off x="457200" y="5330952"/>
             <a:ext cx="91440" cy="1097280"/>
           </a:xfrm>
           <a:prstGeom prst="rect">
@@ -2160,7 +2160,7 @@
         </p:nvSpPr>
         <p:spPr>
           <a:xfrm>
-            <a:off x="685800" y="5623560"/>
+            <a:off x="685800" y="5532120"/>
             <a:ext cx="438912" cy="438912"/>
           </a:xfrm>
           <a:prstGeom prst="ellipse">
@@ -2185,7 +2185,7 @@
         </p:nvSpPr>
         <p:spPr>
           <a:xfrm>
-            <a:off x="685800" y="5623560"/>
+            <a:off x="685800" y="5532120"/>
             <a:ext cx="438912" cy="438912"/>
           </a:xfrm>
           <a:prstGeom prst="rect">
@@ -2224,7 +2224,7 @@
         </p:nvSpPr>
         <p:spPr>
           <a:xfrm>
-            <a:off x="1207008" y="5586984"/>
+            <a:off x="1207008" y="5495544"/>
             <a:ext cx="2473452" cy="310896"/>
           </a:xfrm>
           <a:prstGeom prst="rect">
@@ -2263,7 +2263,7 @@
         </p:nvSpPr>
         <p:spPr>
           <a:xfrm>
-            <a:off x="1207008" y="5916168"/>
+            <a:off x="1207008" y="5824728"/>
             <a:ext cx="2473452" cy="548640"/>
           </a:xfrm>
           <a:prstGeom prst="rect">
@@ -2302,7 +2302,7 @@
         </p:nvSpPr>
         <p:spPr>
           <a:xfrm>
-            <a:off x="4000500" y="5422392"/>
+            <a:off x="4000500" y="5330952"/>
             <a:ext cx="3314700" cy="1097280"/>
           </a:xfrm>
           <a:prstGeom prst="rect">
@@ -2334,7 +2334,7 @@
         </p:nvSpPr>
         <p:spPr>
           <a:xfrm>
-            <a:off x="4000500" y="5422392"/>
+            <a:off x="4000500" y="5330952"/>
             <a:ext cx="91440" cy="1097280"/>
           </a:xfrm>
           <a:prstGeom prst="rect">
@@ -2359,7 +2359,7 @@
         </p:nvSpPr>
         <p:spPr>
           <a:xfrm>
-            <a:off x="4229100" y="5623560"/>
+            <a:off x="4229100" y="5532120"/>
             <a:ext cx="438912" cy="438912"/>
           </a:xfrm>
           <a:prstGeom prst="ellipse">
@@ -2384,7 +2384,7 @@
         </p:nvSpPr>
         <p:spPr>
           <a:xfrm>
-            <a:off x="4229100" y="5623560"/>
+            <a:off x="4229100" y="5532120"/>
             <a:ext cx="438912" cy="438912"/>
           </a:xfrm>
           <a:prstGeom prst="rect">
@@ -2423,7 +2423,7 @@
         </p:nvSpPr>
         <p:spPr>
           <a:xfrm>
-            <a:off x="4750308" y="5586984"/>
+            <a:off x="4750308" y="5495544"/>
             <a:ext cx="2473452" cy="310896"/>
           </a:xfrm>
           <a:prstGeom prst="rect">
@@ -2462,7 +2462,7 @@
         </p:nvSpPr>
         <p:spPr>
           <a:xfrm>
-            <a:off x="4750308" y="5916168"/>
+            <a:off x="4750308" y="5824728"/>
             <a:ext cx="2473452" cy="548640"/>
           </a:xfrm>
           <a:prstGeom prst="rect">
@@ -2501,7 +2501,7 @@
         </p:nvSpPr>
         <p:spPr>
           <a:xfrm>
-            <a:off x="457200" y="6583680"/>
+            <a:off x="457200" y="6492240"/>
             <a:ext cx="6858000" cy="274320"/>
           </a:xfrm>
           <a:prstGeom prst="rect">
@@ -2540,7 +2540,7 @@
         </p:nvSpPr>
         <p:spPr>
           <a:xfrm>
-            <a:off x="457200" y="6894576"/>
+            <a:off x="457200" y="6803136"/>
             <a:ext cx="6858000" cy="502920"/>
           </a:xfrm>
           <a:prstGeom prst="rect">
@@ -2593,7 +2593,7 @@
         </p:nvSpPr>
         <p:spPr>
           <a:xfrm>
-            <a:off x="457200" y="7397496"/>
+            <a:off x="457200" y="7306056"/>
             <a:ext cx="6858000" cy="502920"/>
           </a:xfrm>
           <a:prstGeom prst="rect">
@@ -2646,8 +2646,8 @@
         </p:nvSpPr>
         <p:spPr>
           <a:xfrm>
-            <a:off x="457200" y="7946136"/>
-            <a:ext cx="6858000" cy="777240"/>
+            <a:off x="457200" y="7854696"/>
+            <a:ext cx="6858000" cy="731520"/>
           </a:xfrm>
           <a:prstGeom prst="rect">
             <a:avLst/>
@@ -2671,8 +2671,8 @@
         </p:nvSpPr>
         <p:spPr>
           <a:xfrm>
-            <a:off x="457200" y="7946136"/>
-            <a:ext cx="91440" cy="777240"/>
+            <a:off x="457200" y="7854696"/>
+            <a:ext cx="91440" cy="731520"/>
           </a:xfrm>
           <a:prstGeom prst="rect">
             <a:avLst/>
@@ -2696,8 +2696,8 @@
         </p:nvSpPr>
         <p:spPr>
           <a:xfrm>
-            <a:off x="731520" y="8019288"/>
-            <a:ext cx="6492240" cy="274320"/>
+            <a:off x="731520" y="7927848"/>
+            <a:ext cx="6492240" cy="256032"/>
           </a:xfrm>
           <a:prstGeom prst="rect">
             <a:avLst/>
@@ -2735,8 +2735,8 @@
         </p:nvSpPr>
         <p:spPr>
           <a:xfrm>
-            <a:off x="731520" y="8293608"/>
-            <a:ext cx="6492240" cy="384048"/>
+            <a:off x="731520" y="8183880"/>
+            <a:ext cx="6492240" cy="365760"/>
           </a:xfrm>
           <a:prstGeom prst="rect">
             <a:avLst/>
@@ -2774,7 +2774,7 @@
         </p:nvSpPr>
         <p:spPr>
           <a:xfrm>
-            <a:off x="457200" y="8686800"/>
+            <a:off x="457200" y="8732520"/>
             <a:ext cx="6858000" cy="201168"/>
           </a:xfrm>
           <a:prstGeom prst="rect">
@@ -2821,7 +2821,7 @@
         </p:blipFill>
         <p:spPr>
           <a:xfrm>
-            <a:off x="457200" y="8933688"/>
+            <a:off x="457200" y="8979408"/>
             <a:ext cx="237744" cy="237744"/>
           </a:xfrm>
           <a:prstGeom prst="rect">
@@ -2837,7 +2837,7 @@
         </p:nvSpPr>
         <p:spPr>
           <a:xfrm>
-            <a:off x="768096" y="8906256"/>
+            <a:off x="768096" y="8951976"/>
             <a:ext cx="2026310" cy="292608"/>
           </a:xfrm>
           <a:prstGeom prst="rect">
@@ -2884,7 +2884,7 @@
         </p:blipFill>
         <p:spPr>
           <a:xfrm>
-            <a:off x="3048610" y="8924544"/>
+            <a:off x="3048610" y="8970264"/>
             <a:ext cx="256032" cy="256032"/>
           </a:xfrm>
           <a:prstGeom prst="rect">
@@ -2900,7 +2900,7 @@
         </p:nvSpPr>
         <p:spPr>
           <a:xfrm>
-            <a:off x="3377794" y="8906256"/>
+            <a:off x="3377794" y="8951976"/>
             <a:ext cx="1437437" cy="292608"/>
           </a:xfrm>
           <a:prstGeom prst="rect">
@@ -2947,7 +2947,7 @@
         </p:blipFill>
         <p:spPr>
           <a:xfrm>
-            <a:off x="5440680" y="8933688"/>
+            <a:off x="5440680" y="8979408"/>
             <a:ext cx="237744" cy="237744"/>
           </a:xfrm>
           <a:prstGeom prst="rect">
@@ -2963,7 +2963,7 @@
         </p:nvSpPr>
         <p:spPr>
           <a:xfrm>
-            <a:off x="5751576" y="8906256"/>
+            <a:off x="5751576" y="8951976"/>
             <a:ext cx="1353312" cy="292608"/>
           </a:xfrm>
           <a:prstGeom prst="rect">
@@ -3002,7 +3002,7 @@
         </p:nvSpPr>
         <p:spPr>
           <a:xfrm>
-            <a:off x="457200" y="9253728"/>
+            <a:off x="457200" y="9299448"/>
             <a:ext cx="6858000" cy="201168"/>
           </a:xfrm>
           <a:prstGeom prst="rect">
@@ -3041,8 +3041,8 @@
         </p:nvSpPr>
         <p:spPr>
           <a:xfrm>
-            <a:off x="457200" y="9454896"/>
-            <a:ext cx="6858000" cy="402336"/>
+            <a:off x="457200" y="9482328"/>
+            <a:ext cx="6858000" cy="365760"/>
           </a:xfrm>
           <a:prstGeom prst="rect">
             <a:avLst/>

</xml_diff>

<commit_message>
Flyers: enlarge cohort line at top of header
The 'Enrolling now · July–October cohort' line was too small
(11pt) for what is essentially the flyer's marketing hook.
Bumped to 15pt all-caps with tighter charSpacing, claiming the
empty space at the top of the header band so the deadline /
window jumps out at first glance.
</commit_message>
<xml_diff>
--- a/outputs/flyers/USMLE_Step1_Flyer.pptx
+++ b/outputs/flyers/USMLE_Step1_Flyer.pptx
@@ -908,8 +908,8 @@
         </p:nvSpPr>
         <p:spPr>
           <a:xfrm>
-            <a:off x="457200" y="237744"/>
-            <a:ext cx="4457700" cy="219456"/>
+            <a:off x="457200" y="164592"/>
+            <a:ext cx="5394960" cy="310896"/>
           </a:xfrm>
           <a:prstGeom prst="rect">
             <a:avLst/>
@@ -925,7 +925,7 @@
               <a:buNone/>
             </a:pPr>
             <a:r>
-              <a:rPr lang="en-US" sz="1100" b="1" spc="400" kern="0" dirty="0">
+              <a:rPr lang="en-US" sz="1500" b="1" spc="300" kern="0" dirty="0">
                 <a:solidFill>
                   <a:srgbClr val="FFFFFF"/>
                 </a:solidFill>
@@ -933,9 +933,9 @@
                 <a:ea typeface="Calibri" pitchFamily="34" charset="-122"/>
                 <a:cs typeface="Calibri" pitchFamily="34" charset="-120"/>
               </a:rPr>
-              <a:t>Enrolling now · July–October cohort</a:t>
-            </a:r>
-            <a:endParaRPr lang="en-US" sz="1100" dirty="0"/>
+              <a:t>ENROLLING NOW  ·  JULY–OCTOBER COHORT</a:t>
+            </a:r>
+            <a:endParaRPr lang="en-US" sz="1500" dirty="0"/>
           </a:p>
         </p:txBody>
       </p:sp>
@@ -947,7 +947,7 @@
         </p:nvSpPr>
         <p:spPr>
           <a:xfrm>
-            <a:off x="457200" y="457200"/>
+            <a:off x="457200" y="493776"/>
             <a:ext cx="4457700" cy="292608"/>
           </a:xfrm>
           <a:prstGeom prst="rect">
@@ -964,7 +964,7 @@
               <a:buNone/>
             </a:pPr>
             <a:r>
-              <a:rPr lang="en-US" sz="2400" b="1" spc="800" kern="0" dirty="0">
+              <a:rPr lang="en-US" sz="2200" b="1" spc="800" kern="0" dirty="0">
                 <a:solidFill>
                   <a:srgbClr val="FFFFFF"/>
                 </a:solidFill>
@@ -974,7 +974,7 @@
               </a:rPr>
               <a:t>USMLE</a:t>
             </a:r>
-            <a:endParaRPr lang="en-US" sz="2400" dirty="0"/>
+            <a:endParaRPr lang="en-US" sz="2200" dirty="0"/>
           </a:p>
         </p:txBody>
       </p:sp>
@@ -986,8 +986,8 @@
         </p:nvSpPr>
         <p:spPr>
           <a:xfrm>
-            <a:off x="457200" y="768096"/>
-            <a:ext cx="4457700" cy="777240"/>
+            <a:off x="457200" y="786384"/>
+            <a:ext cx="4457700" cy="749808"/>
           </a:xfrm>
           <a:prstGeom prst="rect">
             <a:avLst/>

</xml_diff>

<commit_message>
Flyers: enlarge 'daily classes' line in top-right stamp
</commit_message>
<xml_diff>
--- a/outputs/flyers/USMLE_Step1_Flyer.pptx
+++ b/outputs/flyers/USMLE_Step1_Flyer.pptx
@@ -1167,8 +1167,8 @@
         </p:nvSpPr>
         <p:spPr>
           <a:xfrm>
-            <a:off x="5486400" y="1097280"/>
-            <a:ext cx="1828800" cy="274320"/>
+            <a:off x="5486400" y="1078992"/>
+            <a:ext cx="1828800" cy="310896"/>
           </a:xfrm>
           <a:prstGeom prst="rect">
             <a:avLst/>
@@ -1184,7 +1184,7 @@
               <a:buNone/>
             </a:pPr>
             <a:r>
-              <a:rPr lang="en-US" sz="1050" i="1" dirty="0">
+              <a:rPr lang="en-US" sz="1300" i="1" dirty="0">
                 <a:solidFill>
                   <a:srgbClr val="FFFFFF"/>
                 </a:solidFill>
@@ -1194,7 +1194,7 @@
               </a:rPr>
               <a:t>· daily classes ·</a:t>
             </a:r>
-            <a:endParaRPr lang="en-US" sz="1050" dirty="0"/>
+            <a:endParaRPr lang="en-US" sz="1300" dirty="0"/>
           </a:p>
         </p:txBody>
       </p:sp>

</xml_diff>

<commit_message>
Flyers: align topic lists with official USMLE content outlines
Cross-checked against Allan's score reports for both steps.

Step 1 — Disciplines + Systems lists now match the official USMLE
outline. Adds Histology & Cell Biology (was missing). Moves
Biostatistics out of disciplines into systems where USMLE classifies
it (under Biostatistics & Epidemiology). Adds General Principles
(highest-weighted system). Renames Anatomy to Anatomy & Embryology.

Step 2 CK — restructured single 'topics' list into a Disciplines /
Systems split mirroring the official outline. Disciplines reduced
to the 5 + 1 actual specialties (Medicine, Surgery, Pediatrics,
OB/GYN, Psychiatry, Family Medicine); the misclassified items
(Ethics, Biostatistics, Patient Safety, Preventive Medicine)
moved into the Systems & cross-cutting line.

Co-Authored-By: Claude Opus 4.7 (1M context) <noreply@anthropic.com>
</commit_message>
<xml_diff>
--- a/outputs/flyers/USMLE_Step1_Flyer.pptx
+++ b/outputs/flyers/USMLE_Step1_Flyer.pptx
@@ -2579,7 +2579,7 @@
                 <a:ea typeface="Calibri" pitchFamily="34" charset="-122"/>
                 <a:cs typeface="Calibri" pitchFamily="34" charset="-120"/>
               </a:rPr>
-              <a:t>Anatomy  ·  Physiology  ·  Biochemistry  ·  Pathology  ·  Pharmacology  ·  Microbiology  ·  Immunology  ·  Behavioral science  ·  Biostatistics  ·  Genetics</a:t>
+              <a:t>Pathology  ·  Physiology  ·  Biochemistry  ·  Pharmacology  ·  Anatomy &amp; Embryology  ·  Microbiology  ·  Histology  ·  Behavioral Sciences  ·  Immunology  ·  Genetics</a:t>
             </a:r>
             <a:endParaRPr lang="en-US" sz="1250" dirty="0"/>
           </a:p>
@@ -2618,7 +2618,7 @@
                 <a:ea typeface="Calibri" pitchFamily="34" charset="-122"/>
                 <a:cs typeface="Calibri" pitchFamily="34" charset="-120"/>
               </a:rPr>
-              <a:t>Organ systems:  </a:t>
+              <a:t>Systems:  </a:t>
             </a:r>
             <a:pPr indent="0" marL="0">
               <a:buNone/>
@@ -2632,7 +2632,7 @@
                 <a:ea typeface="Calibri" pitchFamily="34" charset="-122"/>
                 <a:cs typeface="Calibri" pitchFamily="34" charset="-120"/>
               </a:rPr>
-              <a:t>Cardiovascular  ·  Respiratory  ·  Gastrointestinal  ·  Renal  ·  Reproductive  ·  Endocrine  ·  Musculoskeletal  ·  Nervous system  ·  Psychiatry  ·  Heme/Onc  ·  Skin</a:t>
+              <a:t>General Principles  ·  Cardiovascular  ·  Respiratory  ·  Gastrointestinal  ·  Renal/Urinary  ·  Reproductive &amp; Endocrine  ·  MSK &amp; Skin  ·  Nervous &amp; Behavioral  ·  Heme &amp; Immune  ·  Biostatistics &amp; Epi</a:t>
             </a:r>
             <a:endParaRPr lang="en-US" sz="1250" dirty="0"/>
           </a:p>

</xml_diff>

<commit_message>
Flyers: lead with Google Form sign-up + QR code
Replaces the 'TO SIGN UP, CONTACT ALLAN' section with a Google
Form CTA: forms.gle/Pj4tB985kpZGBKN59 (collects first/last name,
email, and Step 1/Step 2/Combined track interest). Responses
flow into a linked Sheet on bakesiganajjuma@gmail.com. Direct
contact methods (email, WhatsApp, US call) are kept as a smaller
'Questions? Reach out:' fallback row underneath.

Brand-coloured QR code (forms_qr.png) added on the right, sized
1.2in for reliable scanning from a printed flyer or phone screen.
</commit_message>
<xml_diff>
--- a/outputs/flyers/USMLE_Step1_Flyer.pptx
+++ b/outputs/flyers/USMLE_Step1_Flyer.pptx
@@ -2766,48 +2766,9 @@
           </a:p>
         </p:txBody>
       </p:sp>
-      <p:sp>
-        <p:nvSpPr>
-          <p:cNvPr id="57" name="Text 54"/>
-          <p:cNvSpPr/>
-          <p:nvPr/>
-        </p:nvSpPr>
-        <p:spPr>
-          <a:xfrm>
-            <a:off x="457200" y="8732520"/>
-            <a:ext cx="6858000" cy="201168"/>
-          </a:xfrm>
-          <a:prstGeom prst="rect">
-            <a:avLst/>
-          </a:prstGeom>
-          <a:noFill/>
-          <a:ln/>
-        </p:spPr>
-        <p:txBody>
-          <a:bodyPr wrap="square" lIns="0" tIns="0" rIns="0" bIns="0" rtlCol="0" anchor="ctr"/>
-          <a:lstStyle/>
-          <a:p>
-            <a:pPr indent="0" marL="0">
-              <a:buNone/>
-            </a:pPr>
-            <a:r>
-              <a:rPr lang="en-US" sz="1100" b="1" spc="400" kern="0" dirty="0">
-                <a:solidFill>
-                  <a:srgbClr val="075985"/>
-                </a:solidFill>
-                <a:latin typeface="Calibri" pitchFamily="34" charset="0"/>
-                <a:ea typeface="Calibri" pitchFamily="34" charset="-122"/>
-                <a:cs typeface="Calibri" pitchFamily="34" charset="-120"/>
-              </a:rPr>
-              <a:t>TO SIGN UP, CONTACT ALLAN ON:</a:t>
-            </a:r>
-            <a:endParaRPr lang="en-US" sz="1100" dirty="0"/>
-          </a:p>
-        </p:txBody>
-      </p:sp>
       <p:pic>
         <p:nvPicPr>
-          <p:cNvPr id="58" name="Image 1" descr="email-blue.png">    </p:cNvPr>
+          <p:cNvPr id="57" name="Image 1" descr="forms_qr.png">    </p:cNvPr>
           <p:cNvPicPr>
             <a:picLocks noChangeAspect="1"/>
           </p:cNvPicPr>
@@ -2821,8 +2782,8 @@
         </p:blipFill>
         <p:spPr>
           <a:xfrm>
-            <a:off x="457200" y="8979408"/>
-            <a:ext cx="237744" cy="237744"/>
+            <a:off x="6217920" y="8732520"/>
+            <a:ext cx="1097280" cy="1097280"/>
           </a:xfrm>
           <a:prstGeom prst="rect">
             <a:avLst/>
@@ -2831,46 +2792,163 @@
       </p:pic>
       <p:sp>
         <p:nvSpPr>
-          <p:cNvPr id="59" name="Text 55"/>
-          <p:cNvSpPr/>
-          <p:nvPr/>
-        </p:nvSpPr>
-        <p:spPr>
-          <a:xfrm>
-            <a:off x="768096" y="8951976"/>
-            <a:ext cx="2026310" cy="292608"/>
-          </a:xfrm>
-          <a:prstGeom prst="rect">
-            <a:avLst/>
-          </a:prstGeom>
-          <a:noFill/>
-          <a:ln/>
-        </p:spPr>
-        <p:txBody>
-          <a:bodyPr wrap="square" lIns="0" tIns="0" rIns="0" bIns="0" rtlCol="0" anchor="ctr"/>
-          <a:lstStyle/>
-          <a:p>
-            <a:pPr algn="l" indent="0" marL="0">
-              <a:buNone/>
-            </a:pPr>
-            <a:r>
-              <a:rPr lang="en-US" sz="1200" b="1" dirty="0">
-                <a:solidFill>
-                  <a:srgbClr val="0C2A3D"/>
+          <p:cNvPr id="58" name="Text 54"/>
+          <p:cNvSpPr/>
+          <p:nvPr/>
+        </p:nvSpPr>
+        <p:spPr>
+          <a:xfrm>
+            <a:off x="6217920" y="9793224"/>
+            <a:ext cx="1097280" cy="146304"/>
+          </a:xfrm>
+          <a:prstGeom prst="rect">
+            <a:avLst/>
+          </a:prstGeom>
+          <a:noFill/>
+          <a:ln/>
+        </p:spPr>
+        <p:txBody>
+          <a:bodyPr wrap="square" lIns="0" tIns="0" rIns="0" bIns="0" rtlCol="0" anchor="ctr"/>
+          <a:lstStyle/>
+          <a:p>
+            <a:pPr algn="ctr" indent="0" marL="0">
+              <a:buNone/>
+            </a:pPr>
+            <a:r>
+              <a:rPr lang="en-US" sz="800" i="1" dirty="0">
+                <a:solidFill>
+                  <a:srgbClr val="075985"/>
                 </a:solidFill>
                 <a:latin typeface="Calibri" pitchFamily="34" charset="0"/>
                 <a:ea typeface="Calibri" pitchFamily="34" charset="-122"/>
                 <a:cs typeface="Calibri" pitchFamily="34" charset="-120"/>
               </a:rPr>
-              <a:t>allanbakesiga@gmail.com</a:t>
-            </a:r>
-            <a:endParaRPr lang="en-US" sz="1200" dirty="0"/>
+              <a:t>scan to sign up</a:t>
+            </a:r>
+            <a:endParaRPr lang="en-US" sz="800" dirty="0"/>
+          </a:p>
+        </p:txBody>
+      </p:sp>
+      <p:sp>
+        <p:nvSpPr>
+          <p:cNvPr id="59" name="Text 55"/>
+          <p:cNvSpPr/>
+          <p:nvPr/>
+        </p:nvSpPr>
+        <p:spPr>
+          <a:xfrm>
+            <a:off x="457200" y="8732520"/>
+            <a:ext cx="5577840" cy="201168"/>
+          </a:xfrm>
+          <a:prstGeom prst="rect">
+            <a:avLst/>
+          </a:prstGeom>
+          <a:noFill/>
+          <a:ln/>
+        </p:spPr>
+        <p:txBody>
+          <a:bodyPr wrap="square" lIns="0" tIns="0" rIns="0" bIns="0" rtlCol="0" anchor="ctr"/>
+          <a:lstStyle/>
+          <a:p>
+            <a:pPr indent="0" marL="0">
+              <a:buNone/>
+            </a:pPr>
+            <a:r>
+              <a:rPr lang="en-US" sz="1100" b="1" spc="400" kern="0" dirty="0">
+                <a:solidFill>
+                  <a:srgbClr val="075985"/>
+                </a:solidFill>
+                <a:latin typeface="Calibri" pitchFamily="34" charset="0"/>
+                <a:ea typeface="Calibri" pitchFamily="34" charset="-122"/>
+                <a:cs typeface="Calibri" pitchFamily="34" charset="-120"/>
+              </a:rPr>
+              <a:t>SIGN UP HERE</a:t>
+            </a:r>
+            <a:endParaRPr lang="en-US" sz="1100" dirty="0"/>
+          </a:p>
+        </p:txBody>
+      </p:sp>
+      <p:sp>
+        <p:nvSpPr>
+          <p:cNvPr id="60" name="Text 56"/>
+          <p:cNvSpPr/>
+          <p:nvPr/>
+        </p:nvSpPr>
+        <p:spPr>
+          <a:xfrm>
+            <a:off x="457200" y="8915400"/>
+            <a:ext cx="5577840" cy="420624"/>
+          </a:xfrm>
+          <a:prstGeom prst="rect">
+            <a:avLst/>
+          </a:prstGeom>
+          <a:noFill/>
+          <a:ln/>
+        </p:spPr>
+        <p:txBody>
+          <a:bodyPr wrap="square" lIns="0" tIns="0" rIns="0" bIns="0" rtlCol="0" anchor="ctr"/>
+          <a:lstStyle/>
+          <a:p>
+            <a:pPr indent="0" marL="0">
+              <a:buNone/>
+            </a:pPr>
+            <a:r>
+              <a:rPr lang="en-US" sz="2200" b="1" dirty="0">
+                <a:solidFill>
+                  <a:srgbClr val="0284C7"/>
+                </a:solidFill>
+                <a:latin typeface="Arial Black" pitchFamily="34" charset="0"/>
+                <a:ea typeface="Arial Black" pitchFamily="34" charset="-122"/>
+                <a:cs typeface="Arial Black" pitchFamily="34" charset="-120"/>
+              </a:rPr>
+              <a:t>forms.gle/Pj4tB985kpZGBKN59</a:t>
+            </a:r>
+            <a:endParaRPr lang="en-US" sz="2200" dirty="0"/>
+          </a:p>
+        </p:txBody>
+      </p:sp>
+      <p:sp>
+        <p:nvSpPr>
+          <p:cNvPr id="61" name="Text 57"/>
+          <p:cNvSpPr/>
+          <p:nvPr/>
+        </p:nvSpPr>
+        <p:spPr>
+          <a:xfrm>
+            <a:off x="457200" y="9390888"/>
+            <a:ext cx="5577840" cy="201168"/>
+          </a:xfrm>
+          <a:prstGeom prst="rect">
+            <a:avLst/>
+          </a:prstGeom>
+          <a:noFill/>
+          <a:ln/>
+        </p:spPr>
+        <p:txBody>
+          <a:bodyPr wrap="square" lIns="0" tIns="0" rIns="0" bIns="0" rtlCol="0" anchor="ctr"/>
+          <a:lstStyle/>
+          <a:p>
+            <a:pPr indent="0" marL="0">
+              <a:buNone/>
+            </a:pPr>
+            <a:r>
+              <a:rPr lang="en-US" sz="1050" i="1" dirty="0">
+                <a:solidFill>
+                  <a:srgbClr val="345671"/>
+                </a:solidFill>
+                <a:latin typeface="Calibri" pitchFamily="34" charset="0"/>
+                <a:ea typeface="Calibri" pitchFamily="34" charset="-122"/>
+                <a:cs typeface="Calibri" pitchFamily="34" charset="-120"/>
+              </a:rPr>
+              <a:t>Questions? Reach out to Allan:</a:t>
+            </a:r>
+            <a:endParaRPr lang="en-US" sz="1050" dirty="0"/>
           </a:p>
         </p:txBody>
       </p:sp>
       <p:pic>
         <p:nvPicPr>
-          <p:cNvPr id="60" name="Image 2" descr="whatsapp.png">    </p:cNvPr>
+          <p:cNvPr id="62" name="Image 2" descr="email-blue.png">    </p:cNvPr>
           <p:cNvPicPr>
             <a:picLocks noChangeAspect="1"/>
           </p:cNvPicPr>
@@ -2884,8 +2962,8 @@
         </p:blipFill>
         <p:spPr>
           <a:xfrm>
-            <a:off x="3048610" y="8970264"/>
-            <a:ext cx="256032" cy="256032"/>
+            <a:off x="457200" y="9610344"/>
+            <a:ext cx="182880" cy="182880"/>
           </a:xfrm>
           <a:prstGeom prst="rect">
             <a:avLst/>
@@ -2894,14 +2972,14 @@
       </p:pic>
       <p:sp>
         <p:nvSpPr>
-          <p:cNvPr id="61" name="Text 56"/>
-          <p:cNvSpPr/>
-          <p:nvPr/>
-        </p:nvSpPr>
-        <p:spPr>
-          <a:xfrm>
-            <a:off x="3377794" y="8951976"/>
-            <a:ext cx="1437437" cy="292608"/>
+          <p:cNvPr id="63" name="Text 58"/>
+          <p:cNvSpPr/>
+          <p:nvPr/>
+        </p:nvSpPr>
+        <p:spPr>
+          <a:xfrm>
+            <a:off x="694944" y="9592056"/>
+            <a:ext cx="1668780" cy="219456"/>
           </a:xfrm>
           <a:prstGeom prst="rect">
             <a:avLst/>
@@ -2917,7 +2995,7 @@
               <a:buNone/>
             </a:pPr>
             <a:r>
-              <a:rPr lang="en-US" sz="1200" b="1" dirty="0">
+              <a:rPr lang="en-US" sz="1000" b="1" dirty="0">
                 <a:solidFill>
                   <a:srgbClr val="0C2A3D"/>
                 </a:solidFill>
@@ -2925,15 +3003,15 @@
                 <a:ea typeface="Calibri" pitchFamily="34" charset="-122"/>
                 <a:cs typeface="Calibri" pitchFamily="34" charset="-120"/>
               </a:rPr>
-              <a:t>+256 705 571 443</a:t>
-            </a:r>
-            <a:endParaRPr lang="en-US" sz="1200" dirty="0"/>
+              <a:t>allanbakesiga@gmail.com</a:t>
+            </a:r>
+            <a:endParaRPr lang="en-US" sz="1000" dirty="0"/>
           </a:p>
         </p:txBody>
       </p:sp>
       <p:pic>
         <p:nvPicPr>
-          <p:cNvPr id="62" name="Image 3" descr="phone-blue.png">    </p:cNvPr>
+          <p:cNvPr id="64" name="Image 3" descr="whatsapp.png">    </p:cNvPr>
           <p:cNvPicPr>
             <a:picLocks noChangeAspect="1"/>
           </p:cNvPicPr>
@@ -2947,8 +3025,8 @@
         </p:blipFill>
         <p:spPr>
           <a:xfrm>
-            <a:off x="5440680" y="8979408"/>
-            <a:ext cx="237744" cy="237744"/>
+            <a:off x="2569464" y="9601200"/>
+            <a:ext cx="201168" cy="201168"/>
           </a:xfrm>
           <a:prstGeom prst="rect">
             <a:avLst/>
@@ -2957,14 +3035,14 @@
       </p:pic>
       <p:sp>
         <p:nvSpPr>
-          <p:cNvPr id="63" name="Text 57"/>
-          <p:cNvSpPr/>
-          <p:nvPr/>
-        </p:nvSpPr>
-        <p:spPr>
-          <a:xfrm>
-            <a:off x="5751576" y="8951976"/>
-            <a:ext cx="1353312" cy="292608"/>
+          <p:cNvPr id="65" name="Text 59"/>
+          <p:cNvSpPr/>
+          <p:nvPr/>
+        </p:nvSpPr>
+        <p:spPr>
+          <a:xfrm>
+            <a:off x="2825496" y="9592056"/>
+            <a:ext cx="1188720" cy="219456"/>
           </a:xfrm>
           <a:prstGeom prst="rect">
             <a:avLst/>
@@ -2980,7 +3058,7 @@
               <a:buNone/>
             </a:pPr>
             <a:r>
-              <a:rPr lang="en-US" sz="1200" b="1" dirty="0">
+              <a:rPr lang="en-US" sz="1000" b="1" dirty="0">
                 <a:solidFill>
                   <a:srgbClr val="0C2A3D"/>
                 </a:solidFill>
@@ -2988,93 +3066,78 @@
                 <a:ea typeface="Calibri" pitchFamily="34" charset="-122"/>
                 <a:cs typeface="Calibri" pitchFamily="34" charset="-120"/>
               </a:rPr>
-              <a:t>+1 984 710 2902</a:t>
-            </a:r>
-            <a:endParaRPr lang="en-US" sz="1200" dirty="0"/>
-          </a:p>
-        </p:txBody>
-      </p:sp>
-      <p:sp>
-        <p:nvSpPr>
-          <p:cNvPr id="64" name="Text 58"/>
-          <p:cNvSpPr/>
-          <p:nvPr/>
-        </p:nvSpPr>
-        <p:spPr>
-          <a:xfrm>
-            <a:off x="457200" y="9299448"/>
-            <a:ext cx="6858000" cy="201168"/>
-          </a:xfrm>
-          <a:prstGeom prst="rect">
-            <a:avLst/>
-          </a:prstGeom>
-          <a:noFill/>
-          <a:ln/>
-        </p:spPr>
-        <p:txBody>
-          <a:bodyPr wrap="square" lIns="0" tIns="0" rIns="0" bIns="0" rtlCol="0" anchor="ctr"/>
-          <a:lstStyle/>
-          <a:p>
-            <a:pPr indent="0" marL="0">
-              <a:buNone/>
-            </a:pPr>
-            <a:r>
-              <a:rPr lang="en-US" sz="1050" i="1" dirty="0">
-                <a:solidFill>
-                  <a:srgbClr val="345671"/>
+              <a:t>+256 705 571 443</a:t>
+            </a:r>
+            <a:endParaRPr lang="en-US" sz="1000" dirty="0"/>
+          </a:p>
+        </p:txBody>
+      </p:sp>
+      <p:pic>
+        <p:nvPicPr>
+          <p:cNvPr id="66" name="Image 4" descr="phone-blue.png">    </p:cNvPr>
+          <p:cNvPicPr>
+            <a:picLocks noChangeAspect="1"/>
+          </p:cNvPicPr>
+          <p:nvPr/>
+        </p:nvPicPr>
+        <p:blipFill>
+          <a:blip r:embed="rId5"/>
+          <a:stretch>
+            <a:fillRect/>
+          </a:stretch>
+        </p:blipFill>
+        <p:spPr>
+          <a:xfrm>
+            <a:off x="4502658" y="9610344"/>
+            <a:ext cx="182880" cy="182880"/>
+          </a:xfrm>
+          <a:prstGeom prst="rect">
+            <a:avLst/>
+          </a:prstGeom>
+        </p:spPr>
+      </p:pic>
+      <p:sp>
+        <p:nvSpPr>
+          <p:cNvPr id="67" name="Text 60"/>
+          <p:cNvSpPr/>
+          <p:nvPr/>
+        </p:nvSpPr>
+        <p:spPr>
+          <a:xfrm>
+            <a:off x="4740402" y="9592056"/>
+            <a:ext cx="1120140" cy="219456"/>
+          </a:xfrm>
+          <a:prstGeom prst="rect">
+            <a:avLst/>
+          </a:prstGeom>
+          <a:noFill/>
+          <a:ln/>
+        </p:spPr>
+        <p:txBody>
+          <a:bodyPr wrap="square" lIns="0" tIns="0" rIns="0" bIns="0" rtlCol="0" anchor="ctr"/>
+          <a:lstStyle/>
+          <a:p>
+            <a:pPr algn="l" indent="0" marL="0">
+              <a:buNone/>
+            </a:pPr>
+            <a:r>
+              <a:rPr lang="en-US" sz="1000" b="1" dirty="0">
+                <a:solidFill>
+                  <a:srgbClr val="0C2A3D"/>
                 </a:solidFill>
                 <a:latin typeface="Calibri" pitchFamily="34" charset="0"/>
                 <a:ea typeface="Calibri" pitchFamily="34" charset="-122"/>
                 <a:cs typeface="Calibri" pitchFamily="34" charset="-120"/>
               </a:rPr>
-              <a:t>Once enrolled, you'll be granted access to all course materials at:</a:t>
-            </a:r>
-            <a:endParaRPr lang="en-US" sz="1050" dirty="0"/>
-          </a:p>
-        </p:txBody>
-      </p:sp>
-      <p:sp>
-        <p:nvSpPr>
-          <p:cNvPr id="65" name="Text 59"/>
-          <p:cNvSpPr/>
-          <p:nvPr/>
-        </p:nvSpPr>
-        <p:spPr>
-          <a:xfrm>
-            <a:off x="457200" y="9482328"/>
-            <a:ext cx="6858000" cy="365760"/>
-          </a:xfrm>
-          <a:prstGeom prst="rect">
-            <a:avLst/>
-          </a:prstGeom>
-          <a:noFill/>
-          <a:ln/>
-        </p:spPr>
-        <p:txBody>
-          <a:bodyPr wrap="square" lIns="0" tIns="0" rIns="0" bIns="0" rtlCol="0" anchor="ctr"/>
-          <a:lstStyle/>
-          <a:p>
-            <a:pPr indent="0" marL="0">
-              <a:buNone/>
-            </a:pPr>
-            <a:r>
-              <a:rPr lang="en-US" sz="2200" b="1" dirty="0">
-                <a:solidFill>
-                  <a:srgbClr val="0284C7"/>
-                </a:solidFill>
-                <a:latin typeface="Arial Black" pitchFamily="34" charset="0"/>
-                <a:ea typeface="Arial Black" pitchFamily="34" charset="-122"/>
-                <a:cs typeface="Arial Black" pitchFamily="34" charset="-120"/>
-              </a:rPr>
-              <a:t>bakesiga.github.io/usmle-dashboard</a:t>
-            </a:r>
-            <a:endParaRPr lang="en-US" sz="2200" dirty="0"/>
-          </a:p>
-        </p:txBody>
-      </p:sp>
-      <p:sp>
-        <p:nvSpPr>
-          <p:cNvPr id="66" name="Shape 60"/>
+              <a:t>+1 984 710 2902</a:t>
+            </a:r>
+            <a:endParaRPr lang="en-US" sz="1000" dirty="0"/>
+          </a:p>
+        </p:txBody>
+      </p:sp>
+      <p:sp>
+        <p:nvSpPr>
+          <p:cNvPr id="68" name="Shape 61"/>
           <p:cNvSpPr/>
           <p:nvPr/>
         </p:nvSpPr>
@@ -3099,7 +3162,7 @@
       </p:sp>
       <p:sp>
         <p:nvSpPr>
-          <p:cNvPr id="67" name="Shape 61"/>
+          <p:cNvPr id="69" name="Shape 62"/>
           <p:cNvSpPr/>
           <p:nvPr/>
         </p:nvSpPr>

</xml_diff>

<commit_message>
Flyers: 'Scan to sign up' caption now legible
Earlier the caption was 8pt and overlapped the QR's bottom edge,
making both the caption and the QR's lower rows hard to read.
Shrunk the QR slightly (1.20 -> 1.00) to leave room, bumped the
caption to 10pt bold italic in the brand-deep colour, and gave
it 0.04in clearance below the QR.
</commit_message>
<xml_diff>
--- a/outputs/flyers/USMLE_Step1_Flyer.pptx
+++ b/outputs/flyers/USMLE_Step1_Flyer.pptx
@@ -2782,8 +2782,8 @@
         </p:blipFill>
         <p:spPr>
           <a:xfrm>
-            <a:off x="6217920" y="8732520"/>
-            <a:ext cx="1097280" cy="1097280"/>
+            <a:off x="6400800" y="8732520"/>
+            <a:ext cx="914400" cy="914400"/>
           </a:xfrm>
           <a:prstGeom prst="rect">
             <a:avLst/>
@@ -2798,8 +2798,8 @@
         </p:nvSpPr>
         <p:spPr>
           <a:xfrm>
-            <a:off x="6217920" y="9793224"/>
-            <a:ext cx="1097280" cy="146304"/>
+            <a:off x="6400800" y="9683496"/>
+            <a:ext cx="914400" cy="182880"/>
           </a:xfrm>
           <a:prstGeom prst="rect">
             <a:avLst/>
@@ -2815,7 +2815,7 @@
               <a:buNone/>
             </a:pPr>
             <a:r>
-              <a:rPr lang="en-US" sz="800" i="1" dirty="0">
+              <a:rPr lang="en-US" sz="1000" b="1" i="1" dirty="0">
                 <a:solidFill>
                   <a:srgbClr val="075985"/>
                 </a:solidFill>
@@ -2823,9 +2823,9 @@
                 <a:ea typeface="Calibri" pitchFamily="34" charset="-122"/>
                 <a:cs typeface="Calibri" pitchFamily="34" charset="-120"/>
               </a:rPr>
-              <a:t>scan to sign up</a:t>
-            </a:r>
-            <a:endParaRPr lang="en-US" sz="800" dirty="0"/>
+              <a:t>Scan to sign up</a:t>
+            </a:r>
+            <a:endParaRPr lang="en-US" sz="1000" dirty="0"/>
           </a:p>
         </p:txBody>
       </p:sp>
@@ -2838,7 +2838,7 @@
         <p:spPr>
           <a:xfrm>
             <a:off x="457200" y="8732520"/>
-            <a:ext cx="5577840" cy="201168"/>
+            <a:ext cx="5760720" cy="201168"/>
           </a:xfrm>
           <a:prstGeom prst="rect">
             <a:avLst/>
@@ -2877,7 +2877,7 @@
         <p:spPr>
           <a:xfrm>
             <a:off x="457200" y="8915400"/>
-            <a:ext cx="5577840" cy="420624"/>
+            <a:ext cx="5760720" cy="420624"/>
           </a:xfrm>
           <a:prstGeom prst="rect">
             <a:avLst/>
@@ -2916,7 +2916,7 @@
         <p:spPr>
           <a:xfrm>
             <a:off x="457200" y="9390888"/>
-            <a:ext cx="5577840" cy="201168"/>
+            <a:ext cx="5760720" cy="201168"/>
           </a:xfrm>
           <a:prstGeom prst="rect">
             <a:avLst/>
@@ -2962,7 +2962,7 @@
         </p:blipFill>
         <p:spPr>
           <a:xfrm>
-            <a:off x="457200" y="9610344"/>
+            <a:off x="479298" y="9610344"/>
             <a:ext cx="182880" cy="182880"/>
           </a:xfrm>
           <a:prstGeom prst="rect">
@@ -2978,7 +2978,7 @@
         </p:nvSpPr>
         <p:spPr>
           <a:xfrm>
-            <a:off x="694944" y="9592056"/>
+            <a:off x="717042" y="9592056"/>
             <a:ext cx="1668780" cy="219456"/>
           </a:xfrm>
           <a:prstGeom prst="rect">
@@ -3025,7 +3025,7 @@
         </p:blipFill>
         <p:spPr>
           <a:xfrm>
-            <a:off x="2569464" y="9601200"/>
+            <a:off x="2660904" y="9601200"/>
             <a:ext cx="201168" cy="201168"/>
           </a:xfrm>
           <a:prstGeom prst="rect">
@@ -3041,7 +3041,7 @@
         </p:nvSpPr>
         <p:spPr>
           <a:xfrm>
-            <a:off x="2825496" y="9592056"/>
+            <a:off x="2916936" y="9592056"/>
             <a:ext cx="1188720" cy="219456"/>
           </a:xfrm>
           <a:prstGeom prst="rect">
@@ -3088,7 +3088,7 @@
         </p:blipFill>
         <p:spPr>
           <a:xfrm>
-            <a:off x="4502658" y="9610344"/>
+            <a:off x="4655058" y="9610344"/>
             <a:ext cx="182880" cy="182880"/>
           </a:xfrm>
           <a:prstGeom prst="rect">
@@ -3104,7 +3104,7 @@
         </p:nvSpPr>
         <p:spPr>
           <a:xfrm>
-            <a:off x="4740402" y="9592056"/>
+            <a:off x="4892802" y="9592056"/>
             <a:ext cx="1120140" cy="219456"/>
           </a:xfrm>
           <a:prstGeom prst="rect">

</xml_diff>